<commit_message>
Slide 2: replace with presentation outline
</commit_message>
<xml_diff>
--- a/docs/lightflavorspectra_OO200_Status_Update.pptx
+++ b/docs/lightflavorspectra_OO200_Status_Update.pptx
@@ -1763,7 +1763,7 @@
                 <a:ea typeface="Arial" pitchFamily="34" charset="-122"/>
                 <a:cs typeface="Arial" pitchFamily="34" charset="-120"/>
               </a:rPr>
-              <a:t>OVERVIEW</a:t>
+              <a:t>AGENDA</a:t>
             </a:r>
             <a:endParaRPr lang="en-US" sz="1200" dirty="0"/>
           </a:p>
@@ -1816,8 +1816,52 @@
         </p:nvSpPr>
         <p:spPr>
           <a:xfrm>
-            <a:off x="502920" y="1417320"/>
-            <a:ext cx="402336" cy="402336"/>
+            <a:off x="7635240" y="274320"/>
+            <a:ext cx="777240" cy="777240"/>
+          </a:xfrm>
+          <a:prstGeom prst="ellipse">
+            <a:avLst/>
+          </a:prstGeom>
+          <a:solidFill>
+            <a:srgbClr val="CADCFC">
+              <a:alpha val="45000"/>
+            </a:srgbClr>
+          </a:solidFill>
+          <a:ln/>
+        </p:spPr>
+      </p:sp>
+      <p:sp>
+        <p:nvSpPr>
+          <p:cNvPr id="5" name="Shape 3"/>
+          <p:cNvSpPr/>
+          <p:nvPr/>
+        </p:nvSpPr>
+        <p:spPr>
+          <a:xfrm>
+            <a:off x="7961681" y="367589"/>
+            <a:ext cx="777240" cy="777240"/>
+          </a:xfrm>
+          <a:prstGeom prst="ellipse">
+            <a:avLst/>
+          </a:prstGeom>
+          <a:solidFill>
+            <a:srgbClr val="E8A33D">
+              <a:alpha val="45000"/>
+            </a:srgbClr>
+          </a:solidFill>
+          <a:ln/>
+        </p:spPr>
+      </p:sp>
+      <p:sp>
+        <p:nvSpPr>
+          <p:cNvPr id="6" name="Shape 4"/>
+          <p:cNvSpPr/>
+          <p:nvPr/>
+        </p:nvSpPr>
+        <p:spPr>
+          <a:xfrm>
+            <a:off x="548640" y="1417320"/>
+            <a:ext cx="420624" cy="420624"/>
           </a:xfrm>
           <a:prstGeom prst="ellipse">
             <a:avLst/>
@@ -1830,14 +1874,14 @@
       </p:sp>
       <p:sp>
         <p:nvSpPr>
-          <p:cNvPr id="5" name="Text 3"/>
-          <p:cNvSpPr/>
-          <p:nvPr/>
-        </p:nvSpPr>
-        <p:spPr>
-          <a:xfrm>
-            <a:off x="502920" y="1403604"/>
-            <a:ext cx="402336" cy="402336"/>
+          <p:cNvPr id="7" name="Text 5"/>
+          <p:cNvSpPr/>
+          <p:nvPr/>
+        </p:nvSpPr>
+        <p:spPr>
+          <a:xfrm>
+            <a:off x="548640" y="1403604"/>
+            <a:ext cx="420624" cy="420624"/>
           </a:xfrm>
           <a:prstGeom prst="rect">
             <a:avLst/>
@@ -1853,7 +1897,7 @@
               <a:buNone/>
             </a:pPr>
             <a:r>
-              <a:rPr lang="en-US" sz="1400" b="1" dirty="0">
+              <a:rPr lang="en-US" sz="1600" b="1" dirty="0">
                 <a:solidFill>
                   <a:srgbClr val="FFFFFF"/>
                 </a:solidFill>
@@ -1863,20 +1907,42 @@
               </a:rPr>
               <a:t>1</a:t>
             </a:r>
-            <a:endParaRPr lang="en-US" sz="1400" dirty="0"/>
-          </a:p>
-        </p:txBody>
-      </p:sp>
-      <p:sp>
-        <p:nvSpPr>
-          <p:cNvPr id="6" name="Text 4"/>
-          <p:cNvSpPr/>
-          <p:nvPr/>
-        </p:nvSpPr>
-        <p:spPr>
-          <a:xfrm>
-            <a:off x="1106424" y="1362456"/>
-            <a:ext cx="3877056" cy="292608"/>
+            <a:endParaRPr lang="en-US" sz="1600" dirty="0"/>
+          </a:p>
+        </p:txBody>
+      </p:sp>
+      <p:sp>
+        <p:nvSpPr>
+          <p:cNvPr id="8" name="Shape 6"/>
+          <p:cNvSpPr/>
+          <p:nvPr/>
+        </p:nvSpPr>
+        <p:spPr>
+          <a:xfrm>
+            <a:off x="1143000" y="1417320"/>
+            <a:ext cx="7452360" cy="420624"/>
+          </a:xfrm>
+          <a:prstGeom prst="roundRect">
+            <a:avLst>
+              <a:gd name="adj" fmla="val 15217"/>
+            </a:avLst>
+          </a:prstGeom>
+          <a:solidFill>
+            <a:srgbClr val="F3F6FD"/>
+          </a:solidFill>
+          <a:ln/>
+        </p:spPr>
+      </p:sp>
+      <p:sp>
+        <p:nvSpPr>
+          <p:cNvPr id="9" name="Text 7"/>
+          <p:cNvSpPr/>
+          <p:nvPr/>
+        </p:nvSpPr>
+        <p:spPr>
+          <a:xfrm>
+            <a:off x="1371600" y="1417320"/>
+            <a:ext cx="4206240" cy="420624"/>
           </a:xfrm>
           <a:prstGeom prst="rect">
             <a:avLst/>
@@ -1900,7 +1966,7 @@
                 <a:ea typeface="Arial" pitchFamily="34" charset="-122"/>
                 <a:cs typeface="Arial" pitchFamily="34" charset="-120"/>
               </a:rPr>
-              <a:t>The physics goal</a:t>
+              <a:t>PicoDst Reader Migration</a:t>
             </a:r>
             <a:endParaRPr lang="en-US" sz="1500" dirty="0"/>
           </a:p>
@@ -1908,30 +1974,189 @@
       </p:sp>
       <p:sp>
         <p:nvSpPr>
-          <p:cNvPr id="7" name="Text 5"/>
-          <p:cNvSpPr/>
-          <p:nvPr/>
-        </p:nvSpPr>
-        <p:spPr>
-          <a:xfrm>
-            <a:off x="1106424" y="1673352"/>
-            <a:ext cx="3877056" cy="502920"/>
-          </a:xfrm>
-          <a:prstGeom prst="rect">
-            <a:avLst/>
-          </a:prstGeom>
-          <a:noFill/>
-          <a:ln/>
-        </p:spPr>
-        <p:txBody>
-          <a:bodyPr wrap="square" lIns="0" tIns="0" rIns="0" bIns="0" rtlCol="0" anchor="t"/>
+          <p:cNvPr id="10" name="Text 8"/>
+          <p:cNvSpPr/>
+          <p:nvPr/>
+        </p:nvSpPr>
+        <p:spPr>
+          <a:xfrm>
+            <a:off x="5669280" y="1417320"/>
+            <a:ext cx="2788920" cy="420624"/>
+          </a:xfrm>
+          <a:prstGeom prst="rect">
+            <a:avLst/>
+          </a:prstGeom>
+          <a:noFill/>
+          <a:ln/>
+        </p:spPr>
+        <p:txBody>
+          <a:bodyPr wrap="square" lIns="0" tIns="0" rIns="0" bIns="0" rtlCol="0" anchor="ctr"/>
+          <a:lstStyle/>
+          <a:p>
+            <a:pPr algn="r" indent="0" marL="0">
+              <a:buNone/>
+            </a:pPr>
+            <a:r>
+              <a:rPr lang="en-US" sz="1150" i="1" dirty="0">
+                <a:solidFill>
+                  <a:srgbClr val="5B6382"/>
+                </a:solidFill>
+                <a:latin typeface="Arial" pitchFamily="34" charset="0"/>
+                <a:ea typeface="Arial" pitchFamily="34" charset="-122"/>
+                <a:cs typeface="Arial" pitchFamily="34" charset="-120"/>
+              </a:rPr>
+              <a:t>Porting to the SL24y library</a:t>
+            </a:r>
+            <a:endParaRPr lang="en-US" sz="1150" dirty="0"/>
+          </a:p>
+        </p:txBody>
+      </p:sp>
+      <p:sp>
+        <p:nvSpPr>
+          <p:cNvPr id="11" name="Shape 9"/>
+          <p:cNvSpPr/>
+          <p:nvPr/>
+        </p:nvSpPr>
+        <p:spPr>
+          <a:xfrm>
+            <a:off x="548640" y="1965960"/>
+            <a:ext cx="420624" cy="420624"/>
+          </a:xfrm>
+          <a:prstGeom prst="ellipse">
+            <a:avLst/>
+          </a:prstGeom>
+          <a:solidFill>
+            <a:srgbClr val="E8A33D"/>
+          </a:solidFill>
+          <a:ln/>
+        </p:spPr>
+      </p:sp>
+      <p:sp>
+        <p:nvSpPr>
+          <p:cNvPr id="12" name="Text 10"/>
+          <p:cNvSpPr/>
+          <p:nvPr/>
+        </p:nvSpPr>
+        <p:spPr>
+          <a:xfrm>
+            <a:off x="548640" y="1952244"/>
+            <a:ext cx="420624" cy="420624"/>
+          </a:xfrm>
+          <a:prstGeom prst="rect">
+            <a:avLst/>
+          </a:prstGeom>
+          <a:noFill/>
+          <a:ln/>
+        </p:spPr>
+        <p:txBody>
+          <a:bodyPr wrap="square" lIns="0" tIns="0" rIns="0" bIns="0" rtlCol="0" anchor="ctr"/>
+          <a:lstStyle/>
+          <a:p>
+            <a:pPr algn="ctr" indent="0" marL="0">
+              <a:buNone/>
+            </a:pPr>
+            <a:r>
+              <a:rPr lang="en-US" sz="1600" b="1" dirty="0">
+                <a:solidFill>
+                  <a:srgbClr val="FFFFFF"/>
+                </a:solidFill>
+                <a:latin typeface="Arial" pitchFamily="34" charset="0"/>
+                <a:ea typeface="Arial" pitchFamily="34" charset="-122"/>
+                <a:cs typeface="Arial" pitchFamily="34" charset="-120"/>
+              </a:rPr>
+              <a:t>2</a:t>
+            </a:r>
+            <a:endParaRPr lang="en-US" sz="1600" dirty="0"/>
+          </a:p>
+        </p:txBody>
+      </p:sp>
+      <p:sp>
+        <p:nvSpPr>
+          <p:cNvPr id="13" name="Shape 11"/>
+          <p:cNvSpPr/>
+          <p:nvPr/>
+        </p:nvSpPr>
+        <p:spPr>
+          <a:xfrm>
+            <a:off x="1143000" y="1965960"/>
+            <a:ext cx="7452360" cy="420624"/>
+          </a:xfrm>
+          <a:prstGeom prst="roundRect">
+            <a:avLst>
+              <a:gd name="adj" fmla="val 15217"/>
+            </a:avLst>
+          </a:prstGeom>
+          <a:solidFill>
+            <a:srgbClr val="F3F6FD"/>
+          </a:solidFill>
+          <a:ln/>
+        </p:spPr>
+      </p:sp>
+      <p:sp>
+        <p:nvSpPr>
+          <p:cNvPr id="14" name="Text 12"/>
+          <p:cNvSpPr/>
+          <p:nvPr/>
+        </p:nvSpPr>
+        <p:spPr>
+          <a:xfrm>
+            <a:off x="1371600" y="1965960"/>
+            <a:ext cx="4206240" cy="420624"/>
+          </a:xfrm>
+          <a:prstGeom prst="rect">
+            <a:avLst/>
+          </a:prstGeom>
+          <a:noFill/>
+          <a:ln/>
+        </p:spPr>
+        <p:txBody>
+          <a:bodyPr wrap="square" lIns="0" tIns="0" rIns="0" bIns="0" rtlCol="0" anchor="ctr"/>
           <a:lstStyle/>
           <a:p>
             <a:pPr indent="0" marL="0">
               <a:buNone/>
             </a:pPr>
             <a:r>
-              <a:rPr lang="en-US" sz="1250" dirty="0">
+              <a:rPr lang="en-US" sz="1500" b="1" dirty="0">
+                <a:solidFill>
+                  <a:srgbClr val="1E2761"/>
+                </a:solidFill>
+                <a:latin typeface="Arial" pitchFamily="34" charset="0"/>
+                <a:ea typeface="Arial" pitchFamily="34" charset="-122"/>
+                <a:cs typeface="Arial" pitchFamily="34" charset="-120"/>
+              </a:rPr>
+              <a:t>SDCC Batch Submission</a:t>
+            </a:r>
+            <a:endParaRPr lang="en-US" sz="1500" dirty="0"/>
+          </a:p>
+        </p:txBody>
+      </p:sp>
+      <p:sp>
+        <p:nvSpPr>
+          <p:cNvPr id="15" name="Text 13"/>
+          <p:cNvSpPr/>
+          <p:nvPr/>
+        </p:nvSpPr>
+        <p:spPr>
+          <a:xfrm>
+            <a:off x="5669280" y="1965960"/>
+            <a:ext cx="2788920" cy="420624"/>
+          </a:xfrm>
+          <a:prstGeom prst="rect">
+            <a:avLst/>
+          </a:prstGeom>
+          <a:noFill/>
+          <a:ln/>
+        </p:spPr>
+        <p:txBody>
+          <a:bodyPr wrap="square" lIns="0" tIns="0" rIns="0" bIns="0" rtlCol="0" anchor="ctr"/>
+          <a:lstStyle/>
+          <a:p>
+            <a:pPr algn="r" indent="0" marL="0">
+              <a:buNone/>
+            </a:pPr>
+            <a:r>
+              <a:rPr lang="en-US" sz="1150" i="1" dirty="0">
                 <a:solidFill>
                   <a:srgbClr val="5B6382"/>
                 </a:solidFill>
@@ -1939,22 +2164,22 @@
                 <a:ea typeface="Arial" pitchFamily="34" charset="-122"/>
                 <a:cs typeface="Arial" pitchFamily="34" charset="-120"/>
               </a:rPr>
-              <a:t>Identified pion/kaon/proton spectra in O+O collisions at √sNN = 200 GeV, ColliderCenter geometry.</a:t>
-            </a:r>
-            <a:endParaRPr lang="en-US" sz="1250" dirty="0"/>
-          </a:p>
-        </p:txBody>
-      </p:sp>
-      <p:sp>
-        <p:nvSpPr>
-          <p:cNvPr id="8" name="Shape 6"/>
-          <p:cNvSpPr/>
-          <p:nvPr/>
-        </p:nvSpPr>
-        <p:spPr>
-          <a:xfrm>
-            <a:off x="502920" y="2258568"/>
-            <a:ext cx="402336" cy="402336"/>
+              <a:t>Running Stage 1 at production scale</a:t>
+            </a:r>
+            <a:endParaRPr lang="en-US" sz="1150" dirty="0"/>
+          </a:p>
+        </p:txBody>
+      </p:sp>
+      <p:sp>
+        <p:nvSpPr>
+          <p:cNvPr id="16" name="Shape 14"/>
+          <p:cNvSpPr/>
+          <p:nvPr/>
+        </p:nvSpPr>
+        <p:spPr>
+          <a:xfrm>
+            <a:off x="548640" y="2514600"/>
+            <a:ext cx="420624" cy="420624"/>
           </a:xfrm>
           <a:prstGeom prst="ellipse">
             <a:avLst/>
@@ -1967,14 +2192,14 @@
       </p:sp>
       <p:sp>
         <p:nvSpPr>
-          <p:cNvPr id="9" name="Text 7"/>
-          <p:cNvSpPr/>
-          <p:nvPr/>
-        </p:nvSpPr>
-        <p:spPr>
-          <a:xfrm>
-            <a:off x="502920" y="2244852"/>
-            <a:ext cx="402336" cy="402336"/>
+          <p:cNvPr id="17" name="Text 15"/>
+          <p:cNvSpPr/>
+          <p:nvPr/>
+        </p:nvSpPr>
+        <p:spPr>
+          <a:xfrm>
+            <a:off x="548640" y="2500884"/>
+            <a:ext cx="420624" cy="420624"/>
           </a:xfrm>
           <a:prstGeom prst="rect">
             <a:avLst/>
@@ -1990,7 +2215,7 @@
               <a:buNone/>
             </a:pPr>
             <a:r>
-              <a:rPr lang="en-US" sz="1400" b="1" dirty="0">
+              <a:rPr lang="en-US" sz="1600" b="1" dirty="0">
                 <a:solidFill>
                   <a:srgbClr val="FFFFFF"/>
                 </a:solidFill>
@@ -1998,22 +2223,44 @@
                 <a:ea typeface="Arial" pitchFamily="34" charset="-122"/>
                 <a:cs typeface="Arial" pitchFamily="34" charset="-120"/>
               </a:rPr>
-              <a:t>2</a:t>
-            </a:r>
-            <a:endParaRPr lang="en-US" sz="1400" dirty="0"/>
-          </a:p>
-        </p:txBody>
-      </p:sp>
-      <p:sp>
-        <p:nvSpPr>
-          <p:cNvPr id="10" name="Text 8"/>
-          <p:cNvSpPr/>
-          <p:nvPr/>
-        </p:nvSpPr>
-        <p:spPr>
-          <a:xfrm>
-            <a:off x="1106424" y="2203704"/>
-            <a:ext cx="3877056" cy="292608"/>
+              <a:t>3</a:t>
+            </a:r>
+            <a:endParaRPr lang="en-US" sz="1600" dirty="0"/>
+          </a:p>
+        </p:txBody>
+      </p:sp>
+      <p:sp>
+        <p:nvSpPr>
+          <p:cNvPr id="18" name="Shape 16"/>
+          <p:cNvSpPr/>
+          <p:nvPr/>
+        </p:nvSpPr>
+        <p:spPr>
+          <a:xfrm>
+            <a:off x="1143000" y="2514600"/>
+            <a:ext cx="7452360" cy="420624"/>
+          </a:xfrm>
+          <a:prstGeom prst="roundRect">
+            <a:avLst>
+              <a:gd name="adj" fmla="val 15217"/>
+            </a:avLst>
+          </a:prstGeom>
+          <a:solidFill>
+            <a:srgbClr val="F3F6FD"/>
+          </a:solidFill>
+          <a:ln/>
+        </p:spPr>
+      </p:sp>
+      <p:sp>
+        <p:nvSpPr>
+          <p:cNvPr id="19" name="Text 17"/>
+          <p:cNvSpPr/>
+          <p:nvPr/>
+        </p:nvSpPr>
+        <p:spPr>
+          <a:xfrm>
+            <a:off x="1371600" y="2514600"/>
+            <a:ext cx="4206240" cy="420624"/>
           </a:xfrm>
           <a:prstGeom prst="rect">
             <a:avLst/>
@@ -2037,7 +2284,7 @@
                 <a:ea typeface="Arial" pitchFamily="34" charset="-122"/>
                 <a:cs typeface="Arial" pitchFamily="34" charset="-120"/>
               </a:rPr>
-              <a:t>A lean, focused fork</a:t>
+              <a:t>Getting the Build Working</a:t>
             </a:r>
             <a:endParaRPr lang="en-US" sz="1500" dirty="0"/>
           </a:p>
@@ -2045,30 +2292,189 @@
       </p:sp>
       <p:sp>
         <p:nvSpPr>
-          <p:cNvPr id="11" name="Text 9"/>
-          <p:cNvSpPr/>
-          <p:nvPr/>
-        </p:nvSpPr>
-        <p:spPr>
-          <a:xfrm>
-            <a:off x="1106424" y="2514600"/>
-            <a:ext cx="3877056" cy="502920"/>
-          </a:xfrm>
-          <a:prstGeom prst="rect">
-            <a:avLst/>
-          </a:prstGeom>
-          <a:noFill/>
-          <a:ln/>
-        </p:spPr>
-        <p:txBody>
-          <a:bodyPr wrap="square" lIns="0" tIns="0" rIns="0" bIns="0" rtlCol="0" anchor="t"/>
+          <p:cNvPr id="20" name="Text 18"/>
+          <p:cNvSpPr/>
+          <p:nvPr/>
+        </p:nvSpPr>
+        <p:spPr>
+          <a:xfrm>
+            <a:off x="5669280" y="2514600"/>
+            <a:ext cx="2788920" cy="420624"/>
+          </a:xfrm>
+          <a:prstGeom prst="rect">
+            <a:avLst/>
+          </a:prstGeom>
+          <a:noFill/>
+          <a:ln/>
+        </p:spPr>
+        <p:txBody>
+          <a:bodyPr wrap="square" lIns="0" tIns="0" rIns="0" bIns="0" rtlCol="0" anchor="ctr"/>
+          <a:lstStyle/>
+          <a:p>
+            <a:pPr algn="r" indent="0" marL="0">
+              <a:buNone/>
+            </a:pPr>
+            <a:r>
+              <a:rPr lang="en-US" sz="1150" i="1" dirty="0">
+                <a:solidFill>
+                  <a:srgbClr val="5B6382"/>
+                </a:solidFill>
+                <a:latin typeface="Arial" pitchFamily="34" charset="0"/>
+                <a:ea typeface="Arial" pitchFamily="34" charset="-122"/>
+                <a:cs typeface="Arial" pitchFamily="34" charset="-120"/>
+              </a:rPr>
+              <a:t>ROOT5 / CINT compatibility fixes</a:t>
+            </a:r>
+            <a:endParaRPr lang="en-US" sz="1150" dirty="0"/>
+          </a:p>
+        </p:txBody>
+      </p:sp>
+      <p:sp>
+        <p:nvSpPr>
+          <p:cNvPr id="21" name="Shape 19"/>
+          <p:cNvSpPr/>
+          <p:nvPr/>
+        </p:nvSpPr>
+        <p:spPr>
+          <a:xfrm>
+            <a:off x="548640" y="3063240"/>
+            <a:ext cx="420624" cy="420624"/>
+          </a:xfrm>
+          <a:prstGeom prst="ellipse">
+            <a:avLst/>
+          </a:prstGeom>
+          <a:solidFill>
+            <a:srgbClr val="E8A33D"/>
+          </a:solidFill>
+          <a:ln/>
+        </p:spPr>
+      </p:sp>
+      <p:sp>
+        <p:nvSpPr>
+          <p:cNvPr id="22" name="Text 20"/>
+          <p:cNvSpPr/>
+          <p:nvPr/>
+        </p:nvSpPr>
+        <p:spPr>
+          <a:xfrm>
+            <a:off x="548640" y="3049524"/>
+            <a:ext cx="420624" cy="420624"/>
+          </a:xfrm>
+          <a:prstGeom prst="rect">
+            <a:avLst/>
+          </a:prstGeom>
+          <a:noFill/>
+          <a:ln/>
+        </p:spPr>
+        <p:txBody>
+          <a:bodyPr wrap="square" lIns="0" tIns="0" rIns="0" bIns="0" rtlCol="0" anchor="ctr"/>
+          <a:lstStyle/>
+          <a:p>
+            <a:pPr algn="ctr" indent="0" marL="0">
+              <a:buNone/>
+            </a:pPr>
+            <a:r>
+              <a:rPr lang="en-US" sz="1600" b="1" dirty="0">
+                <a:solidFill>
+                  <a:srgbClr val="FFFFFF"/>
+                </a:solidFill>
+                <a:latin typeface="Arial" pitchFamily="34" charset="0"/>
+                <a:ea typeface="Arial" pitchFamily="34" charset="-122"/>
+                <a:cs typeface="Arial" pitchFamily="34" charset="-120"/>
+              </a:rPr>
+              <a:t>4</a:t>
+            </a:r>
+            <a:endParaRPr lang="en-US" sz="1600" dirty="0"/>
+          </a:p>
+        </p:txBody>
+      </p:sp>
+      <p:sp>
+        <p:nvSpPr>
+          <p:cNvPr id="23" name="Shape 21"/>
+          <p:cNvSpPr/>
+          <p:nvPr/>
+        </p:nvSpPr>
+        <p:spPr>
+          <a:xfrm>
+            <a:off x="1143000" y="3063240"/>
+            <a:ext cx="7452360" cy="420624"/>
+          </a:xfrm>
+          <a:prstGeom prst="roundRect">
+            <a:avLst>
+              <a:gd name="adj" fmla="val 15217"/>
+            </a:avLst>
+          </a:prstGeom>
+          <a:solidFill>
+            <a:srgbClr val="F3F6FD"/>
+          </a:solidFill>
+          <a:ln/>
+        </p:spPr>
+      </p:sp>
+      <p:sp>
+        <p:nvSpPr>
+          <p:cNvPr id="24" name="Text 22"/>
+          <p:cNvSpPr/>
+          <p:nvPr/>
+        </p:nvSpPr>
+        <p:spPr>
+          <a:xfrm>
+            <a:off x="1371600" y="3063240"/>
+            <a:ext cx="4206240" cy="420624"/>
+          </a:xfrm>
+          <a:prstGeom prst="rect">
+            <a:avLst/>
+          </a:prstGeom>
+          <a:noFill/>
+          <a:ln/>
+        </p:spPr>
+        <p:txBody>
+          <a:bodyPr wrap="square" lIns="0" tIns="0" rIns="0" bIns="0" rtlCol="0" anchor="ctr"/>
           <a:lstStyle/>
           <a:p>
             <a:pPr indent="0" marL="0">
               <a:buNone/>
             </a:pPr>
             <a:r>
-              <a:rPr lang="en-US" sz="1250" dirty="0">
+              <a:rPr lang="en-US" sz="1500" b="1" dirty="0">
+                <a:solidFill>
+                  <a:srgbClr val="1E2761"/>
+                </a:solidFill>
+                <a:latin typeface="Arial" pitchFamily="34" charset="0"/>
+                <a:ea typeface="Arial" pitchFamily="34" charset="-122"/>
+                <a:cs typeface="Arial" pitchFamily="34" charset="-120"/>
+              </a:rPr>
+              <a:t>Current Status</a:t>
+            </a:r>
+            <a:endParaRPr lang="en-US" sz="1500" dirty="0"/>
+          </a:p>
+        </p:txBody>
+      </p:sp>
+      <p:sp>
+        <p:nvSpPr>
+          <p:cNvPr id="25" name="Text 23"/>
+          <p:cNvSpPr/>
+          <p:nvPr/>
+        </p:nvSpPr>
+        <p:spPr>
+          <a:xfrm>
+            <a:off x="5669280" y="3063240"/>
+            <a:ext cx="2788920" cy="420624"/>
+          </a:xfrm>
+          <a:prstGeom prst="rect">
+            <a:avLst/>
+          </a:prstGeom>
+          <a:noFill/>
+          <a:ln/>
+        </p:spPr>
+        <p:txBody>
+          <a:bodyPr wrap="square" lIns="0" tIns="0" rIns="0" bIns="0" rtlCol="0" anchor="ctr"/>
+          <a:lstStyle/>
+          <a:p>
+            <a:pPr algn="r" indent="0" marL="0">
+              <a:buNone/>
+            </a:pPr>
+            <a:r>
+              <a:rPr lang="en-US" sz="1150" i="1" dirty="0">
                 <a:solidFill>
                   <a:srgbClr val="5B6382"/>
                 </a:solidFill>
@@ -2076,22 +2482,22 @@
                 <a:ea typeface="Arial" pitchFamily="34" charset="-122"/>
                 <a:cs typeface="Arial" pitchFamily="34" charset="-120"/>
               </a:rPr>
-              <a:t>Narrowed a multi-energy codebase down to just this dataset for fast, laptop-scale runs.</a:t>
-            </a:r>
-            <a:endParaRPr lang="en-US" sz="1250" dirty="0"/>
-          </a:p>
-        </p:txBody>
-      </p:sp>
-      <p:sp>
-        <p:nvSpPr>
-          <p:cNvPr id="12" name="Shape 10"/>
-          <p:cNvSpPr/>
-          <p:nvPr/>
-        </p:nvSpPr>
-        <p:spPr>
-          <a:xfrm>
-            <a:off x="502920" y="3099816"/>
-            <a:ext cx="402336" cy="402336"/>
+              <a:t>What's working today</a:t>
+            </a:r>
+            <a:endParaRPr lang="en-US" sz="1150" dirty="0"/>
+          </a:p>
+        </p:txBody>
+      </p:sp>
+      <p:sp>
+        <p:nvSpPr>
+          <p:cNvPr id="26" name="Shape 24"/>
+          <p:cNvSpPr/>
+          <p:nvPr/>
+        </p:nvSpPr>
+        <p:spPr>
+          <a:xfrm>
+            <a:off x="548640" y="3611880"/>
+            <a:ext cx="420624" cy="420624"/>
           </a:xfrm>
           <a:prstGeom prst="ellipse">
             <a:avLst/>
@@ -2104,14 +2510,14 @@
       </p:sp>
       <p:sp>
         <p:nvSpPr>
-          <p:cNvPr id="13" name="Text 11"/>
-          <p:cNvSpPr/>
-          <p:nvPr/>
-        </p:nvSpPr>
-        <p:spPr>
-          <a:xfrm>
-            <a:off x="502920" y="3086100"/>
-            <a:ext cx="402336" cy="402336"/>
+          <p:cNvPr id="27" name="Text 25"/>
+          <p:cNvSpPr/>
+          <p:nvPr/>
+        </p:nvSpPr>
+        <p:spPr>
+          <a:xfrm>
+            <a:off x="548640" y="3598164"/>
+            <a:ext cx="420624" cy="420624"/>
           </a:xfrm>
           <a:prstGeom prst="rect">
             <a:avLst/>
@@ -2127,7 +2533,7 @@
               <a:buNone/>
             </a:pPr>
             <a:r>
-              <a:rPr lang="en-US" sz="1400" b="1" dirty="0">
+              <a:rPr lang="en-US" sz="1600" b="1" dirty="0">
                 <a:solidFill>
                   <a:srgbClr val="FFFFFF"/>
                 </a:solidFill>
@@ -2135,22 +2541,44 @@
                 <a:ea typeface="Arial" pitchFamily="34" charset="-122"/>
                 <a:cs typeface="Arial" pitchFamily="34" charset="-120"/>
               </a:rPr>
-              <a:t>3</a:t>
-            </a:r>
-            <a:endParaRPr lang="en-US" sz="1400" dirty="0"/>
-          </a:p>
-        </p:txBody>
-      </p:sp>
-      <p:sp>
-        <p:nvSpPr>
-          <p:cNvPr id="14" name="Text 12"/>
-          <p:cNvSpPr/>
-          <p:nvPr/>
-        </p:nvSpPr>
-        <p:spPr>
-          <a:xfrm>
-            <a:off x="1106424" y="3044952"/>
-            <a:ext cx="3877056" cy="292608"/>
+              <a:t>5</a:t>
+            </a:r>
+            <a:endParaRPr lang="en-US" sz="1600" dirty="0"/>
+          </a:p>
+        </p:txBody>
+      </p:sp>
+      <p:sp>
+        <p:nvSpPr>
+          <p:cNvPr id="28" name="Shape 26"/>
+          <p:cNvSpPr/>
+          <p:nvPr/>
+        </p:nvSpPr>
+        <p:spPr>
+          <a:xfrm>
+            <a:off x="1143000" y="3611880"/>
+            <a:ext cx="7452360" cy="420624"/>
+          </a:xfrm>
+          <a:prstGeom prst="roundRect">
+            <a:avLst>
+              <a:gd name="adj" fmla="val 15217"/>
+            </a:avLst>
+          </a:prstGeom>
+          <a:solidFill>
+            <a:srgbClr val="F3F6FD"/>
+          </a:solidFill>
+          <a:ln/>
+        </p:spPr>
+      </p:sp>
+      <p:sp>
+        <p:nvSpPr>
+          <p:cNvPr id="29" name="Text 27"/>
+          <p:cNvSpPr/>
+          <p:nvPr/>
+        </p:nvSpPr>
+        <p:spPr>
+          <a:xfrm>
+            <a:off x="1371600" y="3611880"/>
+            <a:ext cx="4206240" cy="420624"/>
           </a:xfrm>
           <a:prstGeom prst="rect">
             <a:avLst/>
@@ -2174,7 +2602,7 @@
                 <a:ea typeface="Arial" pitchFamily="34" charset="-122"/>
                 <a:cs typeface="Arial" pitchFamily="34" charset="-120"/>
               </a:rPr>
-              <a:t>Four-stage pipeline</a:t>
+              <a:t>What's Still Needed</a:t>
             </a:r>
             <a:endParaRPr lang="en-US" sz="1500" dirty="0"/>
           </a:p>
@@ -2182,30 +2610,30 @@
       </p:sp>
       <p:sp>
         <p:nvSpPr>
-          <p:cNvPr id="15" name="Text 13"/>
-          <p:cNvSpPr/>
-          <p:nvPr/>
-        </p:nvSpPr>
-        <p:spPr>
-          <a:xfrm>
-            <a:off x="1106424" y="3355848"/>
-            <a:ext cx="3877056" cy="502920"/>
-          </a:xfrm>
-          <a:prstGeom prst="rect">
-            <a:avLst/>
-          </a:prstGeom>
-          <a:noFill/>
-          <a:ln/>
-        </p:spPr>
-        <p:txBody>
-          <a:bodyPr wrap="square" lIns="0" tIns="0" rIns="0" bIns="0" rtlCol="0" anchor="t"/>
-          <a:lstStyle/>
-          <a:p>
-            <a:pPr indent="0" marL="0">
-              <a:buNone/>
-            </a:pPr>
-            <a:r>
-              <a:rPr lang="en-US" sz="1250" dirty="0">
+          <p:cNvPr id="30" name="Text 28"/>
+          <p:cNvSpPr/>
+          <p:nvPr/>
+        </p:nvSpPr>
+        <p:spPr>
+          <a:xfrm>
+            <a:off x="5669280" y="3611880"/>
+            <a:ext cx="2788920" cy="420624"/>
+          </a:xfrm>
+          <a:prstGeom prst="rect">
+            <a:avLst/>
+          </a:prstGeom>
+          <a:noFill/>
+          <a:ln/>
+        </p:spPr>
+        <p:txBody>
+          <a:bodyPr wrap="square" lIns="0" tIns="0" rIns="0" bIns="0" rtlCol="0" anchor="ctr"/>
+          <a:lstStyle/>
+          <a:p>
+            <a:pPr algn="r" indent="0" marL="0">
+              <a:buNone/>
+            </a:pPr>
+            <a:r>
+              <a:rPr lang="en-US" sz="1150" i="1" dirty="0">
                 <a:solidFill>
                   <a:srgbClr val="5B6382"/>
                 </a:solidFill>
@@ -2213,22 +2641,22 @@
                 <a:ea typeface="Arial" pitchFamily="34" charset="-122"/>
                 <a:cs typeface="Arial" pitchFamily="34" charset="-120"/>
               </a:rPr>
-              <a:t>Raw yields → PID fits → corrections → final spectra fits (see right).</a:t>
-            </a:r>
-            <a:endParaRPr lang="en-US" sz="1250" dirty="0"/>
-          </a:p>
-        </p:txBody>
-      </p:sp>
-      <p:sp>
-        <p:nvSpPr>
-          <p:cNvPr id="16" name="Shape 14"/>
-          <p:cNvSpPr/>
-          <p:nvPr/>
-        </p:nvSpPr>
-        <p:spPr>
-          <a:xfrm>
-            <a:off x="502920" y="3941064"/>
-            <a:ext cx="402336" cy="402336"/>
+              <a:t>Remaining steps before first results</a:t>
+            </a:r>
+            <a:endParaRPr lang="en-US" sz="1150" dirty="0"/>
+          </a:p>
+        </p:txBody>
+      </p:sp>
+      <p:sp>
+        <p:nvSpPr>
+          <p:cNvPr id="31" name="Shape 29"/>
+          <p:cNvSpPr/>
+          <p:nvPr/>
+        </p:nvSpPr>
+        <p:spPr>
+          <a:xfrm>
+            <a:off x="548640" y="4160520"/>
+            <a:ext cx="420624" cy="420624"/>
           </a:xfrm>
           <a:prstGeom prst="ellipse">
             <a:avLst/>
@@ -2241,14 +2669,14 @@
       </p:sp>
       <p:sp>
         <p:nvSpPr>
-          <p:cNvPr id="17" name="Text 15"/>
-          <p:cNvSpPr/>
-          <p:nvPr/>
-        </p:nvSpPr>
-        <p:spPr>
-          <a:xfrm>
-            <a:off x="502920" y="3927348"/>
-            <a:ext cx="402336" cy="402336"/>
+          <p:cNvPr id="32" name="Text 30"/>
+          <p:cNvSpPr/>
+          <p:nvPr/>
+        </p:nvSpPr>
+        <p:spPr>
+          <a:xfrm>
+            <a:off x="548640" y="4146804"/>
+            <a:ext cx="420624" cy="420624"/>
           </a:xfrm>
           <a:prstGeom prst="rect">
             <a:avLst/>
@@ -2264,7 +2692,7 @@
               <a:buNone/>
             </a:pPr>
             <a:r>
-              <a:rPr lang="en-US" sz="1400" b="1" dirty="0">
+              <a:rPr lang="en-US" sz="1600" b="1" dirty="0">
                 <a:solidFill>
                   <a:srgbClr val="FFFFFF"/>
                 </a:solidFill>
@@ -2272,134 +2700,44 @@
                 <a:ea typeface="Arial" pitchFamily="34" charset="-122"/>
                 <a:cs typeface="Arial" pitchFamily="34" charset="-120"/>
               </a:rPr>
-              <a:t>4</a:t>
-            </a:r>
-            <a:endParaRPr lang="en-US" sz="1400" dirty="0"/>
-          </a:p>
-        </p:txBody>
-      </p:sp>
-      <p:sp>
-        <p:nvSpPr>
-          <p:cNvPr id="18" name="Text 16"/>
-          <p:cNvSpPr/>
-          <p:nvPr/>
-        </p:nvSpPr>
-        <p:spPr>
-          <a:xfrm>
-            <a:off x="1106424" y="3886200"/>
-            <a:ext cx="3877056" cy="292608"/>
-          </a:xfrm>
-          <a:prstGeom prst="rect">
-            <a:avLst/>
-          </a:prstGeom>
-          <a:noFill/>
-          <a:ln/>
-        </p:spPr>
-        <p:txBody>
-          <a:bodyPr wrap="square" lIns="0" tIns="0" rIns="0" bIns="0" rtlCol="0" anchor="ctr"/>
-          <a:lstStyle/>
-          <a:p>
-            <a:pPr indent="0" marL="0">
-              <a:buNone/>
-            </a:pPr>
-            <a:r>
-              <a:rPr lang="en-US" sz="1500" b="1" dirty="0">
-                <a:solidFill>
-                  <a:srgbClr val="1E2761"/>
-                </a:solidFill>
-                <a:latin typeface="Arial" pitchFamily="34" charset="0"/>
-                <a:ea typeface="Arial" pitchFamily="34" charset="-122"/>
-                <a:cs typeface="Arial" pitchFamily="34" charset="-120"/>
-              </a:rPr>
-              <a:t>New this cycle</a:t>
-            </a:r>
-            <a:endParaRPr lang="en-US" sz="1500" dirty="0"/>
-          </a:p>
-        </p:txBody>
-      </p:sp>
-      <p:sp>
-        <p:nvSpPr>
-          <p:cNvPr id="19" name="Text 17"/>
-          <p:cNvSpPr/>
-          <p:nvPr/>
-        </p:nvSpPr>
-        <p:spPr>
-          <a:xfrm>
-            <a:off x="1106424" y="4197096"/>
-            <a:ext cx="3877056" cy="502920"/>
-          </a:xfrm>
-          <a:prstGeom prst="rect">
-            <a:avLst/>
-          </a:prstGeom>
-          <a:noFill/>
-          <a:ln/>
-        </p:spPr>
-        <p:txBody>
-          <a:bodyPr wrap="square" lIns="0" tIns="0" rIns="0" bIns="0" rtlCol="0" anchor="t"/>
-          <a:lstStyle/>
-          <a:p>
-            <a:pPr indent="0" marL="0">
-              <a:buNone/>
-            </a:pPr>
-            <a:r>
-              <a:rPr lang="en-US" sz="1250" dirty="0">
-                <a:solidFill>
-                  <a:srgbClr val="5B6382"/>
-                </a:solidFill>
-                <a:latin typeface="Arial" pitchFamily="34" charset="0"/>
-                <a:ea typeface="Arial" pitchFamily="34" charset="-122"/>
-                <a:cs typeface="Arial" pitchFamily="34" charset="-120"/>
-              </a:rPr>
-              <a:t>Added a batch-submission path so I can run the first stage on the full production dataset at SDCC, not just locally.</a:t>
-            </a:r>
-            <a:endParaRPr lang="en-US" sz="1250" dirty="0"/>
-          </a:p>
-        </p:txBody>
-      </p:sp>
-      <p:sp>
-        <p:nvSpPr>
-          <p:cNvPr id="20" name="Shape 18"/>
-          <p:cNvSpPr/>
-          <p:nvPr/>
-        </p:nvSpPr>
-        <p:spPr>
-          <a:xfrm>
-            <a:off x="5349240" y="1371600"/>
-            <a:ext cx="1508760" cy="566928"/>
+              <a:t>6</a:t>
+            </a:r>
+            <a:endParaRPr lang="en-US" sz="1600" dirty="0"/>
+          </a:p>
+        </p:txBody>
+      </p:sp>
+      <p:sp>
+        <p:nvSpPr>
+          <p:cNvPr id="33" name="Shape 31"/>
+          <p:cNvSpPr/>
+          <p:nvPr/>
+        </p:nvSpPr>
+        <p:spPr>
+          <a:xfrm>
+            <a:off x="1143000" y="4160520"/>
+            <a:ext cx="7452360" cy="420624"/>
           </a:xfrm>
           <a:prstGeom prst="roundRect">
             <a:avLst>
-              <a:gd name="adj" fmla="val 12903"/>
+              <a:gd name="adj" fmla="val 15217"/>
             </a:avLst>
           </a:prstGeom>
           <a:solidFill>
             <a:srgbClr val="F3F6FD"/>
           </a:solidFill>
-          <a:ln w="12700">
-            <a:solidFill>
-              <a:srgbClr val="1E2761"/>
-            </a:solidFill>
-            <a:prstDash val="solid"/>
-          </a:ln>
-          <a:effectLst>
-            <a:outerShdw sx="100000" sy="100000" kx="0" ky="0" algn="bl" rotWithShape="0" blurRad="50800" dist="12700" dir="2700000">
-              <a:srgbClr val="000000">
-                <a:alpha val="12000"/>
-              </a:srgbClr>
-            </a:outerShdw>
-          </a:effectLst>
-        </p:spPr>
-      </p:sp>
-      <p:sp>
-        <p:nvSpPr>
-          <p:cNvPr id="21" name="Text 19"/>
-          <p:cNvSpPr/>
-          <p:nvPr/>
-        </p:nvSpPr>
-        <p:spPr>
-          <a:xfrm>
-            <a:off x="5404104" y="1408176"/>
-            <a:ext cx="320040" cy="274320"/>
+          <a:ln/>
+        </p:spPr>
+      </p:sp>
+      <p:sp>
+        <p:nvSpPr>
+          <p:cNvPr id="34" name="Text 32"/>
+          <p:cNvSpPr/>
+          <p:nvPr/>
+        </p:nvSpPr>
+        <p:spPr>
+          <a:xfrm>
+            <a:off x="1371600" y="4160520"/>
+            <a:ext cx="4206240" cy="420624"/>
           </a:xfrm>
           <a:prstGeom prst="rect">
             <a:avLst/>
@@ -2415,46 +2753,7 @@
               <a:buNone/>
             </a:pPr>
             <a:r>
-              <a:rPr lang="en-US" sz="1100" b="1" dirty="0">
-                <a:solidFill>
-                  <a:srgbClr val="E8A33D"/>
-                </a:solidFill>
-                <a:latin typeface="Arial" pitchFamily="34" charset="0"/>
-                <a:ea typeface="Arial" pitchFamily="34" charset="-122"/>
-                <a:cs typeface="Arial" pitchFamily="34" charset="-120"/>
-              </a:rPr>
-              <a:t>1</a:t>
-            </a:r>
-            <a:endParaRPr lang="en-US" sz="1100" dirty="0"/>
-          </a:p>
-        </p:txBody>
-      </p:sp>
-      <p:sp>
-        <p:nvSpPr>
-          <p:cNvPr id="22" name="Text 20"/>
-          <p:cNvSpPr/>
-          <p:nvPr/>
-        </p:nvSpPr>
-        <p:spPr>
-          <a:xfrm>
-            <a:off x="5394960" y="1371600"/>
-            <a:ext cx="1417320" cy="566928"/>
-          </a:xfrm>
-          <a:prstGeom prst="rect">
-            <a:avLst/>
-          </a:prstGeom>
-          <a:noFill/>
-          <a:ln/>
-        </p:spPr>
-        <p:txBody>
-          <a:bodyPr wrap="square" lIns="0" tIns="0" rIns="0" bIns="0" rtlCol="0" anchor="ctr"/>
-          <a:lstStyle/>
-          <a:p>
-            <a:pPr algn="ctr" indent="0" marL="0">
-              <a:buNone/>
-            </a:pPr>
-            <a:r>
-              <a:rPr lang="en-US" sz="1250" b="1" dirty="0">
+              <a:rPr lang="en-US" sz="1500" b="1" dirty="0">
                 <a:solidFill>
                   <a:srgbClr val="1E2761"/>
                 </a:solidFill>
@@ -2462,479 +2761,9 @@
                 <a:ea typeface="Arial" pitchFamily="34" charset="-122"/>
                 <a:cs typeface="Arial" pitchFamily="34" charset="-120"/>
               </a:rPr>
-              <a:t>PicoBinner</a:t>
-            </a:r>
-            <a:endParaRPr lang="en-US" sz="1250" dirty="0"/>
-          </a:p>
-        </p:txBody>
-      </p:sp>
-      <p:sp>
-        <p:nvSpPr>
-          <p:cNvPr id="23" name="Text 21"/>
-          <p:cNvSpPr/>
-          <p:nvPr/>
-        </p:nvSpPr>
-        <p:spPr>
-          <a:xfrm>
-            <a:off x="5966460" y="1920240"/>
-            <a:ext cx="274320" cy="173736"/>
-          </a:xfrm>
-          <a:prstGeom prst="rect">
-            <a:avLst/>
-          </a:prstGeom>
-          <a:noFill/>
-          <a:ln/>
-        </p:spPr>
-        <p:txBody>
-          <a:bodyPr wrap="square" lIns="0" tIns="0" rIns="0" bIns="0" rtlCol="0" anchor="ctr"/>
-          <a:lstStyle/>
-          <a:p>
-            <a:pPr algn="ctr" indent="0" marL="0">
-              <a:buNone/>
-            </a:pPr>
-            <a:r>
-              <a:rPr lang="en-US" sz="1100" dirty="0">
-                <a:solidFill>
-                  <a:srgbClr val="1E2761"/>
-                </a:solidFill>
-                <a:latin typeface="Arial" pitchFamily="34" charset="0"/>
-                <a:ea typeface="Arial" pitchFamily="34" charset="-122"/>
-                <a:cs typeface="Arial" pitchFamily="34" charset="-120"/>
-              </a:rPr>
-              <a:t>▼</a:t>
-            </a:r>
-            <a:endParaRPr lang="en-US" sz="1100" dirty="0"/>
-          </a:p>
-        </p:txBody>
-      </p:sp>
-      <p:sp>
-        <p:nvSpPr>
-          <p:cNvPr id="24" name="Shape 22"/>
-          <p:cNvSpPr/>
-          <p:nvPr/>
-        </p:nvSpPr>
-        <p:spPr>
-          <a:xfrm>
-            <a:off x="5349240" y="2066544"/>
-            <a:ext cx="1508760" cy="566928"/>
-          </a:xfrm>
-          <a:prstGeom prst="roundRect">
-            <a:avLst>
-              <a:gd name="adj" fmla="val 12903"/>
-            </a:avLst>
-          </a:prstGeom>
-          <a:solidFill>
-            <a:srgbClr val="CADCFC"/>
-          </a:solidFill>
-          <a:ln w="12700">
-            <a:solidFill>
-              <a:srgbClr val="1E2761"/>
-            </a:solidFill>
-            <a:prstDash val="solid"/>
-          </a:ln>
-          <a:effectLst>
-            <a:outerShdw sx="100000" sy="100000" kx="0" ky="0" algn="bl" rotWithShape="0" blurRad="50800" dist="12700" dir="2700000">
-              <a:srgbClr val="000000">
-                <a:alpha val="12000"/>
-              </a:srgbClr>
-            </a:outerShdw>
-          </a:effectLst>
-        </p:spPr>
-      </p:sp>
-      <p:sp>
-        <p:nvSpPr>
-          <p:cNvPr id="25" name="Text 23"/>
-          <p:cNvSpPr/>
-          <p:nvPr/>
-        </p:nvSpPr>
-        <p:spPr>
-          <a:xfrm>
-            <a:off x="5404104" y="2103120"/>
-            <a:ext cx="320040" cy="274320"/>
-          </a:xfrm>
-          <a:prstGeom prst="rect">
-            <a:avLst/>
-          </a:prstGeom>
-          <a:noFill/>
-          <a:ln/>
-        </p:spPr>
-        <p:txBody>
-          <a:bodyPr wrap="square" lIns="0" tIns="0" rIns="0" bIns="0" rtlCol="0" anchor="ctr"/>
-          <a:lstStyle/>
-          <a:p>
-            <a:pPr indent="0" marL="0">
-              <a:buNone/>
-            </a:pPr>
-            <a:r>
-              <a:rPr lang="en-US" sz="1100" b="1" dirty="0">
-                <a:solidFill>
-                  <a:srgbClr val="E8A33D"/>
-                </a:solidFill>
-                <a:latin typeface="Arial" pitchFamily="34" charset="0"/>
-                <a:ea typeface="Arial" pitchFamily="34" charset="-122"/>
-                <a:cs typeface="Arial" pitchFamily="34" charset="-120"/>
-              </a:rPr>
-              <a:t>2</a:t>
-            </a:r>
-            <a:endParaRPr lang="en-US" sz="1100" dirty="0"/>
-          </a:p>
-        </p:txBody>
-      </p:sp>
-      <p:sp>
-        <p:nvSpPr>
-          <p:cNvPr id="26" name="Text 24"/>
-          <p:cNvSpPr/>
-          <p:nvPr/>
-        </p:nvSpPr>
-        <p:spPr>
-          <a:xfrm>
-            <a:off x="5394960" y="2066544"/>
-            <a:ext cx="1417320" cy="566928"/>
-          </a:xfrm>
-          <a:prstGeom prst="rect">
-            <a:avLst/>
-          </a:prstGeom>
-          <a:noFill/>
-          <a:ln/>
-        </p:spPr>
-        <p:txBody>
-          <a:bodyPr wrap="square" lIns="0" tIns="0" rIns="0" bIns="0" rtlCol="0" anchor="ctr"/>
-          <a:lstStyle/>
-          <a:p>
-            <a:pPr algn="ctr" indent="0" marL="0">
-              <a:buNone/>
-            </a:pPr>
-            <a:r>
-              <a:rPr lang="en-US" sz="1250" b="1" dirty="0">
-                <a:solidFill>
-                  <a:srgbClr val="1E2761"/>
-                </a:solidFill>
-                <a:latin typeface="Arial" pitchFamily="34" charset="0"/>
-                <a:ea typeface="Arial" pitchFamily="34" charset="-122"/>
-                <a:cs typeface="Arial" pitchFamily="34" charset="-120"/>
-              </a:rPr>
-              <a:t>ZFitter</a:t>
-            </a:r>
-            <a:endParaRPr lang="en-US" sz="1250" dirty="0"/>
-          </a:p>
-        </p:txBody>
-      </p:sp>
-      <p:sp>
-        <p:nvSpPr>
-          <p:cNvPr id="27" name="Text 25"/>
-          <p:cNvSpPr/>
-          <p:nvPr/>
-        </p:nvSpPr>
-        <p:spPr>
-          <a:xfrm>
-            <a:off x="5966460" y="2615184"/>
-            <a:ext cx="274320" cy="173736"/>
-          </a:xfrm>
-          <a:prstGeom prst="rect">
-            <a:avLst/>
-          </a:prstGeom>
-          <a:noFill/>
-          <a:ln/>
-        </p:spPr>
-        <p:txBody>
-          <a:bodyPr wrap="square" lIns="0" tIns="0" rIns="0" bIns="0" rtlCol="0" anchor="ctr"/>
-          <a:lstStyle/>
-          <a:p>
-            <a:pPr algn="ctr" indent="0" marL="0">
-              <a:buNone/>
-            </a:pPr>
-            <a:r>
-              <a:rPr lang="en-US" sz="1100" dirty="0">
-                <a:solidFill>
-                  <a:srgbClr val="1E2761"/>
-                </a:solidFill>
-                <a:latin typeface="Arial" pitchFamily="34" charset="0"/>
-                <a:ea typeface="Arial" pitchFamily="34" charset="-122"/>
-                <a:cs typeface="Arial" pitchFamily="34" charset="-120"/>
-              </a:rPr>
-              <a:t>▼</a:t>
-            </a:r>
-            <a:endParaRPr lang="en-US" sz="1100" dirty="0"/>
-          </a:p>
-        </p:txBody>
-      </p:sp>
-      <p:sp>
-        <p:nvSpPr>
-          <p:cNvPr id="28" name="Shape 26"/>
-          <p:cNvSpPr/>
-          <p:nvPr/>
-        </p:nvSpPr>
-        <p:spPr>
-          <a:xfrm>
-            <a:off x="5349240" y="2761488"/>
-            <a:ext cx="1508760" cy="566928"/>
-          </a:xfrm>
-          <a:prstGeom prst="roundRect">
-            <a:avLst>
-              <a:gd name="adj" fmla="val 12903"/>
-            </a:avLst>
-          </a:prstGeom>
-          <a:solidFill>
-            <a:srgbClr val="F3F6FD"/>
-          </a:solidFill>
-          <a:ln w="12700">
-            <a:solidFill>
-              <a:srgbClr val="1E2761"/>
-            </a:solidFill>
-            <a:prstDash val="solid"/>
-          </a:ln>
-          <a:effectLst>
-            <a:outerShdw sx="100000" sy="100000" kx="0" ky="0" algn="bl" rotWithShape="0" blurRad="50800" dist="12700" dir="2700000">
-              <a:srgbClr val="000000">
-                <a:alpha val="12000"/>
-              </a:srgbClr>
-            </a:outerShdw>
-          </a:effectLst>
-        </p:spPr>
-      </p:sp>
-      <p:sp>
-        <p:nvSpPr>
-          <p:cNvPr id="29" name="Text 27"/>
-          <p:cNvSpPr/>
-          <p:nvPr/>
-        </p:nvSpPr>
-        <p:spPr>
-          <a:xfrm>
-            <a:off x="5404104" y="2798064"/>
-            <a:ext cx="320040" cy="274320"/>
-          </a:xfrm>
-          <a:prstGeom prst="rect">
-            <a:avLst/>
-          </a:prstGeom>
-          <a:noFill/>
-          <a:ln/>
-        </p:spPr>
-        <p:txBody>
-          <a:bodyPr wrap="square" lIns="0" tIns="0" rIns="0" bIns="0" rtlCol="0" anchor="ctr"/>
-          <a:lstStyle/>
-          <a:p>
-            <a:pPr indent="0" marL="0">
-              <a:buNone/>
-            </a:pPr>
-            <a:r>
-              <a:rPr lang="en-US" sz="1100" b="1" dirty="0">
-                <a:solidFill>
-                  <a:srgbClr val="E8A33D"/>
-                </a:solidFill>
-                <a:latin typeface="Arial" pitchFamily="34" charset="0"/>
-                <a:ea typeface="Arial" pitchFamily="34" charset="-122"/>
-                <a:cs typeface="Arial" pitchFamily="34" charset="-120"/>
-              </a:rPr>
-              <a:t>3</a:t>
-            </a:r>
-            <a:endParaRPr lang="en-US" sz="1100" dirty="0"/>
-          </a:p>
-        </p:txBody>
-      </p:sp>
-      <p:sp>
-        <p:nvSpPr>
-          <p:cNvPr id="30" name="Text 28"/>
-          <p:cNvSpPr/>
-          <p:nvPr/>
-        </p:nvSpPr>
-        <p:spPr>
-          <a:xfrm>
-            <a:off x="5394960" y="2761488"/>
-            <a:ext cx="1417320" cy="566928"/>
-          </a:xfrm>
-          <a:prstGeom prst="rect">
-            <a:avLst/>
-          </a:prstGeom>
-          <a:noFill/>
-          <a:ln/>
-        </p:spPr>
-        <p:txBody>
-          <a:bodyPr wrap="square" lIns="0" tIns="0" rIns="0" bIns="0" rtlCol="0" anchor="ctr"/>
-          <a:lstStyle/>
-          <a:p>
-            <a:pPr algn="ctr" indent="0" marL="0">
-              <a:buNone/>
-            </a:pPr>
-            <a:r>
-              <a:rPr lang="en-US" sz="1250" b="1" dirty="0">
-                <a:solidFill>
-                  <a:srgbClr val="1E2761"/>
-                </a:solidFill>
-                <a:latin typeface="Arial" pitchFamily="34" charset="0"/>
-                <a:ea typeface="Arial" pitchFamily="34" charset="-122"/>
-                <a:cs typeface="Arial" pitchFamily="34" charset="-120"/>
-              </a:rPr>
-              <a:t>RawSpectra</a:t>
-            </a:r>
-            <a:endParaRPr lang="en-US" sz="1250" dirty="0"/>
-          </a:p>
-          <a:p>
-            <a:pPr algn="ctr" indent="0" marL="0">
-              <a:buNone/>
-            </a:pPr>
-            <a:r>
-              <a:rPr lang="en-US" sz="1250" b="1" dirty="0">
-                <a:solidFill>
-                  <a:srgbClr val="1E2761"/>
-                </a:solidFill>
-                <a:latin typeface="Arial" pitchFamily="34" charset="0"/>
-                <a:ea typeface="Arial" pitchFamily="34" charset="-122"/>
-                <a:cs typeface="Arial" pitchFamily="34" charset="-120"/>
-              </a:rPr>
-              <a:t>Modifier</a:t>
-            </a:r>
-            <a:endParaRPr lang="en-US" sz="1250" dirty="0"/>
-          </a:p>
-        </p:txBody>
-      </p:sp>
-      <p:sp>
-        <p:nvSpPr>
-          <p:cNvPr id="31" name="Text 29"/>
-          <p:cNvSpPr/>
-          <p:nvPr/>
-        </p:nvSpPr>
-        <p:spPr>
-          <a:xfrm>
-            <a:off x="5966460" y="3310128"/>
-            <a:ext cx="274320" cy="173736"/>
-          </a:xfrm>
-          <a:prstGeom prst="rect">
-            <a:avLst/>
-          </a:prstGeom>
-          <a:noFill/>
-          <a:ln/>
-        </p:spPr>
-        <p:txBody>
-          <a:bodyPr wrap="square" lIns="0" tIns="0" rIns="0" bIns="0" rtlCol="0" anchor="ctr"/>
-          <a:lstStyle/>
-          <a:p>
-            <a:pPr algn="ctr" indent="0" marL="0">
-              <a:buNone/>
-            </a:pPr>
-            <a:r>
-              <a:rPr lang="en-US" sz="1100" dirty="0">
-                <a:solidFill>
-                  <a:srgbClr val="1E2761"/>
-                </a:solidFill>
-                <a:latin typeface="Arial" pitchFamily="34" charset="0"/>
-                <a:ea typeface="Arial" pitchFamily="34" charset="-122"/>
-                <a:cs typeface="Arial" pitchFamily="34" charset="-120"/>
-              </a:rPr>
-              <a:t>▼</a:t>
-            </a:r>
-            <a:endParaRPr lang="en-US" sz="1100" dirty="0"/>
-          </a:p>
-        </p:txBody>
-      </p:sp>
-      <p:sp>
-        <p:nvSpPr>
-          <p:cNvPr id="32" name="Shape 30"/>
-          <p:cNvSpPr/>
-          <p:nvPr/>
-        </p:nvSpPr>
-        <p:spPr>
-          <a:xfrm>
-            <a:off x="5349240" y="3456432"/>
-            <a:ext cx="1508760" cy="566928"/>
-          </a:xfrm>
-          <a:prstGeom prst="roundRect">
-            <a:avLst>
-              <a:gd name="adj" fmla="val 12903"/>
-            </a:avLst>
-          </a:prstGeom>
-          <a:solidFill>
-            <a:srgbClr val="CADCFC"/>
-          </a:solidFill>
-          <a:ln w="12700">
-            <a:solidFill>
-              <a:srgbClr val="1E2761"/>
-            </a:solidFill>
-            <a:prstDash val="solid"/>
-          </a:ln>
-          <a:effectLst>
-            <a:outerShdw sx="100000" sy="100000" kx="0" ky="0" algn="bl" rotWithShape="0" blurRad="50800" dist="12700" dir="2700000">
-              <a:srgbClr val="000000">
-                <a:alpha val="12000"/>
-              </a:srgbClr>
-            </a:outerShdw>
-          </a:effectLst>
-        </p:spPr>
-      </p:sp>
-      <p:sp>
-        <p:nvSpPr>
-          <p:cNvPr id="33" name="Text 31"/>
-          <p:cNvSpPr/>
-          <p:nvPr/>
-        </p:nvSpPr>
-        <p:spPr>
-          <a:xfrm>
-            <a:off x="5404104" y="3493008"/>
-            <a:ext cx="320040" cy="274320"/>
-          </a:xfrm>
-          <a:prstGeom prst="rect">
-            <a:avLst/>
-          </a:prstGeom>
-          <a:noFill/>
-          <a:ln/>
-        </p:spPr>
-        <p:txBody>
-          <a:bodyPr wrap="square" lIns="0" tIns="0" rIns="0" bIns="0" rtlCol="0" anchor="ctr"/>
-          <a:lstStyle/>
-          <a:p>
-            <a:pPr indent="0" marL="0">
-              <a:buNone/>
-            </a:pPr>
-            <a:r>
-              <a:rPr lang="en-US" sz="1100" b="1" dirty="0">
-                <a:solidFill>
-                  <a:srgbClr val="E8A33D"/>
-                </a:solidFill>
-                <a:latin typeface="Arial" pitchFamily="34" charset="0"/>
-                <a:ea typeface="Arial" pitchFamily="34" charset="-122"/>
-                <a:cs typeface="Arial" pitchFamily="34" charset="-120"/>
-              </a:rPr>
-              <a:t>4</a:t>
-            </a:r>
-            <a:endParaRPr lang="en-US" sz="1100" dirty="0"/>
-          </a:p>
-        </p:txBody>
-      </p:sp>
-      <p:sp>
-        <p:nvSpPr>
-          <p:cNvPr id="34" name="Text 32"/>
-          <p:cNvSpPr/>
-          <p:nvPr/>
-        </p:nvSpPr>
-        <p:spPr>
-          <a:xfrm>
-            <a:off x="5394960" y="3456432"/>
-            <a:ext cx="1417320" cy="566928"/>
-          </a:xfrm>
-          <a:prstGeom prst="rect">
-            <a:avLst/>
-          </a:prstGeom>
-          <a:noFill/>
-          <a:ln/>
-        </p:spPr>
-        <p:txBody>
-          <a:bodyPr wrap="square" lIns="0" tIns="0" rIns="0" bIns="0" rtlCol="0" anchor="ctr"/>
-          <a:lstStyle/>
-          <a:p>
-            <a:pPr algn="ctr" indent="0" marL="0">
-              <a:buNone/>
-            </a:pPr>
-            <a:r>
-              <a:rPr lang="en-US" sz="1250" b="1" dirty="0">
-                <a:solidFill>
-                  <a:srgbClr val="1E2761"/>
-                </a:solidFill>
-                <a:latin typeface="Arial" pitchFamily="34" charset="0"/>
-                <a:ea typeface="Arial" pitchFamily="34" charset="-122"/>
-                <a:cs typeface="Arial" pitchFamily="34" charset="-120"/>
-              </a:rPr>
-              <a:t>SpectraFitter</a:t>
-            </a:r>
-            <a:endParaRPr lang="en-US" sz="1250" dirty="0"/>
+              <a:t>Summary &amp; Next Steps</a:t>
+            </a:r>
+            <a:endParaRPr lang="en-US" sz="1500" dirty="0"/>
           </a:p>
         </p:txBody>
       </p:sp>
@@ -2946,24 +2775,24 @@
         </p:nvSpPr>
         <p:spPr>
           <a:xfrm>
-            <a:off x="5212080" y="4197096"/>
-            <a:ext cx="3291840" cy="365760"/>
-          </a:xfrm>
-          <a:prstGeom prst="rect">
-            <a:avLst/>
-          </a:prstGeom>
-          <a:noFill/>
-          <a:ln/>
-        </p:spPr>
-        <p:txBody>
-          <a:bodyPr wrap="square" lIns="0" tIns="0" rIns="0" bIns="0" rtlCol="0" anchor="ctr"/>
-          <a:lstStyle/>
-          <a:p>
-            <a:pPr indent="0" marL="0">
-              <a:buNone/>
-            </a:pPr>
-            <a:r>
-              <a:rPr lang="en-US" sz="1050" i="1" dirty="0">
+            <a:off x="5669280" y="4160520"/>
+            <a:ext cx="2788920" cy="420624"/>
+          </a:xfrm>
+          <a:prstGeom prst="rect">
+            <a:avLst/>
+          </a:prstGeom>
+          <a:noFill/>
+          <a:ln/>
+        </p:spPr>
+        <p:txBody>
+          <a:bodyPr wrap="square" lIns="0" tIns="0" rIns="0" bIns="0" rtlCol="0" anchor="ctr"/>
+          <a:lstStyle/>
+          <a:p>
+            <a:pPr algn="r" indent="0" marL="0">
+              <a:buNone/>
+            </a:pPr>
+            <a:r>
+              <a:rPr lang="en-US" sz="1150" i="1" dirty="0">
                 <a:solidFill>
                   <a:srgbClr val="5B6382"/>
                 </a:solidFill>
@@ -2971,9 +2800,9 @@
                 <a:ea typeface="Arial" pitchFamily="34" charset="-122"/>
                 <a:cs typeface="Arial" pitchFamily="34" charset="-120"/>
               </a:rPr>
-              <a:t>Stage 1 now runs on SDCC; stages 2–4 run locally on the output.</a:t>
-            </a:r>
-            <a:endParaRPr lang="en-US" sz="1050" dirty="0"/>
+              <a:t>Where this goes from here</a:t>
+            </a:r>
+            <a:endParaRPr lang="en-US" sz="1150" dirty="0"/>
           </a:p>
         </p:txBody>
       </p:sp>

</xml_diff>

<commit_message>
Simplify main slides for a general audience; move technical detail to backup slides
</commit_message>
<xml_diff>
--- a/docs/lightflavorspectra_OO200_Status_Update.pptx
+++ b/docs/lightflavorspectra_OO200_Status_Update.pptx
@@ -13,9 +13,13 @@
     <p:sldId id="261" r:id="rId7"/>
     <p:sldId id="262" r:id="rId8"/>
     <p:sldId id="263" r:id="rId9"/>
+    <p:sldId id="264" r:id="rId10"/>
+    <p:sldId id="265" r:id="rId11"/>
+    <p:sldId id="266" r:id="rId12"/>
+    <p:sldId id="267" r:id="rId13"/>
   </p:sldIdLst>
   <p:notesMasterIdLst>
-    <p:notesMasterId r:id="rId10"/>
+    <p:notesMasterId r:id="rId14"/>
   </p:notesMasterIdLst>
   <p:sldSz cx="9144000" cy="5143500"/>
   <p:notesSz cx="5143500" cy="9144000"/>
@@ -551,6 +555,270 @@
 </p:notes>
 </file>
 
+<file path=ppt/notesSlides/notesSlide10.xml><?xml version="1.0" encoding="utf-8"?>
+<p:notes xmlns:a="http://schemas.openxmlformats.org/drawingml/2006/main" xmlns:r="http://schemas.openxmlformats.org/officeDocument/2006/relationships" xmlns:p="http://schemas.openxmlformats.org/presentationml/2006/main">
+  <p:cSld>
+    <p:spTree>
+      <p:nvGrpSpPr>
+        <p:cNvPr id="1" name=""/>
+        <p:cNvGrpSpPr/>
+        <p:nvPr/>
+      </p:nvGrpSpPr>
+      <p:grpSpPr>
+        <a:xfrm>
+          <a:off x="0" y="0"/>
+          <a:ext cx="0" cy="0"/>
+          <a:chOff x="0" y="0"/>
+          <a:chExt cx="0" cy="0"/>
+        </a:xfrm>
+      </p:grpSpPr>
+      <p:sp>
+        <p:nvSpPr>
+          <p:cNvPr id="2" name="Slide Image Placeholder 1"/>
+          <p:cNvSpPr>
+            <a:spLocks noGrp="1" noRot="1" noChangeAspect="1"/>
+          </p:cNvSpPr>
+          <p:nvPr>
+            <p:ph type="sldImg"/>
+          </p:nvPr>
+        </p:nvSpPr>
+        <p:spPr/>
+      </p:sp>
+      <p:sp>
+        <p:nvSpPr>
+          <p:cNvPr id="3" name="Notes Placeholder 2"/>
+          <p:cNvSpPr>
+            <a:spLocks noGrp="1"/>
+          </p:cNvSpPr>
+          <p:nvPr>
+            <p:ph type="body" idx="1"/>
+          </p:nvPr>
+        </p:nvSpPr>
+        <p:spPr/>
+        <p:txBody>
+          <a:bodyPr/>
+          <a:lstStyle/>
+          <a:p>
+            <a:r>
+              <a:rPr lang="en-US" dirty="0"/>
+              <a:t/>
+            </a:r>
+            <a:endParaRPr lang="en-US" dirty="0"/>
+          </a:p>
+        </p:txBody>
+      </p:sp>
+      <p:sp>
+        <p:nvSpPr>
+          <p:cNvPr id="4" name="Slide Number Placeholder 3"/>
+          <p:cNvSpPr>
+            <a:spLocks noGrp="1"/>
+          </p:cNvSpPr>
+          <p:nvPr>
+            <p:ph type="sldNum" sz="quarter" idx="10"/>
+          </p:nvPr>
+        </p:nvSpPr>
+        <p:spPr/>
+        <p:txBody>
+          <a:bodyPr/>
+          <a:lstStyle/>
+          <a:p>
+            <a:fld id="{F7021451-1387-4CA6-816F-3879F97B5CBC}" type="slidenum">
+              <a:rPr lang="en-US"/>
+              <a:t>10</a:t>
+            </a:fld>
+            <a:endParaRPr lang="en-US"/>
+          </a:p>
+        </p:txBody>
+      </p:sp>
+    </p:spTree>
+    <p:extLst>
+      <p:ext uri="{BB962C8B-B14F-4D97-AF65-F5344CB8AC3E}">
+        <p14:creationId xmlns:p14="http://schemas.microsoft.com/office/powerpoint/2010/main" val="1024086991"/>
+      </p:ext>
+    </p:extLst>
+  </p:cSld>
+  <p:clrMapOvr>
+    <a:masterClrMapping/>
+  </p:clrMapOvr>
+</p:notes>
+</file>
+
+<file path=ppt/notesSlides/notesSlide11.xml><?xml version="1.0" encoding="utf-8"?>
+<p:notes xmlns:a="http://schemas.openxmlformats.org/drawingml/2006/main" xmlns:r="http://schemas.openxmlformats.org/officeDocument/2006/relationships" xmlns:p="http://schemas.openxmlformats.org/presentationml/2006/main">
+  <p:cSld>
+    <p:spTree>
+      <p:nvGrpSpPr>
+        <p:cNvPr id="1" name=""/>
+        <p:cNvGrpSpPr/>
+        <p:nvPr/>
+      </p:nvGrpSpPr>
+      <p:grpSpPr>
+        <a:xfrm>
+          <a:off x="0" y="0"/>
+          <a:ext cx="0" cy="0"/>
+          <a:chOff x="0" y="0"/>
+          <a:chExt cx="0" cy="0"/>
+        </a:xfrm>
+      </p:grpSpPr>
+      <p:sp>
+        <p:nvSpPr>
+          <p:cNvPr id="2" name="Slide Image Placeholder 1"/>
+          <p:cNvSpPr>
+            <a:spLocks noGrp="1" noRot="1" noChangeAspect="1"/>
+          </p:cNvSpPr>
+          <p:nvPr>
+            <p:ph type="sldImg"/>
+          </p:nvPr>
+        </p:nvSpPr>
+        <p:spPr/>
+      </p:sp>
+      <p:sp>
+        <p:nvSpPr>
+          <p:cNvPr id="3" name="Notes Placeholder 2"/>
+          <p:cNvSpPr>
+            <a:spLocks noGrp="1"/>
+          </p:cNvSpPr>
+          <p:nvPr>
+            <p:ph type="body" idx="1"/>
+          </p:nvPr>
+        </p:nvSpPr>
+        <p:spPr/>
+        <p:txBody>
+          <a:bodyPr/>
+          <a:lstStyle/>
+          <a:p>
+            <a:r>
+              <a:rPr lang="en-US" dirty="0"/>
+              <a:t/>
+            </a:r>
+            <a:endParaRPr lang="en-US" dirty="0"/>
+          </a:p>
+        </p:txBody>
+      </p:sp>
+      <p:sp>
+        <p:nvSpPr>
+          <p:cNvPr id="4" name="Slide Number Placeholder 3"/>
+          <p:cNvSpPr>
+            <a:spLocks noGrp="1"/>
+          </p:cNvSpPr>
+          <p:nvPr>
+            <p:ph type="sldNum" sz="quarter" idx="10"/>
+          </p:nvPr>
+        </p:nvSpPr>
+        <p:spPr/>
+        <p:txBody>
+          <a:bodyPr/>
+          <a:lstStyle/>
+          <a:p>
+            <a:fld id="{F7021451-1387-4CA6-816F-3879F97B5CBC}" type="slidenum">
+              <a:rPr lang="en-US"/>
+              <a:t>11</a:t>
+            </a:fld>
+            <a:endParaRPr lang="en-US"/>
+          </a:p>
+        </p:txBody>
+      </p:sp>
+    </p:spTree>
+    <p:extLst>
+      <p:ext uri="{BB962C8B-B14F-4D97-AF65-F5344CB8AC3E}">
+        <p14:creationId xmlns:p14="http://schemas.microsoft.com/office/powerpoint/2010/main" val="1024086991"/>
+      </p:ext>
+    </p:extLst>
+  </p:cSld>
+  <p:clrMapOvr>
+    <a:masterClrMapping/>
+  </p:clrMapOvr>
+</p:notes>
+</file>
+
+<file path=ppt/notesSlides/notesSlide12.xml><?xml version="1.0" encoding="utf-8"?>
+<p:notes xmlns:a="http://schemas.openxmlformats.org/drawingml/2006/main" xmlns:r="http://schemas.openxmlformats.org/officeDocument/2006/relationships" xmlns:p="http://schemas.openxmlformats.org/presentationml/2006/main">
+  <p:cSld>
+    <p:spTree>
+      <p:nvGrpSpPr>
+        <p:cNvPr id="1" name=""/>
+        <p:cNvGrpSpPr/>
+        <p:nvPr/>
+      </p:nvGrpSpPr>
+      <p:grpSpPr>
+        <a:xfrm>
+          <a:off x="0" y="0"/>
+          <a:ext cx="0" cy="0"/>
+          <a:chOff x="0" y="0"/>
+          <a:chExt cx="0" cy="0"/>
+        </a:xfrm>
+      </p:grpSpPr>
+      <p:sp>
+        <p:nvSpPr>
+          <p:cNvPr id="2" name="Slide Image Placeholder 1"/>
+          <p:cNvSpPr>
+            <a:spLocks noGrp="1" noRot="1" noChangeAspect="1"/>
+          </p:cNvSpPr>
+          <p:nvPr>
+            <p:ph type="sldImg"/>
+          </p:nvPr>
+        </p:nvSpPr>
+        <p:spPr/>
+      </p:sp>
+      <p:sp>
+        <p:nvSpPr>
+          <p:cNvPr id="3" name="Notes Placeholder 2"/>
+          <p:cNvSpPr>
+            <a:spLocks noGrp="1"/>
+          </p:cNvSpPr>
+          <p:nvPr>
+            <p:ph type="body" idx="1"/>
+          </p:nvPr>
+        </p:nvSpPr>
+        <p:spPr/>
+        <p:txBody>
+          <a:bodyPr/>
+          <a:lstStyle/>
+          <a:p>
+            <a:r>
+              <a:rPr lang="en-US" dirty="0"/>
+              <a:t/>
+            </a:r>
+            <a:endParaRPr lang="en-US" dirty="0"/>
+          </a:p>
+        </p:txBody>
+      </p:sp>
+      <p:sp>
+        <p:nvSpPr>
+          <p:cNvPr id="4" name="Slide Number Placeholder 3"/>
+          <p:cNvSpPr>
+            <a:spLocks noGrp="1"/>
+          </p:cNvSpPr>
+          <p:nvPr>
+            <p:ph type="sldNum" sz="quarter" idx="10"/>
+          </p:nvPr>
+        </p:nvSpPr>
+        <p:spPr/>
+        <p:txBody>
+          <a:bodyPr/>
+          <a:lstStyle/>
+          <a:p>
+            <a:fld id="{F7021451-1387-4CA6-816F-3879F97B5CBC}" type="slidenum">
+              <a:rPr lang="en-US"/>
+              <a:t>12</a:t>
+            </a:fld>
+            <a:endParaRPr lang="en-US"/>
+          </a:p>
+        </p:txBody>
+      </p:sp>
+    </p:spTree>
+    <p:extLst>
+      <p:ext uri="{BB962C8B-B14F-4D97-AF65-F5344CB8AC3E}">
+        <p14:creationId xmlns:p14="http://schemas.microsoft.com/office/powerpoint/2010/main" val="1024086991"/>
+      </p:ext>
+    </p:extLst>
+  </p:cSld>
+  <p:clrMapOvr>
+    <a:masterClrMapping/>
+  </p:clrMapOvr>
+</p:notes>
+</file>
+
 <file path=ppt/notesSlides/notesSlide2.xml><?xml version="1.0" encoding="utf-8"?>
 <p:notes xmlns:a="http://schemas.openxmlformats.org/drawingml/2006/main" xmlns:r="http://schemas.openxmlformats.org/officeDocument/2006/relationships" xmlns:p="http://schemas.openxmlformats.org/presentationml/2006/main">
   <p:cSld>
@@ -685,7 +953,7 @@
           <a:p>
             <a:r>
               <a:rPr lang="en-US" dirty="0"/>
-              <a:t/>
+              <a:t>Full technical detail (library versions, class-by-class diff, specific fixes) is in the backup slides.</a:t>
             </a:r>
             <a:endParaRPr lang="en-US" dirty="0"/>
           </a:p>
@@ -773,7 +1041,7 @@
           <a:p>
             <a:r>
               <a:rPr lang="en-US" dirty="0"/>
-              <a:t/>
+              <a:t>Technical detail (job submission mechanics, XML config, catalog query) is in the backup slides.</a:t>
             </a:r>
             <a:endParaRPr lang="en-US" dirty="0"/>
           </a:p>
@@ -861,7 +1129,7 @@
           <a:p>
             <a:r>
               <a:rPr lang="en-US" dirty="0"/>
-              <a:t/>
+              <a:t>Full technical detail (CINT/ROOT5 dictionary issues, C++ syntax fixes, specific unimplemented methods) is in the backup slides.</a:t>
             </a:r>
             <a:endParaRPr lang="en-US" dirty="0"/>
           </a:p>
@@ -1149,6 +1417,94 @@
             <a:fld id="{F7021451-1387-4CA6-816F-3879F97B5CBC}" type="slidenum">
               <a:rPr lang="en-US"/>
               <a:t>8</a:t>
+            </a:fld>
+            <a:endParaRPr lang="en-US"/>
+          </a:p>
+        </p:txBody>
+      </p:sp>
+    </p:spTree>
+    <p:extLst>
+      <p:ext uri="{BB962C8B-B14F-4D97-AF65-F5344CB8AC3E}">
+        <p14:creationId xmlns:p14="http://schemas.microsoft.com/office/powerpoint/2010/main" val="1024086991"/>
+      </p:ext>
+    </p:extLst>
+  </p:cSld>
+  <p:clrMapOvr>
+    <a:masterClrMapping/>
+  </p:clrMapOvr>
+</p:notes>
+</file>
+
+<file path=ppt/notesSlides/notesSlide9.xml><?xml version="1.0" encoding="utf-8"?>
+<p:notes xmlns:a="http://schemas.openxmlformats.org/drawingml/2006/main" xmlns:r="http://schemas.openxmlformats.org/officeDocument/2006/relationships" xmlns:p="http://schemas.openxmlformats.org/presentationml/2006/main">
+  <p:cSld>
+    <p:spTree>
+      <p:nvGrpSpPr>
+        <p:cNvPr id="1" name=""/>
+        <p:cNvGrpSpPr/>
+        <p:nvPr/>
+      </p:nvGrpSpPr>
+      <p:grpSpPr>
+        <a:xfrm>
+          <a:off x="0" y="0"/>
+          <a:ext cx="0" cy="0"/>
+          <a:chOff x="0" y="0"/>
+          <a:chExt cx="0" cy="0"/>
+        </a:xfrm>
+      </p:grpSpPr>
+      <p:sp>
+        <p:nvSpPr>
+          <p:cNvPr id="2" name="Slide Image Placeholder 1"/>
+          <p:cNvSpPr>
+            <a:spLocks noGrp="1" noRot="1" noChangeAspect="1"/>
+          </p:cNvSpPr>
+          <p:nvPr>
+            <p:ph type="sldImg"/>
+          </p:nvPr>
+        </p:nvSpPr>
+        <p:spPr/>
+      </p:sp>
+      <p:sp>
+        <p:nvSpPr>
+          <p:cNvPr id="3" name="Notes Placeholder 2"/>
+          <p:cNvSpPr>
+            <a:spLocks noGrp="1"/>
+          </p:cNvSpPr>
+          <p:nvPr>
+            <p:ph type="body" idx="1"/>
+          </p:nvPr>
+        </p:nvSpPr>
+        <p:spPr/>
+        <p:txBody>
+          <a:bodyPr/>
+          <a:lstStyle/>
+          <a:p>
+            <a:r>
+              <a:rPr lang="en-US" dirty="0"/>
+              <a:t/>
+            </a:r>
+            <a:endParaRPr lang="en-US" dirty="0"/>
+          </a:p>
+        </p:txBody>
+      </p:sp>
+      <p:sp>
+        <p:nvSpPr>
+          <p:cNvPr id="4" name="Slide Number Placeholder 3"/>
+          <p:cNvSpPr>
+            <a:spLocks noGrp="1"/>
+          </p:cNvSpPr>
+          <p:nvPr>
+            <p:ph type="sldNum" sz="quarter" idx="10"/>
+          </p:nvPr>
+        </p:nvSpPr>
+        <p:spPr/>
+        <p:txBody>
+          <a:bodyPr/>
+          <a:lstStyle/>
+          <a:p>
+            <a:fld id="{F7021451-1387-4CA6-816F-3879F97B5CBC}" type="slidenum">
+              <a:rPr lang="en-US"/>
+              <a:t>9</a:t>
             </a:fld>
             <a:endParaRPr lang="en-US"/>
           </a:p>
@@ -1706,6 +2062,2347 @@
 </p:sld>
 </file>
 
+<file path=ppt/slides/slide10.xml><?xml version="1.0" encoding="utf-8"?>
+<p:sld xmlns:a="http://schemas.openxmlformats.org/drawingml/2006/main" xmlns:r="http://schemas.openxmlformats.org/officeDocument/2006/relationships" xmlns:p="http://schemas.openxmlformats.org/presentationml/2006/main">
+  <p:cSld name="Slide 10">
+    <p:bg>
+      <p:bgPr>
+        <a:solidFill>
+          <a:srgbClr val="FFFFFF"/>
+        </a:solidFill>
+      </p:bgPr>
+    </p:bg>
+    <p:spTree>
+      <p:nvGrpSpPr>
+        <p:cNvPr id="1" name=""/>
+        <p:cNvGrpSpPr/>
+        <p:nvPr/>
+      </p:nvGrpSpPr>
+      <p:grpSpPr>
+        <a:xfrm>
+          <a:off x="0" y="0"/>
+          <a:ext cx="0" cy="0"/>
+          <a:chOff x="0" y="0"/>
+          <a:chExt cx="0" cy="0"/>
+        </a:xfrm>
+      </p:grpSpPr>
+      <p:sp>
+        <p:nvSpPr>
+          <p:cNvPr id="2" name="Text 0"/>
+          <p:cNvSpPr/>
+          <p:nvPr/>
+        </p:nvSpPr>
+        <p:spPr>
+          <a:xfrm>
+            <a:off x="457200" y="320040"/>
+            <a:ext cx="8229600" cy="274320"/>
+          </a:xfrm>
+          <a:prstGeom prst="rect">
+            <a:avLst/>
+          </a:prstGeom>
+          <a:noFill/>
+          <a:ln/>
+        </p:spPr>
+        <p:txBody>
+          <a:bodyPr wrap="square" lIns="0" tIns="0" rIns="0" bIns="0" rtlCol="0" anchor="ctr"/>
+          <a:lstStyle/>
+          <a:p>
+            <a:pPr indent="0" marL="0">
+              <a:buNone/>
+            </a:pPr>
+            <a:r>
+              <a:rPr lang="en-US" sz="1200" b="1" spc="200" kern="0" dirty="0">
+                <a:solidFill>
+                  <a:srgbClr val="E8A33D"/>
+                </a:solidFill>
+                <a:latin typeface="Arial" pitchFamily="34" charset="0"/>
+                <a:ea typeface="Arial" pitchFamily="34" charset="-122"/>
+                <a:cs typeface="Arial" pitchFamily="34" charset="-120"/>
+              </a:rPr>
+              <a:t>BACKUP</a:t>
+            </a:r>
+            <a:endParaRPr lang="en-US" sz="1200" dirty="0"/>
+          </a:p>
+        </p:txBody>
+      </p:sp>
+      <p:sp>
+        <p:nvSpPr>
+          <p:cNvPr id="3" name="Text 1"/>
+          <p:cNvSpPr/>
+          <p:nvPr/>
+        </p:nvSpPr>
+        <p:spPr>
+          <a:xfrm>
+            <a:off x="457200" y="566928"/>
+            <a:ext cx="8229600" cy="640080"/>
+          </a:xfrm>
+          <a:prstGeom prst="rect">
+            <a:avLst/>
+          </a:prstGeom>
+          <a:noFill/>
+          <a:ln/>
+        </p:spPr>
+        <p:txBody>
+          <a:bodyPr wrap="square" lIns="0" tIns="0" rIns="0" bIns="0" rtlCol="0" anchor="ctr"/>
+          <a:lstStyle/>
+          <a:p>
+            <a:pPr indent="0" marL="0">
+              <a:buNone/>
+            </a:pPr>
+            <a:r>
+              <a:rPr lang="en-US" sz="3000" b="1" dirty="0">
+                <a:solidFill>
+                  <a:srgbClr val="1E2761"/>
+                </a:solidFill>
+                <a:latin typeface="Arial" pitchFamily="34" charset="0"/>
+                <a:ea typeface="Arial" pitchFamily="34" charset="-122"/>
+                <a:cs typeface="Arial" pitchFamily="34" charset="-120"/>
+              </a:rPr>
+              <a:t>PicoDst Reader Migration -- Detail</a:t>
+            </a:r>
+            <a:endParaRPr lang="en-US" sz="3000" dirty="0"/>
+          </a:p>
+        </p:txBody>
+      </p:sp>
+      <p:sp>
+        <p:nvSpPr>
+          <p:cNvPr id="4" name="Shape 2"/>
+          <p:cNvSpPr/>
+          <p:nvPr/>
+        </p:nvSpPr>
+        <p:spPr>
+          <a:xfrm>
+            <a:off x="502920" y="1417320"/>
+            <a:ext cx="2331720" cy="1234440"/>
+          </a:xfrm>
+          <a:prstGeom prst="roundRect">
+            <a:avLst>
+              <a:gd name="adj" fmla="val 5926"/>
+            </a:avLst>
+          </a:prstGeom>
+          <a:solidFill>
+            <a:srgbClr val="F3F6FD"/>
+          </a:solidFill>
+          <a:ln/>
+        </p:spPr>
+      </p:sp>
+      <p:sp>
+        <p:nvSpPr>
+          <p:cNvPr id="5" name="Text 3"/>
+          <p:cNvSpPr/>
+          <p:nvPr/>
+        </p:nvSpPr>
+        <p:spPr>
+          <a:xfrm>
+            <a:off x="685800" y="1545336"/>
+            <a:ext cx="1965960" cy="256032"/>
+          </a:xfrm>
+          <a:prstGeom prst="rect">
+            <a:avLst/>
+          </a:prstGeom>
+          <a:noFill/>
+          <a:ln/>
+        </p:spPr>
+        <p:txBody>
+          <a:bodyPr wrap="square" lIns="0" tIns="0" rIns="0" bIns="0" rtlCol="0" anchor="ctr"/>
+          <a:lstStyle/>
+          <a:p>
+            <a:pPr indent="0" marL="0">
+              <a:buNone/>
+            </a:pPr>
+            <a:r>
+              <a:rPr lang="en-US" sz="1100" b="1" spc="150" kern="0" dirty="0">
+                <a:solidFill>
+                  <a:srgbClr val="5B6382"/>
+                </a:solidFill>
+                <a:latin typeface="Arial" pitchFamily="34" charset="0"/>
+                <a:ea typeface="Arial" pitchFamily="34" charset="-122"/>
+                <a:cs typeface="Arial" pitchFamily="34" charset="-120"/>
+              </a:rPr>
+              <a:t>BEFORE</a:t>
+            </a:r>
+            <a:endParaRPr lang="en-US" sz="1100" dirty="0"/>
+          </a:p>
+        </p:txBody>
+      </p:sp>
+      <p:sp>
+        <p:nvSpPr>
+          <p:cNvPr id="6" name="Text 4"/>
+          <p:cNvSpPr/>
+          <p:nvPr/>
+        </p:nvSpPr>
+        <p:spPr>
+          <a:xfrm>
+            <a:off x="685800" y="1801368"/>
+            <a:ext cx="1965960" cy="457200"/>
+          </a:xfrm>
+          <a:prstGeom prst="rect">
+            <a:avLst/>
+          </a:prstGeom>
+          <a:noFill/>
+          <a:ln/>
+        </p:spPr>
+        <p:txBody>
+          <a:bodyPr wrap="square" lIns="0" tIns="0" rIns="0" bIns="0" rtlCol="0" anchor="ctr"/>
+          <a:lstStyle/>
+          <a:p>
+            <a:pPr indent="0" marL="0">
+              <a:buNone/>
+            </a:pPr>
+            <a:r>
+              <a:rPr lang="en-US" sz="2600" b="1" dirty="0">
+                <a:solidFill>
+                  <a:srgbClr val="1E2761"/>
+                </a:solidFill>
+                <a:latin typeface="Arial" pitchFamily="34" charset="0"/>
+                <a:ea typeface="Arial" pitchFamily="34" charset="-122"/>
+                <a:cs typeface="Arial" pitchFamily="34" charset="-120"/>
+              </a:rPr>
+              <a:t>SL23a</a:t>
+            </a:r>
+            <a:endParaRPr lang="en-US" sz="2600" dirty="0"/>
+          </a:p>
+        </p:txBody>
+      </p:sp>
+      <p:sp>
+        <p:nvSpPr>
+          <p:cNvPr id="7" name="Text 5"/>
+          <p:cNvSpPr/>
+          <p:nvPr/>
+        </p:nvSpPr>
+        <p:spPr>
+          <a:xfrm>
+            <a:off x="685800" y="2286000"/>
+            <a:ext cx="1965960" cy="365760"/>
+          </a:xfrm>
+          <a:prstGeom prst="rect">
+            <a:avLst/>
+          </a:prstGeom>
+          <a:noFill/>
+          <a:ln/>
+        </p:spPr>
+        <p:txBody>
+          <a:bodyPr wrap="square" lIns="0" tIns="0" rIns="0" bIns="0" rtlCol="0" anchor="ctr"/>
+          <a:lstStyle/>
+          <a:p>
+            <a:pPr indent="0" marL="0">
+              <a:buNone/>
+            </a:pPr>
+            <a:r>
+              <a:rPr lang="en-US" sz="1050" dirty="0">
+                <a:solidFill>
+                  <a:srgbClr val="5B6382"/>
+                </a:solidFill>
+                <a:latin typeface="Arial" pitchFamily="34" charset="0"/>
+                <a:ea typeface="Arial" pitchFamily="34" charset="-122"/>
+                <a:cs typeface="Arial" pitchFamily="34" charset="-120"/>
+              </a:rPr>
+              <a:t>Carried over from a different-energy analysis</a:t>
+            </a:r>
+            <a:endParaRPr lang="en-US" sz="1050" dirty="0"/>
+          </a:p>
+        </p:txBody>
+      </p:sp>
+      <p:sp>
+        <p:nvSpPr>
+          <p:cNvPr id="8" name="Text 6"/>
+          <p:cNvSpPr/>
+          <p:nvPr/>
+        </p:nvSpPr>
+        <p:spPr>
+          <a:xfrm>
+            <a:off x="2926080" y="1783080"/>
+            <a:ext cx="457200" cy="548640"/>
+          </a:xfrm>
+          <a:prstGeom prst="rect">
+            <a:avLst/>
+          </a:prstGeom>
+          <a:noFill/>
+          <a:ln/>
+        </p:spPr>
+        <p:txBody>
+          <a:bodyPr wrap="square" lIns="0" tIns="0" rIns="0" bIns="0" rtlCol="0" anchor="ctr"/>
+          <a:lstStyle/>
+          <a:p>
+            <a:pPr algn="ctr" indent="0" marL="0">
+              <a:buNone/>
+            </a:pPr>
+            <a:r>
+              <a:rPr lang="en-US" sz="2800" b="1" dirty="0">
+                <a:solidFill>
+                  <a:srgbClr val="E8A33D"/>
+                </a:solidFill>
+                <a:latin typeface="Arial" pitchFamily="34" charset="0"/>
+                <a:ea typeface="Arial" pitchFamily="34" charset="-122"/>
+                <a:cs typeface="Arial" pitchFamily="34" charset="-120"/>
+              </a:rPr>
+              <a:t>→</a:t>
+            </a:r>
+            <a:endParaRPr lang="en-US" sz="2800" dirty="0"/>
+          </a:p>
+        </p:txBody>
+      </p:sp>
+      <p:sp>
+        <p:nvSpPr>
+          <p:cNvPr id="9" name="Shape 7"/>
+          <p:cNvSpPr/>
+          <p:nvPr/>
+        </p:nvSpPr>
+        <p:spPr>
+          <a:xfrm>
+            <a:off x="3474720" y="1417320"/>
+            <a:ext cx="2331720" cy="1234440"/>
+          </a:xfrm>
+          <a:prstGeom prst="roundRect">
+            <a:avLst>
+              <a:gd name="adj" fmla="val 5926"/>
+            </a:avLst>
+          </a:prstGeom>
+          <a:solidFill>
+            <a:srgbClr val="1E2761"/>
+          </a:solidFill>
+          <a:ln/>
+          <a:effectLst>
+            <a:outerShdw sx="100000" sy="100000" kx="0" ky="0" algn="bl" rotWithShape="0" blurRad="63500" dist="25400" dir="2700000">
+              <a:srgbClr val="000000">
+                <a:alpha val="18000"/>
+              </a:srgbClr>
+            </a:outerShdw>
+          </a:effectLst>
+        </p:spPr>
+      </p:sp>
+      <p:sp>
+        <p:nvSpPr>
+          <p:cNvPr id="10" name="Text 8"/>
+          <p:cNvSpPr/>
+          <p:nvPr/>
+        </p:nvSpPr>
+        <p:spPr>
+          <a:xfrm>
+            <a:off x="3657600" y="1545336"/>
+            <a:ext cx="1965960" cy="256032"/>
+          </a:xfrm>
+          <a:prstGeom prst="rect">
+            <a:avLst/>
+          </a:prstGeom>
+          <a:noFill/>
+          <a:ln/>
+        </p:spPr>
+        <p:txBody>
+          <a:bodyPr wrap="square" lIns="0" tIns="0" rIns="0" bIns="0" rtlCol="0" anchor="ctr"/>
+          <a:lstStyle/>
+          <a:p>
+            <a:pPr indent="0" marL="0">
+              <a:buNone/>
+            </a:pPr>
+            <a:r>
+              <a:rPr lang="en-US" sz="1100" b="1" spc="150" kern="0" dirty="0">
+                <a:solidFill>
+                  <a:srgbClr val="CADCFC"/>
+                </a:solidFill>
+                <a:latin typeface="Arial" pitchFamily="34" charset="0"/>
+                <a:ea typeface="Arial" pitchFamily="34" charset="-122"/>
+                <a:cs typeface="Arial" pitchFamily="34" charset="-120"/>
+              </a:rPr>
+              <a:t>AFTER</a:t>
+            </a:r>
+            <a:endParaRPr lang="en-US" sz="1100" dirty="0"/>
+          </a:p>
+        </p:txBody>
+      </p:sp>
+      <p:sp>
+        <p:nvSpPr>
+          <p:cNvPr id="11" name="Text 9"/>
+          <p:cNvSpPr/>
+          <p:nvPr/>
+        </p:nvSpPr>
+        <p:spPr>
+          <a:xfrm>
+            <a:off x="3657600" y="1801368"/>
+            <a:ext cx="1965960" cy="457200"/>
+          </a:xfrm>
+          <a:prstGeom prst="rect">
+            <a:avLst/>
+          </a:prstGeom>
+          <a:noFill/>
+          <a:ln/>
+        </p:spPr>
+        <p:txBody>
+          <a:bodyPr wrap="square" lIns="0" tIns="0" rIns="0" bIns="0" rtlCol="0" anchor="ctr"/>
+          <a:lstStyle/>
+          <a:p>
+            <a:pPr indent="0" marL="0">
+              <a:buNone/>
+            </a:pPr>
+            <a:r>
+              <a:rPr lang="en-US" sz="2600" b="1" dirty="0">
+                <a:solidFill>
+                  <a:srgbClr val="FFFFFF"/>
+                </a:solidFill>
+                <a:latin typeface="Arial" pitchFamily="34" charset="0"/>
+                <a:ea typeface="Arial" pitchFamily="34" charset="-122"/>
+                <a:cs typeface="Arial" pitchFamily="34" charset="-120"/>
+              </a:rPr>
+              <a:t>SL24y</a:t>
+            </a:r>
+            <a:endParaRPr lang="en-US" sz="2600" dirty="0"/>
+          </a:p>
+        </p:txBody>
+      </p:sp>
+      <p:sp>
+        <p:nvSpPr>
+          <p:cNvPr id="12" name="Text 10"/>
+          <p:cNvSpPr/>
+          <p:nvPr/>
+        </p:nvSpPr>
+        <p:spPr>
+          <a:xfrm>
+            <a:off x="3657600" y="2286000"/>
+            <a:ext cx="1965960" cy="365760"/>
+          </a:xfrm>
+          <a:prstGeom prst="rect">
+            <a:avLst/>
+          </a:prstGeom>
+          <a:noFill/>
+          <a:ln/>
+        </p:spPr>
+        <p:txBody>
+          <a:bodyPr wrap="square" lIns="0" tIns="0" rIns="0" bIns="0" rtlCol="0" anchor="ctr"/>
+          <a:lstStyle/>
+          <a:p>
+            <a:pPr indent="0" marL="0">
+              <a:buNone/>
+            </a:pPr>
+            <a:r>
+              <a:rPr lang="en-US" sz="1050" dirty="0">
+                <a:solidFill>
+                  <a:srgbClr val="CADCFC"/>
+                </a:solidFill>
+                <a:latin typeface="Arial" pitchFamily="34" charset="0"/>
+                <a:ea typeface="Arial" pitchFamily="34" charset="-122"/>
+                <a:cs typeface="Arial" pitchFamily="34" charset="-120"/>
+              </a:rPr>
+              <a:t>Matches the real production dataset's library</a:t>
+            </a:r>
+            <a:endParaRPr lang="en-US" sz="1050" dirty="0"/>
+          </a:p>
+        </p:txBody>
+      </p:sp>
+      <p:sp>
+        <p:nvSpPr>
+          <p:cNvPr id="13" name="Shape 11"/>
+          <p:cNvSpPr/>
+          <p:nvPr/>
+        </p:nvSpPr>
+        <p:spPr>
+          <a:xfrm>
+            <a:off x="7223760" y="1463040"/>
+            <a:ext cx="1005840" cy="1005840"/>
+          </a:xfrm>
+          <a:prstGeom prst="ellipse">
+            <a:avLst/>
+          </a:prstGeom>
+          <a:solidFill>
+            <a:srgbClr val="CADCFC">
+              <a:alpha val="45000"/>
+            </a:srgbClr>
+          </a:solidFill>
+          <a:ln/>
+        </p:spPr>
+      </p:sp>
+      <p:sp>
+        <p:nvSpPr>
+          <p:cNvPr id="14" name="Shape 12"/>
+          <p:cNvSpPr/>
+          <p:nvPr/>
+        </p:nvSpPr>
+        <p:spPr>
+          <a:xfrm>
+            <a:off x="7646213" y="1583741"/>
+            <a:ext cx="1005840" cy="1005840"/>
+          </a:xfrm>
+          <a:prstGeom prst="ellipse">
+            <a:avLst/>
+          </a:prstGeom>
+          <a:solidFill>
+            <a:srgbClr val="E8A33D">
+              <a:alpha val="45000"/>
+            </a:srgbClr>
+          </a:solidFill>
+          <a:ln/>
+        </p:spPr>
+      </p:sp>
+      <p:sp>
+        <p:nvSpPr>
+          <p:cNvPr id="15" name="Shape 13"/>
+          <p:cNvSpPr/>
+          <p:nvPr/>
+        </p:nvSpPr>
+        <p:spPr>
+          <a:xfrm>
+            <a:off x="502920" y="2880360"/>
+            <a:ext cx="329184" cy="329184"/>
+          </a:xfrm>
+          <a:prstGeom prst="ellipse">
+            <a:avLst/>
+          </a:prstGeom>
+          <a:solidFill>
+            <a:srgbClr val="2F9E44"/>
+          </a:solidFill>
+          <a:ln/>
+        </p:spPr>
+      </p:sp>
+      <p:sp>
+        <p:nvSpPr>
+          <p:cNvPr id="16" name="Text 14"/>
+          <p:cNvSpPr/>
+          <p:nvPr/>
+        </p:nvSpPr>
+        <p:spPr>
+          <a:xfrm>
+            <a:off x="502920" y="2866644"/>
+            <a:ext cx="329184" cy="329184"/>
+          </a:xfrm>
+          <a:prstGeom prst="rect">
+            <a:avLst/>
+          </a:prstGeom>
+          <a:noFill/>
+          <a:ln/>
+        </p:spPr>
+        <p:txBody>
+          <a:bodyPr wrap="square" lIns="0" tIns="0" rIns="0" bIns="0" rtlCol="0" anchor="ctr"/>
+          <a:lstStyle/>
+          <a:p>
+            <a:pPr algn="ctr" indent="0" marL="0">
+              <a:buNone/>
+            </a:pPr>
+            <a:r>
+              <a:rPr lang="en-US" sz="1400" b="1" dirty="0">
+                <a:solidFill>
+                  <a:srgbClr val="FFFFFF"/>
+                </a:solidFill>
+                <a:latin typeface="Arial" pitchFamily="34" charset="0"/>
+                <a:ea typeface="Arial" pitchFamily="34" charset="-122"/>
+                <a:cs typeface="Arial" pitchFamily="34" charset="-120"/>
+              </a:rPr>
+              <a:t>✓</a:t>
+            </a:r>
+            <a:endParaRPr lang="en-US" sz="1400" dirty="0"/>
+          </a:p>
+        </p:txBody>
+      </p:sp>
+      <p:sp>
+        <p:nvSpPr>
+          <p:cNvPr id="17" name="Text 15"/>
+          <p:cNvSpPr/>
+          <p:nvPr/>
+        </p:nvSpPr>
+        <p:spPr>
+          <a:xfrm>
+            <a:off x="1033272" y="2825496"/>
+            <a:ext cx="7699248" cy="292608"/>
+          </a:xfrm>
+          <a:prstGeom prst="rect">
+            <a:avLst/>
+          </a:prstGeom>
+          <a:noFill/>
+          <a:ln/>
+        </p:spPr>
+        <p:txBody>
+          <a:bodyPr wrap="square" lIns="0" tIns="0" rIns="0" bIns="0" rtlCol="0" anchor="ctr"/>
+          <a:lstStyle/>
+          <a:p>
+            <a:pPr indent="0" marL="0">
+              <a:buNone/>
+            </a:pPr>
+            <a:r>
+              <a:rPr lang="en-US" sz="1350" b="1" dirty="0">
+                <a:solidFill>
+                  <a:srgbClr val="1E2761"/>
+                </a:solidFill>
+                <a:latin typeface="Arial" pitchFamily="34" charset="0"/>
+                <a:ea typeface="Arial" pitchFamily="34" charset="-122"/>
+                <a:cs typeface="Arial" pitchFamily="34" charset="-120"/>
+              </a:rPr>
+              <a:t>Re-vendored from STAR's own public source</a:t>
+            </a:r>
+            <a:endParaRPr lang="en-US" sz="1350" dirty="0"/>
+          </a:p>
+        </p:txBody>
+      </p:sp>
+      <p:sp>
+        <p:nvSpPr>
+          <p:cNvPr id="18" name="Text 16"/>
+          <p:cNvSpPr/>
+          <p:nvPr/>
+        </p:nvSpPr>
+        <p:spPr>
+          <a:xfrm>
+            <a:off x="1033272" y="3136392"/>
+            <a:ext cx="7699248" cy="502920"/>
+          </a:xfrm>
+          <a:prstGeom prst="rect">
+            <a:avLst/>
+          </a:prstGeom>
+          <a:noFill/>
+          <a:ln/>
+        </p:spPr>
+        <p:txBody>
+          <a:bodyPr wrap="square" lIns="0" tIns="0" rIns="0" bIns="0" rtlCol="0" anchor="t"/>
+          <a:lstStyle/>
+          <a:p>
+            <a:pPr indent="0" marL="0">
+              <a:buNone/>
+            </a:pPr>
+            <a:r>
+              <a:rPr lang="en-US" sz="1150" dirty="0">
+                <a:solidFill>
+                  <a:srgbClr val="5B6382"/>
+                </a:solidFill>
+                <a:latin typeface="Arial" pitchFamily="34" charset="0"/>
+                <a:ea typeface="Arial" pitchFamily="34" charset="-122"/>
+                <a:cs typeface="Arial" pitchFamily="34" charset="-120"/>
+              </a:rPr>
+              <a:t>Pulled the SL24y class definitions directly from STAR's public repository rather than hand-editing the old ones.</a:t>
+            </a:r>
+            <a:endParaRPr lang="en-US" sz="1150" dirty="0"/>
+          </a:p>
+        </p:txBody>
+      </p:sp>
+      <p:sp>
+        <p:nvSpPr>
+          <p:cNvPr id="19" name="Shape 17"/>
+          <p:cNvSpPr/>
+          <p:nvPr/>
+        </p:nvSpPr>
+        <p:spPr>
+          <a:xfrm>
+            <a:off x="502920" y="3538728"/>
+            <a:ext cx="329184" cy="329184"/>
+          </a:xfrm>
+          <a:prstGeom prst="ellipse">
+            <a:avLst/>
+          </a:prstGeom>
+          <a:solidFill>
+            <a:srgbClr val="2F9E44"/>
+          </a:solidFill>
+          <a:ln/>
+        </p:spPr>
+      </p:sp>
+      <p:sp>
+        <p:nvSpPr>
+          <p:cNvPr id="20" name="Text 18"/>
+          <p:cNvSpPr/>
+          <p:nvPr/>
+        </p:nvSpPr>
+        <p:spPr>
+          <a:xfrm>
+            <a:off x="502920" y="3525012"/>
+            <a:ext cx="329184" cy="329184"/>
+          </a:xfrm>
+          <a:prstGeom prst="rect">
+            <a:avLst/>
+          </a:prstGeom>
+          <a:noFill/>
+          <a:ln/>
+        </p:spPr>
+        <p:txBody>
+          <a:bodyPr wrap="square" lIns="0" tIns="0" rIns="0" bIns="0" rtlCol="0" anchor="ctr"/>
+          <a:lstStyle/>
+          <a:p>
+            <a:pPr algn="ctr" indent="0" marL="0">
+              <a:buNone/>
+            </a:pPr>
+            <a:r>
+              <a:rPr lang="en-US" sz="1400" b="1" dirty="0">
+                <a:solidFill>
+                  <a:srgbClr val="FFFFFF"/>
+                </a:solidFill>
+                <a:latin typeface="Arial" pitchFamily="34" charset="0"/>
+                <a:ea typeface="Arial" pitchFamily="34" charset="-122"/>
+                <a:cs typeface="Arial" pitchFamily="34" charset="-120"/>
+              </a:rPr>
+              <a:t>✓</a:t>
+            </a:r>
+            <a:endParaRPr lang="en-US" sz="1400" dirty="0"/>
+          </a:p>
+        </p:txBody>
+      </p:sp>
+      <p:sp>
+        <p:nvSpPr>
+          <p:cNvPr id="21" name="Text 19"/>
+          <p:cNvSpPr/>
+          <p:nvPr/>
+        </p:nvSpPr>
+        <p:spPr>
+          <a:xfrm>
+            <a:off x="1033272" y="3483864"/>
+            <a:ext cx="7699248" cy="292608"/>
+          </a:xfrm>
+          <a:prstGeom prst="rect">
+            <a:avLst/>
+          </a:prstGeom>
+          <a:noFill/>
+          <a:ln/>
+        </p:spPr>
+        <p:txBody>
+          <a:bodyPr wrap="square" lIns="0" tIns="0" rIns="0" bIns="0" rtlCol="0" anchor="ctr"/>
+          <a:lstStyle/>
+          <a:p>
+            <a:pPr indent="0" marL="0">
+              <a:buNone/>
+            </a:pPr>
+            <a:r>
+              <a:rPr lang="en-US" sz="1350" b="1" dirty="0">
+                <a:solidFill>
+                  <a:srgbClr val="1E2761"/>
+                </a:solidFill>
+                <a:latin typeface="Arial" pitchFamily="34" charset="0"/>
+                <a:ea typeface="Arial" pitchFamily="34" charset="-122"/>
+                <a:cs typeface="Arial" pitchFamily="34" charset="-120"/>
+              </a:rPr>
+              <a:t>Diffed every class against the old version</a:t>
+            </a:r>
+            <a:endParaRPr lang="en-US" sz="1350" dirty="0"/>
+          </a:p>
+        </p:txBody>
+      </p:sp>
+      <p:sp>
+        <p:nvSpPr>
+          <p:cNvPr id="22" name="Text 20"/>
+          <p:cNvSpPr/>
+          <p:nvPr/>
+        </p:nvSpPr>
+        <p:spPr>
+          <a:xfrm>
+            <a:off x="1033272" y="3794760"/>
+            <a:ext cx="7699248" cy="502920"/>
+          </a:xfrm>
+          <a:prstGeom prst="rect">
+            <a:avLst/>
+          </a:prstGeom>
+          <a:noFill/>
+          <a:ln/>
+        </p:spPr>
+        <p:txBody>
+          <a:bodyPr wrap="square" lIns="0" tIns="0" rIns="0" bIns="0" rtlCol="0" anchor="t"/>
+          <a:lstStyle/>
+          <a:p>
+            <a:pPr indent="0" marL="0">
+              <a:buNone/>
+            </a:pPr>
+            <a:r>
+              <a:rPr lang="en-US" sz="1150" dirty="0">
+                <a:solidFill>
+                  <a:srgbClr val="5B6382"/>
+                </a:solidFill>
+                <a:latin typeface="Arial" pitchFamily="34" charset="0"/>
+                <a:ea typeface="Arial" pitchFamily="34" charset="-122"/>
+                <a:cs typeface="Arial" pitchFamily="34" charset="-120"/>
+              </a:rPr>
+              <a:t>Confirmed almost everything was unchanged; only the eTOF good-event-flag data grew far more granular (108 → 1728 entries) and needed a small update at its one call site.</a:t>
+            </a:r>
+            <a:endParaRPr lang="en-US" sz="1150" dirty="0"/>
+          </a:p>
+        </p:txBody>
+      </p:sp>
+      <p:sp>
+        <p:nvSpPr>
+          <p:cNvPr id="23" name="Shape 21"/>
+          <p:cNvSpPr/>
+          <p:nvPr/>
+        </p:nvSpPr>
+        <p:spPr>
+          <a:xfrm>
+            <a:off x="502920" y="4197096"/>
+            <a:ext cx="329184" cy="329184"/>
+          </a:xfrm>
+          <a:prstGeom prst="ellipse">
+            <a:avLst/>
+          </a:prstGeom>
+          <a:solidFill>
+            <a:srgbClr val="2F9E44"/>
+          </a:solidFill>
+          <a:ln/>
+        </p:spPr>
+      </p:sp>
+      <p:sp>
+        <p:nvSpPr>
+          <p:cNvPr id="24" name="Text 22"/>
+          <p:cNvSpPr/>
+          <p:nvPr/>
+        </p:nvSpPr>
+        <p:spPr>
+          <a:xfrm>
+            <a:off x="502920" y="4183380"/>
+            <a:ext cx="329184" cy="329184"/>
+          </a:xfrm>
+          <a:prstGeom prst="rect">
+            <a:avLst/>
+          </a:prstGeom>
+          <a:noFill/>
+          <a:ln/>
+        </p:spPr>
+        <p:txBody>
+          <a:bodyPr wrap="square" lIns="0" tIns="0" rIns="0" bIns="0" rtlCol="0" anchor="ctr"/>
+          <a:lstStyle/>
+          <a:p>
+            <a:pPr algn="ctr" indent="0" marL="0">
+              <a:buNone/>
+            </a:pPr>
+            <a:r>
+              <a:rPr lang="en-US" sz="1400" b="1" dirty="0">
+                <a:solidFill>
+                  <a:srgbClr val="FFFFFF"/>
+                </a:solidFill>
+                <a:latin typeface="Arial" pitchFamily="34" charset="0"/>
+                <a:ea typeface="Arial" pitchFamily="34" charset="-122"/>
+                <a:cs typeface="Arial" pitchFamily="34" charset="-120"/>
+              </a:rPr>
+              <a:t>✓</a:t>
+            </a:r>
+            <a:endParaRPr lang="en-US" sz="1400" dirty="0"/>
+          </a:p>
+        </p:txBody>
+      </p:sp>
+      <p:sp>
+        <p:nvSpPr>
+          <p:cNvPr id="25" name="Text 23"/>
+          <p:cNvSpPr/>
+          <p:nvPr/>
+        </p:nvSpPr>
+        <p:spPr>
+          <a:xfrm>
+            <a:off x="1033272" y="4142232"/>
+            <a:ext cx="7699248" cy="292608"/>
+          </a:xfrm>
+          <a:prstGeom prst="rect">
+            <a:avLst/>
+          </a:prstGeom>
+          <a:noFill/>
+          <a:ln/>
+        </p:spPr>
+        <p:txBody>
+          <a:bodyPr wrap="square" lIns="0" tIns="0" rIns="0" bIns="0" rtlCol="0" anchor="ctr"/>
+          <a:lstStyle/>
+          <a:p>
+            <a:pPr indent="0" marL="0">
+              <a:buNone/>
+            </a:pPr>
+            <a:r>
+              <a:rPr lang="en-US" sz="1350" b="1" dirty="0">
+                <a:solidFill>
+                  <a:srgbClr val="1E2761"/>
+                </a:solidFill>
+                <a:latin typeface="Arial" pitchFamily="34" charset="0"/>
+                <a:ea typeface="Arial" pitchFamily="34" charset="-122"/>
+                <a:cs typeface="Arial" pitchFamily="34" charset="-120"/>
+              </a:rPr>
+              <a:t>Closed a small upstream gap</a:t>
+            </a:r>
+            <a:endParaRPr lang="en-US" sz="1350" dirty="0"/>
+          </a:p>
+        </p:txBody>
+      </p:sp>
+      <p:sp>
+        <p:nvSpPr>
+          <p:cNvPr id="26" name="Text 24"/>
+          <p:cNvSpPr/>
+          <p:nvPr/>
+        </p:nvSpPr>
+        <p:spPr>
+          <a:xfrm>
+            <a:off x="1033272" y="4453128"/>
+            <a:ext cx="7699248" cy="502920"/>
+          </a:xfrm>
+          <a:prstGeom prst="rect">
+            <a:avLst/>
+          </a:prstGeom>
+          <a:noFill/>
+          <a:ln/>
+        </p:spPr>
+        <p:txBody>
+          <a:bodyPr wrap="square" lIns="0" tIns="0" rIns="0" bIns="0" rtlCol="0" anchor="t"/>
+          <a:lstStyle/>
+          <a:p>
+            <a:pPr indent="0" marL="0">
+              <a:buNone/>
+            </a:pPr>
+            <a:r>
+              <a:rPr lang="en-US" sz="1150" dirty="0">
+                <a:solidFill>
+                  <a:srgbClr val="5B6382"/>
+                </a:solidFill>
+                <a:latin typeface="Arial" pitchFamily="34" charset="0"/>
+                <a:ea typeface="Arial" pitchFamily="34" charset="-122"/>
+                <a:cs typeface="Arial" pitchFamily="34" charset="-120"/>
+              </a:rPr>
+              <a:t>Two methods STAR's own header declares but never defines needed minimal implementations so the library links cleanly.</a:t>
+            </a:r>
+            <a:endParaRPr lang="en-US" sz="1150" dirty="0"/>
+          </a:p>
+        </p:txBody>
+      </p:sp>
+      <p:sp>
+        <p:nvSpPr>
+          <p:cNvPr id="27" name="Text 25"/>
+          <p:cNvSpPr/>
+          <p:nvPr/>
+        </p:nvSpPr>
+        <p:spPr>
+          <a:xfrm>
+            <a:off x="8549640" y="4828032"/>
+            <a:ext cx="457200" cy="274320"/>
+          </a:xfrm>
+          <a:prstGeom prst="rect">
+            <a:avLst/>
+          </a:prstGeom>
+          <a:noFill/>
+          <a:ln/>
+        </p:spPr>
+        <p:txBody>
+          <a:bodyPr wrap="square" lIns="0" tIns="0" rIns="0" bIns="0" rtlCol="0" anchor="ctr"/>
+          <a:lstStyle/>
+          <a:p>
+            <a:pPr algn="r" indent="0" marL="0">
+              <a:buNone/>
+            </a:pPr>
+            <a:r>
+              <a:rPr lang="en-US" sz="1000" dirty="0">
+                <a:solidFill>
+                  <a:srgbClr val="5B6382"/>
+                </a:solidFill>
+                <a:latin typeface="Arial" pitchFamily="34" charset="0"/>
+                <a:ea typeface="Arial" pitchFamily="34" charset="-122"/>
+                <a:cs typeface="Arial" pitchFamily="34" charset="-120"/>
+              </a:rPr>
+              <a:t>10</a:t>
+            </a:r>
+            <a:endParaRPr lang="en-US" sz="1000" dirty="0"/>
+          </a:p>
+        </p:txBody>
+      </p:sp>
+      <p:sp>
+        <p:nvSpPr>
+          <p:cNvPr id="28" name="Text 26"/>
+          <p:cNvSpPr/>
+          <p:nvPr/>
+        </p:nvSpPr>
+        <p:spPr>
+          <a:xfrm>
+            <a:off x="457200" y="4828032"/>
+            <a:ext cx="3657600" cy="274320"/>
+          </a:xfrm>
+          <a:prstGeom prst="rect">
+            <a:avLst/>
+          </a:prstGeom>
+          <a:noFill/>
+          <a:ln/>
+        </p:spPr>
+        <p:txBody>
+          <a:bodyPr wrap="square" lIns="0" tIns="0" rIns="0" bIns="0" rtlCol="0" anchor="ctr"/>
+          <a:lstStyle/>
+          <a:p>
+            <a:pPr algn="l" indent="0" marL="0">
+              <a:buNone/>
+            </a:pPr>
+            <a:r>
+              <a:rPr lang="en-US" sz="1000" dirty="0">
+                <a:solidFill>
+                  <a:srgbClr val="5B6382"/>
+                </a:solidFill>
+                <a:latin typeface="Arial" pitchFamily="34" charset="0"/>
+                <a:ea typeface="Arial" pitchFamily="34" charset="-122"/>
+                <a:cs typeface="Arial" pitchFamily="34" charset="-120"/>
+              </a:rPr>
+              <a:t>lightflavorspectra_OO200</a:t>
+            </a:r>
+            <a:endParaRPr lang="en-US" sz="1000" dirty="0"/>
+          </a:p>
+        </p:txBody>
+      </p:sp>
+    </p:spTree>
+  </p:cSld>
+  <p:clrMapOvr>
+    <a:masterClrMapping/>
+  </p:clrMapOvr>
+</p:sld>
+</file>
+
+<file path=ppt/slides/slide11.xml><?xml version="1.0" encoding="utf-8"?>
+<p:sld xmlns:a="http://schemas.openxmlformats.org/drawingml/2006/main" xmlns:r="http://schemas.openxmlformats.org/officeDocument/2006/relationships" xmlns:p="http://schemas.openxmlformats.org/presentationml/2006/main">
+  <p:cSld name="Slide 11">
+    <p:bg>
+      <p:bgPr>
+        <a:solidFill>
+          <a:srgbClr val="FFFFFF"/>
+        </a:solidFill>
+      </p:bgPr>
+    </p:bg>
+    <p:spTree>
+      <p:nvGrpSpPr>
+        <p:cNvPr id="1" name=""/>
+        <p:cNvGrpSpPr/>
+        <p:nvPr/>
+      </p:nvGrpSpPr>
+      <p:grpSpPr>
+        <a:xfrm>
+          <a:off x="0" y="0"/>
+          <a:ext cx="0" cy="0"/>
+          <a:chOff x="0" y="0"/>
+          <a:chExt cx="0" cy="0"/>
+        </a:xfrm>
+      </p:grpSpPr>
+      <p:sp>
+        <p:nvSpPr>
+          <p:cNvPr id="2" name="Text 0"/>
+          <p:cNvSpPr/>
+          <p:nvPr/>
+        </p:nvSpPr>
+        <p:spPr>
+          <a:xfrm>
+            <a:off x="457200" y="320040"/>
+            <a:ext cx="8229600" cy="274320"/>
+          </a:xfrm>
+          <a:prstGeom prst="rect">
+            <a:avLst/>
+          </a:prstGeom>
+          <a:noFill/>
+          <a:ln/>
+        </p:spPr>
+        <p:txBody>
+          <a:bodyPr wrap="square" lIns="0" tIns="0" rIns="0" bIns="0" rtlCol="0" anchor="ctr"/>
+          <a:lstStyle/>
+          <a:p>
+            <a:pPr indent="0" marL="0">
+              <a:buNone/>
+            </a:pPr>
+            <a:r>
+              <a:rPr lang="en-US" sz="1200" b="1" spc="200" kern="0" dirty="0">
+                <a:solidFill>
+                  <a:srgbClr val="E8A33D"/>
+                </a:solidFill>
+                <a:latin typeface="Arial" pitchFamily="34" charset="0"/>
+                <a:ea typeface="Arial" pitchFamily="34" charset="-122"/>
+                <a:cs typeface="Arial" pitchFamily="34" charset="-120"/>
+              </a:rPr>
+              <a:t>BACKUP</a:t>
+            </a:r>
+            <a:endParaRPr lang="en-US" sz="1200" dirty="0"/>
+          </a:p>
+        </p:txBody>
+      </p:sp>
+      <p:sp>
+        <p:nvSpPr>
+          <p:cNvPr id="3" name="Text 1"/>
+          <p:cNvSpPr/>
+          <p:nvPr/>
+        </p:nvSpPr>
+        <p:spPr>
+          <a:xfrm>
+            <a:off x="457200" y="566928"/>
+            <a:ext cx="8229600" cy="640080"/>
+          </a:xfrm>
+          <a:prstGeom prst="rect">
+            <a:avLst/>
+          </a:prstGeom>
+          <a:noFill/>
+          <a:ln/>
+        </p:spPr>
+        <p:txBody>
+          <a:bodyPr wrap="square" lIns="0" tIns="0" rIns="0" bIns="0" rtlCol="0" anchor="ctr"/>
+          <a:lstStyle/>
+          <a:p>
+            <a:pPr indent="0" marL="0">
+              <a:buNone/>
+            </a:pPr>
+            <a:r>
+              <a:rPr lang="en-US" sz="3000" b="1" dirty="0">
+                <a:solidFill>
+                  <a:srgbClr val="1E2761"/>
+                </a:solidFill>
+                <a:latin typeface="Arial" pitchFamily="34" charset="0"/>
+                <a:ea typeface="Arial" pitchFamily="34" charset="-122"/>
+                <a:cs typeface="Arial" pitchFamily="34" charset="-120"/>
+              </a:rPr>
+              <a:t>Computing Infrastructure -- Detail</a:t>
+            </a:r>
+            <a:endParaRPr lang="en-US" sz="3000" dirty="0"/>
+          </a:p>
+        </p:txBody>
+      </p:sp>
+      <p:sp>
+        <p:nvSpPr>
+          <p:cNvPr id="4" name="Shape 2"/>
+          <p:cNvSpPr/>
+          <p:nvPr/>
+        </p:nvSpPr>
+        <p:spPr>
+          <a:xfrm>
+            <a:off x="502920" y="1417320"/>
+            <a:ext cx="3566160" cy="2331720"/>
+          </a:xfrm>
+          <a:prstGeom prst="roundRect">
+            <a:avLst>
+              <a:gd name="adj" fmla="val 3922"/>
+            </a:avLst>
+          </a:prstGeom>
+          <a:solidFill>
+            <a:srgbClr val="F3F6FD"/>
+          </a:solidFill>
+          <a:ln w="15875">
+            <a:solidFill>
+              <a:srgbClr val="CADCFC"/>
+            </a:solidFill>
+            <a:prstDash val="solid"/>
+          </a:ln>
+        </p:spPr>
+      </p:sp>
+      <p:sp>
+        <p:nvSpPr>
+          <p:cNvPr id="5" name="Text 3"/>
+          <p:cNvSpPr/>
+          <p:nvPr/>
+        </p:nvSpPr>
+        <p:spPr>
+          <a:xfrm>
+            <a:off x="731520" y="1600200"/>
+            <a:ext cx="3108960" cy="274320"/>
+          </a:xfrm>
+          <a:prstGeom prst="rect">
+            <a:avLst/>
+          </a:prstGeom>
+          <a:noFill/>
+          <a:ln/>
+        </p:spPr>
+        <p:txBody>
+          <a:bodyPr wrap="square" lIns="0" tIns="0" rIns="0" bIns="0" rtlCol="0" anchor="ctr"/>
+          <a:lstStyle/>
+          <a:p>
+            <a:pPr indent="0" marL="0">
+              <a:buNone/>
+            </a:pPr>
+            <a:r>
+              <a:rPr lang="en-US" sz="1200" b="1" spc="150" kern="0" dirty="0">
+                <a:solidFill>
+                  <a:srgbClr val="5B6382"/>
+                </a:solidFill>
+                <a:latin typeface="Arial" pitchFamily="34" charset="0"/>
+                <a:ea typeface="Arial" pitchFamily="34" charset="-122"/>
+                <a:cs typeface="Arial" pitchFamily="34" charset="-120"/>
+              </a:rPr>
+              <a:t>MY LAPTOP</a:t>
+            </a:r>
+            <a:endParaRPr lang="en-US" sz="1200" dirty="0"/>
+          </a:p>
+        </p:txBody>
+      </p:sp>
+      <p:sp>
+        <p:nvSpPr>
+          <p:cNvPr id="6" name="Text 4"/>
+          <p:cNvSpPr/>
+          <p:nvPr/>
+        </p:nvSpPr>
+        <p:spPr>
+          <a:xfrm>
+            <a:off x="731520" y="1874520"/>
+            <a:ext cx="3108960" cy="411480"/>
+          </a:xfrm>
+          <a:prstGeom prst="rect">
+            <a:avLst/>
+          </a:prstGeom>
+          <a:noFill/>
+          <a:ln/>
+        </p:spPr>
+        <p:txBody>
+          <a:bodyPr wrap="square" lIns="0" tIns="0" rIns="0" bIns="0" rtlCol="0" anchor="ctr"/>
+          <a:lstStyle/>
+          <a:p>
+            <a:pPr indent="0" marL="0">
+              <a:buNone/>
+            </a:pPr>
+            <a:r>
+              <a:rPr lang="en-US" sz="2000" b="1" dirty="0">
+                <a:solidFill>
+                  <a:srgbClr val="1E2761"/>
+                </a:solidFill>
+                <a:latin typeface="Arial" pitchFamily="34" charset="0"/>
+                <a:ea typeface="Arial" pitchFamily="34" charset="-122"/>
+                <a:cs typeface="Arial" pitchFamily="34" charset="-120"/>
+              </a:rPr>
+              <a:t>Stages 2–4</a:t>
+            </a:r>
+            <a:endParaRPr lang="en-US" sz="2000" dirty="0"/>
+          </a:p>
+        </p:txBody>
+      </p:sp>
+      <p:sp>
+        <p:nvSpPr>
+          <p:cNvPr id="7" name="Text 5"/>
+          <p:cNvSpPr/>
+          <p:nvPr/>
+        </p:nvSpPr>
+        <p:spPr>
+          <a:xfrm>
+            <a:off x="731520" y="2331720"/>
+            <a:ext cx="3017520" cy="731520"/>
+          </a:xfrm>
+          <a:prstGeom prst="rect">
+            <a:avLst/>
+          </a:prstGeom>
+          <a:noFill/>
+          <a:ln/>
+        </p:spPr>
+        <p:txBody>
+          <a:bodyPr wrap="square" lIns="0" tIns="0" rIns="0" bIns="0" rtlCol="0" anchor="ctr"/>
+          <a:lstStyle/>
+          <a:p>
+            <a:pPr indent="0" marL="0">
+              <a:buNone/>
+            </a:pPr>
+            <a:r>
+              <a:rPr lang="en-US" sz="1200" dirty="0">
+                <a:solidFill>
+                  <a:srgbClr val="5B6382"/>
+                </a:solidFill>
+                <a:latin typeface="Arial" pitchFamily="34" charset="0"/>
+                <a:ea typeface="Arial" pitchFamily="34" charset="-122"/>
+                <a:cs typeface="Arial" pitchFamily="34" charset="-120"/>
+              </a:rPr>
+              <a:t>PID fitting, corrections, and final spectra fits -- unchanged, still run locally exactly as before.</a:t>
+            </a:r>
+            <a:endParaRPr lang="en-US" sz="1200" dirty="0"/>
+          </a:p>
+        </p:txBody>
+      </p:sp>
+      <p:sp>
+        <p:nvSpPr>
+          <p:cNvPr id="8" name="Shape 6"/>
+          <p:cNvSpPr/>
+          <p:nvPr/>
+        </p:nvSpPr>
+        <p:spPr>
+          <a:xfrm>
+            <a:off x="5074920" y="1417320"/>
+            <a:ext cx="3566160" cy="2331720"/>
+          </a:xfrm>
+          <a:prstGeom prst="roundRect">
+            <a:avLst>
+              <a:gd name="adj" fmla="val 3922"/>
+            </a:avLst>
+          </a:prstGeom>
+          <a:solidFill>
+            <a:srgbClr val="1E2761"/>
+          </a:solidFill>
+          <a:ln/>
+          <a:effectLst>
+            <a:outerShdw sx="100000" sy="100000" kx="0" ky="0" algn="bl" rotWithShape="0" blurRad="63500" dist="25400" dir="2700000">
+              <a:srgbClr val="000000">
+                <a:alpha val="15000"/>
+              </a:srgbClr>
+            </a:outerShdw>
+          </a:effectLst>
+        </p:spPr>
+      </p:sp>
+      <p:sp>
+        <p:nvSpPr>
+          <p:cNvPr id="9" name="Text 7"/>
+          <p:cNvSpPr/>
+          <p:nvPr/>
+        </p:nvSpPr>
+        <p:spPr>
+          <a:xfrm>
+            <a:off x="5303520" y="1600200"/>
+            <a:ext cx="3108960" cy="274320"/>
+          </a:xfrm>
+          <a:prstGeom prst="rect">
+            <a:avLst/>
+          </a:prstGeom>
+          <a:noFill/>
+          <a:ln/>
+        </p:spPr>
+        <p:txBody>
+          <a:bodyPr wrap="square" lIns="0" tIns="0" rIns="0" bIns="0" rtlCol="0" anchor="ctr"/>
+          <a:lstStyle/>
+          <a:p>
+            <a:pPr indent="0" marL="0">
+              <a:buNone/>
+            </a:pPr>
+            <a:r>
+              <a:rPr lang="en-US" sz="1200" b="1" spc="150" kern="0" dirty="0">
+                <a:solidFill>
+                  <a:srgbClr val="E8A33D"/>
+                </a:solidFill>
+                <a:latin typeface="Arial" pitchFamily="34" charset="0"/>
+                <a:ea typeface="Arial" pitchFamily="34" charset="-122"/>
+                <a:cs typeface="Arial" pitchFamily="34" charset="-120"/>
+              </a:rPr>
+              <a:t>SDCC / RCF BATCH  —  NEW</a:t>
+            </a:r>
+            <a:endParaRPr lang="en-US" sz="1200" dirty="0"/>
+          </a:p>
+        </p:txBody>
+      </p:sp>
+      <p:sp>
+        <p:nvSpPr>
+          <p:cNvPr id="10" name="Text 8"/>
+          <p:cNvSpPr/>
+          <p:nvPr/>
+        </p:nvSpPr>
+        <p:spPr>
+          <a:xfrm>
+            <a:off x="5303520" y="1874520"/>
+            <a:ext cx="3108960" cy="411480"/>
+          </a:xfrm>
+          <a:prstGeom prst="rect">
+            <a:avLst/>
+          </a:prstGeom>
+          <a:noFill/>
+          <a:ln/>
+        </p:spPr>
+        <p:txBody>
+          <a:bodyPr wrap="square" lIns="0" tIns="0" rIns="0" bIns="0" rtlCol="0" anchor="ctr"/>
+          <a:lstStyle/>
+          <a:p>
+            <a:pPr indent="0" marL="0">
+              <a:buNone/>
+            </a:pPr>
+            <a:r>
+              <a:rPr lang="en-US" sz="2000" b="1" dirty="0">
+                <a:solidFill>
+                  <a:srgbClr val="FFFFFF"/>
+                </a:solidFill>
+                <a:latin typeface="Arial" pitchFamily="34" charset="0"/>
+                <a:ea typeface="Arial" pitchFamily="34" charset="-122"/>
+                <a:cs typeface="Arial" pitchFamily="34" charset="-120"/>
+              </a:rPr>
+              <a:t>Stage 1</a:t>
+            </a:r>
+            <a:endParaRPr lang="en-US" sz="2000" dirty="0"/>
+          </a:p>
+        </p:txBody>
+      </p:sp>
+      <p:sp>
+        <p:nvSpPr>
+          <p:cNvPr id="11" name="Text 9"/>
+          <p:cNvSpPr/>
+          <p:nvPr/>
+        </p:nvSpPr>
+        <p:spPr>
+          <a:xfrm>
+            <a:off x="5303520" y="2331720"/>
+            <a:ext cx="3017520" cy="822960"/>
+          </a:xfrm>
+          <a:prstGeom prst="rect">
+            <a:avLst/>
+          </a:prstGeom>
+          <a:noFill/>
+          <a:ln/>
+        </p:spPr>
+        <p:txBody>
+          <a:bodyPr wrap="square" lIns="0" tIns="0" rIns="0" bIns="0" rtlCol="0" anchor="ctr"/>
+          <a:lstStyle/>
+          <a:p>
+            <a:pPr indent="0" marL="0">
+              <a:buNone/>
+            </a:pPr>
+            <a:r>
+              <a:rPr lang="en-US" sz="1200" dirty="0">
+                <a:solidFill>
+                  <a:srgbClr val="CADCFC"/>
+                </a:solidFill>
+                <a:latin typeface="Arial" pitchFamily="34" charset="0"/>
+                <a:ea typeface="Arial" pitchFamily="34" charset="-122"/>
+                <a:cs typeface="Arial" pitchFamily="34" charset="-120"/>
+              </a:rPr>
+              <a:t>Raw-yield extraction, one job per species, against the full production file list -- too large to run in one local session.</a:t>
+            </a:r>
+            <a:endParaRPr lang="en-US" sz="1200" dirty="0"/>
+          </a:p>
+        </p:txBody>
+      </p:sp>
+      <p:sp>
+        <p:nvSpPr>
+          <p:cNvPr id="12" name="Text 10"/>
+          <p:cNvSpPr/>
+          <p:nvPr/>
+        </p:nvSpPr>
+        <p:spPr>
+          <a:xfrm>
+            <a:off x="4069080" y="2377440"/>
+            <a:ext cx="1005840" cy="457200"/>
+          </a:xfrm>
+          <a:prstGeom prst="rect">
+            <a:avLst/>
+          </a:prstGeom>
+          <a:noFill/>
+          <a:ln/>
+        </p:spPr>
+        <p:txBody>
+          <a:bodyPr wrap="square" lIns="0" tIns="0" rIns="0" bIns="0" rtlCol="0" anchor="ctr"/>
+          <a:lstStyle/>
+          <a:p>
+            <a:pPr algn="ctr" indent="0" marL="0">
+              <a:buNone/>
+            </a:pPr>
+            <a:r>
+              <a:rPr lang="en-US" sz="2600" b="1" dirty="0">
+                <a:solidFill>
+                  <a:srgbClr val="E8A33D"/>
+                </a:solidFill>
+                <a:latin typeface="Arial" pitchFamily="34" charset="0"/>
+                <a:ea typeface="Arial" pitchFamily="34" charset="-122"/>
+                <a:cs typeface="Arial" pitchFamily="34" charset="-120"/>
+              </a:rPr>
+              <a:t>↔</a:t>
+            </a:r>
+            <a:endParaRPr lang="en-US" sz="2600" dirty="0"/>
+          </a:p>
+        </p:txBody>
+      </p:sp>
+      <p:sp>
+        <p:nvSpPr>
+          <p:cNvPr id="13" name="Text 11"/>
+          <p:cNvSpPr/>
+          <p:nvPr/>
+        </p:nvSpPr>
+        <p:spPr>
+          <a:xfrm>
+            <a:off x="3931920" y="2834640"/>
+            <a:ext cx="1280160" cy="457200"/>
+          </a:xfrm>
+          <a:prstGeom prst="rect">
+            <a:avLst/>
+          </a:prstGeom>
+          <a:noFill/>
+          <a:ln/>
+        </p:spPr>
+        <p:txBody>
+          <a:bodyPr wrap="square" lIns="0" tIns="0" rIns="0" bIns="0" rtlCol="0" anchor="ctr"/>
+          <a:lstStyle/>
+          <a:p>
+            <a:pPr algn="ctr" indent="0" marL="0">
+              <a:buNone/>
+            </a:pPr>
+            <a:r>
+              <a:rPr lang="en-US" sz="950" i="1" dirty="0">
+                <a:solidFill>
+                  <a:srgbClr val="5B6382"/>
+                </a:solidFill>
+                <a:latin typeface="Arial" pitchFamily="34" charset="0"/>
+                <a:ea typeface="Arial" pitchFamily="34" charset="-122"/>
+                <a:cs typeface="Arial" pitchFamily="34" charset="-120"/>
+              </a:rPr>
+              <a:t>output files</a:t>
+            </a:r>
+            <a:endParaRPr lang="en-US" sz="950" dirty="0"/>
+          </a:p>
+          <a:p>
+            <a:pPr algn="ctr" indent="0" marL="0">
+              <a:buNone/>
+            </a:pPr>
+            <a:r>
+              <a:rPr lang="en-US" sz="950" i="1" dirty="0">
+                <a:solidFill>
+                  <a:srgbClr val="5B6382"/>
+                </a:solidFill>
+                <a:latin typeface="Arial" pitchFamily="34" charset="0"/>
+                <a:ea typeface="Arial" pitchFamily="34" charset="-122"/>
+                <a:cs typeface="Arial" pitchFamily="34" charset="-120"/>
+              </a:rPr>
+              <a:t>moved back</a:t>
+            </a:r>
+            <a:endParaRPr lang="en-US" sz="950" dirty="0"/>
+          </a:p>
+        </p:txBody>
+      </p:sp>
+      <p:sp>
+        <p:nvSpPr>
+          <p:cNvPr id="14" name="Text 12"/>
+          <p:cNvSpPr/>
+          <p:nvPr/>
+        </p:nvSpPr>
+        <p:spPr>
+          <a:xfrm>
+            <a:off x="502920" y="3977640"/>
+            <a:ext cx="8138160" cy="457200"/>
+          </a:xfrm>
+          <a:prstGeom prst="rect">
+            <a:avLst/>
+          </a:prstGeom>
+          <a:noFill/>
+          <a:ln/>
+        </p:spPr>
+        <p:txBody>
+          <a:bodyPr wrap="square" lIns="0" tIns="0" rIns="0" bIns="0" rtlCol="0" anchor="ctr"/>
+          <a:lstStyle/>
+          <a:p>
+            <a:pPr indent="0" marL="0">
+              <a:buNone/>
+            </a:pPr>
+            <a:r>
+              <a:rPr lang="en-US" sz="1250" i="1" dirty="0">
+                <a:solidFill>
+                  <a:srgbClr val="5B6382"/>
+                </a:solidFill>
+                <a:latin typeface="Arial" pitchFamily="34" charset="0"/>
+                <a:ea typeface="Arial" pitchFamily="34" charset="-122"/>
+                <a:cs typeface="Arial" pitchFamily="34" charset="-120"/>
+              </a:rPr>
+              <a:t>Configured with a star-submit job template + wrapper script, pointed at the correct production tag and library for this dataset.</a:t>
+            </a:r>
+            <a:endParaRPr lang="en-US" sz="1250" dirty="0"/>
+          </a:p>
+        </p:txBody>
+      </p:sp>
+      <p:sp>
+        <p:nvSpPr>
+          <p:cNvPr id="15" name="Text 13"/>
+          <p:cNvSpPr/>
+          <p:nvPr/>
+        </p:nvSpPr>
+        <p:spPr>
+          <a:xfrm>
+            <a:off x="8549640" y="4828032"/>
+            <a:ext cx="457200" cy="274320"/>
+          </a:xfrm>
+          <a:prstGeom prst="rect">
+            <a:avLst/>
+          </a:prstGeom>
+          <a:noFill/>
+          <a:ln/>
+        </p:spPr>
+        <p:txBody>
+          <a:bodyPr wrap="square" lIns="0" tIns="0" rIns="0" bIns="0" rtlCol="0" anchor="ctr"/>
+          <a:lstStyle/>
+          <a:p>
+            <a:pPr algn="r" indent="0" marL="0">
+              <a:buNone/>
+            </a:pPr>
+            <a:r>
+              <a:rPr lang="en-US" sz="1000" dirty="0">
+                <a:solidFill>
+                  <a:srgbClr val="5B6382"/>
+                </a:solidFill>
+                <a:latin typeface="Arial" pitchFamily="34" charset="0"/>
+                <a:ea typeface="Arial" pitchFamily="34" charset="-122"/>
+                <a:cs typeface="Arial" pitchFamily="34" charset="-120"/>
+              </a:rPr>
+              <a:t>11</a:t>
+            </a:r>
+            <a:endParaRPr lang="en-US" sz="1000" dirty="0"/>
+          </a:p>
+        </p:txBody>
+      </p:sp>
+      <p:sp>
+        <p:nvSpPr>
+          <p:cNvPr id="16" name="Text 14"/>
+          <p:cNvSpPr/>
+          <p:nvPr/>
+        </p:nvSpPr>
+        <p:spPr>
+          <a:xfrm>
+            <a:off x="457200" y="4828032"/>
+            <a:ext cx="3657600" cy="274320"/>
+          </a:xfrm>
+          <a:prstGeom prst="rect">
+            <a:avLst/>
+          </a:prstGeom>
+          <a:noFill/>
+          <a:ln/>
+        </p:spPr>
+        <p:txBody>
+          <a:bodyPr wrap="square" lIns="0" tIns="0" rIns="0" bIns="0" rtlCol="0" anchor="ctr"/>
+          <a:lstStyle/>
+          <a:p>
+            <a:pPr algn="l" indent="0" marL="0">
+              <a:buNone/>
+            </a:pPr>
+            <a:r>
+              <a:rPr lang="en-US" sz="1000" dirty="0">
+                <a:solidFill>
+                  <a:srgbClr val="5B6382"/>
+                </a:solidFill>
+                <a:latin typeface="Arial" pitchFamily="34" charset="0"/>
+                <a:ea typeface="Arial" pitchFamily="34" charset="-122"/>
+                <a:cs typeface="Arial" pitchFamily="34" charset="-120"/>
+              </a:rPr>
+              <a:t>lightflavorspectra_OO200</a:t>
+            </a:r>
+            <a:endParaRPr lang="en-US" sz="1000" dirty="0"/>
+          </a:p>
+        </p:txBody>
+      </p:sp>
+    </p:spTree>
+  </p:cSld>
+  <p:clrMapOvr>
+    <a:masterClrMapping/>
+  </p:clrMapOvr>
+</p:sld>
+</file>
+
+<file path=ppt/slides/slide12.xml><?xml version="1.0" encoding="utf-8"?>
+<p:sld xmlns:a="http://schemas.openxmlformats.org/drawingml/2006/main" xmlns:r="http://schemas.openxmlformats.org/officeDocument/2006/relationships" xmlns:p="http://schemas.openxmlformats.org/presentationml/2006/main">
+  <p:cSld name="Slide 12">
+    <p:bg>
+      <p:bgPr>
+        <a:solidFill>
+          <a:srgbClr val="FFFFFF"/>
+        </a:solidFill>
+      </p:bgPr>
+    </p:bg>
+    <p:spTree>
+      <p:nvGrpSpPr>
+        <p:cNvPr id="1" name=""/>
+        <p:cNvGrpSpPr/>
+        <p:nvPr/>
+      </p:nvGrpSpPr>
+      <p:grpSpPr>
+        <a:xfrm>
+          <a:off x="0" y="0"/>
+          <a:ext cx="0" cy="0"/>
+          <a:chOff x="0" y="0"/>
+          <a:chExt cx="0" cy="0"/>
+        </a:xfrm>
+      </p:grpSpPr>
+      <p:sp>
+        <p:nvSpPr>
+          <p:cNvPr id="2" name="Text 0"/>
+          <p:cNvSpPr/>
+          <p:nvPr/>
+        </p:nvSpPr>
+        <p:spPr>
+          <a:xfrm>
+            <a:off x="457200" y="320040"/>
+            <a:ext cx="8229600" cy="274320"/>
+          </a:xfrm>
+          <a:prstGeom prst="rect">
+            <a:avLst/>
+          </a:prstGeom>
+          <a:noFill/>
+          <a:ln/>
+        </p:spPr>
+        <p:txBody>
+          <a:bodyPr wrap="square" lIns="0" tIns="0" rIns="0" bIns="0" rtlCol="0" anchor="ctr"/>
+          <a:lstStyle/>
+          <a:p>
+            <a:pPr indent="0" marL="0">
+              <a:buNone/>
+            </a:pPr>
+            <a:r>
+              <a:rPr lang="en-US" sz="1200" b="1" spc="200" kern="0" dirty="0">
+                <a:solidFill>
+                  <a:srgbClr val="E8A33D"/>
+                </a:solidFill>
+                <a:latin typeface="Arial" pitchFamily="34" charset="0"/>
+                <a:ea typeface="Arial" pitchFamily="34" charset="-122"/>
+                <a:cs typeface="Arial" pitchFamily="34" charset="-120"/>
+              </a:rPr>
+              <a:t>BACKUP</a:t>
+            </a:r>
+            <a:endParaRPr lang="en-US" sz="1200" dirty="0"/>
+          </a:p>
+        </p:txBody>
+      </p:sp>
+      <p:sp>
+        <p:nvSpPr>
+          <p:cNvPr id="3" name="Text 1"/>
+          <p:cNvSpPr/>
+          <p:nvPr/>
+        </p:nvSpPr>
+        <p:spPr>
+          <a:xfrm>
+            <a:off x="457200" y="566928"/>
+            <a:ext cx="8229600" cy="640080"/>
+          </a:xfrm>
+          <a:prstGeom prst="rect">
+            <a:avLst/>
+          </a:prstGeom>
+          <a:noFill/>
+          <a:ln/>
+        </p:spPr>
+        <p:txBody>
+          <a:bodyPr wrap="square" lIns="0" tIns="0" rIns="0" bIns="0" rtlCol="0" anchor="ctr"/>
+          <a:lstStyle/>
+          <a:p>
+            <a:pPr indent="0" marL="0">
+              <a:buNone/>
+            </a:pPr>
+            <a:r>
+              <a:rPr lang="en-US" sz="3000" b="1" dirty="0">
+                <a:solidFill>
+                  <a:srgbClr val="1E2761"/>
+                </a:solidFill>
+                <a:latin typeface="Arial" pitchFamily="34" charset="0"/>
+                <a:ea typeface="Arial" pitchFamily="34" charset="-122"/>
+                <a:cs typeface="Arial" pitchFamily="34" charset="-120"/>
+              </a:rPr>
+              <a:t>Build Compatibility Fixes -- Detail</a:t>
+            </a:r>
+            <a:endParaRPr lang="en-US" sz="3000" dirty="0"/>
+          </a:p>
+        </p:txBody>
+      </p:sp>
+      <p:sp>
+        <p:nvSpPr>
+          <p:cNvPr id="4" name="Shape 2"/>
+          <p:cNvSpPr/>
+          <p:nvPr/>
+        </p:nvSpPr>
+        <p:spPr>
+          <a:xfrm>
+            <a:off x="502920" y="1417320"/>
+            <a:ext cx="2468880" cy="2606040"/>
+          </a:xfrm>
+          <a:prstGeom prst="roundRect">
+            <a:avLst>
+              <a:gd name="adj" fmla="val 3704"/>
+            </a:avLst>
+          </a:prstGeom>
+          <a:solidFill>
+            <a:srgbClr val="1E2761"/>
+          </a:solidFill>
+          <a:ln/>
+          <a:effectLst>
+            <a:outerShdw sx="100000" sy="100000" kx="0" ky="0" algn="bl" rotWithShape="0" blurRad="63500" dist="25400" dir="2700000">
+              <a:srgbClr val="000000">
+                <a:alpha val="15000"/>
+              </a:srgbClr>
+            </a:outerShdw>
+          </a:effectLst>
+        </p:spPr>
+      </p:sp>
+      <p:sp>
+        <p:nvSpPr>
+          <p:cNvPr id="5" name="Text 3"/>
+          <p:cNvSpPr/>
+          <p:nvPr/>
+        </p:nvSpPr>
+        <p:spPr>
+          <a:xfrm>
+            <a:off x="502920" y="1691640"/>
+            <a:ext cx="2468880" cy="1097280"/>
+          </a:xfrm>
+          <a:prstGeom prst="rect">
+            <a:avLst/>
+          </a:prstGeom>
+          <a:noFill/>
+          <a:ln/>
+        </p:spPr>
+        <p:txBody>
+          <a:bodyPr wrap="square" lIns="0" tIns="0" rIns="0" bIns="0" rtlCol="0" anchor="ctr"/>
+          <a:lstStyle/>
+          <a:p>
+            <a:pPr algn="ctr" indent="0" marL="0">
+              <a:buNone/>
+            </a:pPr>
+            <a:r>
+              <a:rPr lang="en-US" sz="6200" b="1" dirty="0">
+                <a:solidFill>
+                  <a:srgbClr val="E8A33D"/>
+                </a:solidFill>
+                <a:latin typeface="Arial" pitchFamily="34" charset="0"/>
+                <a:ea typeface="Arial" pitchFamily="34" charset="-122"/>
+                <a:cs typeface="Arial" pitchFamily="34" charset="-120"/>
+              </a:rPr>
+              <a:t>6</a:t>
+            </a:r>
+            <a:endParaRPr lang="en-US" sz="6200" dirty="0"/>
+          </a:p>
+        </p:txBody>
+      </p:sp>
+      <p:sp>
+        <p:nvSpPr>
+          <p:cNvPr id="6" name="Text 4"/>
+          <p:cNvSpPr/>
+          <p:nvPr/>
+        </p:nvSpPr>
+        <p:spPr>
+          <a:xfrm>
+            <a:off x="685800" y="2788920"/>
+            <a:ext cx="2103120" cy="822960"/>
+          </a:xfrm>
+          <a:prstGeom prst="rect">
+            <a:avLst/>
+          </a:prstGeom>
+          <a:noFill/>
+          <a:ln/>
+        </p:spPr>
+        <p:txBody>
+          <a:bodyPr wrap="square" lIns="0" tIns="0" rIns="0" bIns="0" rtlCol="0" anchor="ctr"/>
+          <a:lstStyle/>
+          <a:p>
+            <a:pPr algn="ctr" indent="0" marL="0">
+              <a:buNone/>
+            </a:pPr>
+            <a:r>
+              <a:rPr lang="en-US" sz="1350" b="1" dirty="0">
+                <a:solidFill>
+                  <a:srgbClr val="FFFFFF"/>
+                </a:solidFill>
+                <a:latin typeface="Arial" pitchFamily="34" charset="0"/>
+                <a:ea typeface="Arial" pitchFamily="34" charset="-122"/>
+                <a:cs typeface="Arial" pitchFamily="34" charset="-120"/>
+              </a:rPr>
+              <a:t>separate build issues</a:t>
+            </a:r>
+            <a:endParaRPr lang="en-US" sz="1350" dirty="0"/>
+          </a:p>
+          <a:p>
+            <a:pPr algn="ctr" indent="0" marL="0">
+              <a:buNone/>
+            </a:pPr>
+            <a:r>
+              <a:rPr lang="en-US" sz="1350" b="1" dirty="0">
+                <a:solidFill>
+                  <a:srgbClr val="FFFFFF"/>
+                </a:solidFill>
+                <a:latin typeface="Arial" pitchFamily="34" charset="0"/>
+                <a:ea typeface="Arial" pitchFamily="34" charset="-122"/>
+                <a:cs typeface="Arial" pitchFamily="34" charset="-120"/>
+              </a:rPr>
+              <a:t>found and fixed</a:t>
+            </a:r>
+            <a:endParaRPr lang="en-US" sz="1350" dirty="0"/>
+          </a:p>
+        </p:txBody>
+      </p:sp>
+      <p:sp>
+        <p:nvSpPr>
+          <p:cNvPr id="7" name="Text 5"/>
+          <p:cNvSpPr/>
+          <p:nvPr/>
+        </p:nvSpPr>
+        <p:spPr>
+          <a:xfrm>
+            <a:off x="3246120" y="1463040"/>
+            <a:ext cx="5394960" cy="685800"/>
+          </a:xfrm>
+          <a:prstGeom prst="rect">
+            <a:avLst/>
+          </a:prstGeom>
+          <a:noFill/>
+          <a:ln/>
+        </p:spPr>
+        <p:txBody>
+          <a:bodyPr wrap="square" lIns="0" tIns="0" rIns="0" bIns="0" rtlCol="0" anchor="ctr"/>
+          <a:lstStyle/>
+          <a:p>
+            <a:pPr indent="0" marL="0">
+              <a:buNone/>
+            </a:pPr>
+            <a:r>
+              <a:rPr lang="en-US" sz="1400" dirty="0">
+                <a:solidFill>
+                  <a:srgbClr val="20233B"/>
+                </a:solidFill>
+                <a:latin typeface="Arial" pitchFamily="34" charset="0"/>
+                <a:ea typeface="Arial" pitchFamily="34" charset="-122"/>
+                <a:cs typeface="Arial" pitchFamily="34" charset="-120"/>
+              </a:rPr>
+              <a:t>SDCC runs an older ROOT version (via an interpreter called CINT) than my laptop's ROOT 6. Code that compiled fine locally didn't compile there.</a:t>
+            </a:r>
+            <a:endParaRPr lang="en-US" sz="1400" dirty="0"/>
+          </a:p>
+        </p:txBody>
+      </p:sp>
+      <p:sp>
+        <p:nvSpPr>
+          <p:cNvPr id="8" name="Shape 6"/>
+          <p:cNvSpPr/>
+          <p:nvPr/>
+        </p:nvSpPr>
+        <p:spPr>
+          <a:xfrm>
+            <a:off x="3246120" y="2331720"/>
+            <a:ext cx="329184" cy="329184"/>
+          </a:xfrm>
+          <a:prstGeom prst="ellipse">
+            <a:avLst/>
+          </a:prstGeom>
+          <a:solidFill>
+            <a:srgbClr val="E8A33D"/>
+          </a:solidFill>
+          <a:ln/>
+        </p:spPr>
+      </p:sp>
+      <p:sp>
+        <p:nvSpPr>
+          <p:cNvPr id="9" name="Text 7"/>
+          <p:cNvSpPr/>
+          <p:nvPr/>
+        </p:nvSpPr>
+        <p:spPr>
+          <a:xfrm>
+            <a:off x="3246120" y="2318004"/>
+            <a:ext cx="329184" cy="329184"/>
+          </a:xfrm>
+          <a:prstGeom prst="rect">
+            <a:avLst/>
+          </a:prstGeom>
+          <a:noFill/>
+          <a:ln/>
+        </p:spPr>
+        <p:txBody>
+          <a:bodyPr wrap="square" lIns="0" tIns="0" rIns="0" bIns="0" rtlCol="0" anchor="ctr"/>
+          <a:lstStyle/>
+          <a:p>
+            <a:pPr algn="ctr" indent="0" marL="0">
+              <a:buNone/>
+            </a:pPr>
+            <a:r>
+              <a:rPr lang="en-US" sz="1400" b="1" dirty="0">
+                <a:solidFill>
+                  <a:srgbClr val="FFFFFF"/>
+                </a:solidFill>
+                <a:latin typeface="Arial" pitchFamily="34" charset="0"/>
+                <a:ea typeface="Arial" pitchFamily="34" charset="-122"/>
+                <a:cs typeface="Arial" pitchFamily="34" charset="-120"/>
+              </a:rPr>
+              <a:t>!</a:t>
+            </a:r>
+            <a:endParaRPr lang="en-US" sz="1400" dirty="0"/>
+          </a:p>
+        </p:txBody>
+      </p:sp>
+      <p:sp>
+        <p:nvSpPr>
+          <p:cNvPr id="10" name="Text 8"/>
+          <p:cNvSpPr/>
+          <p:nvPr/>
+        </p:nvSpPr>
+        <p:spPr>
+          <a:xfrm>
+            <a:off x="3776472" y="2276856"/>
+            <a:ext cx="4864608" cy="292608"/>
+          </a:xfrm>
+          <a:prstGeom prst="rect">
+            <a:avLst/>
+          </a:prstGeom>
+          <a:noFill/>
+          <a:ln/>
+        </p:spPr>
+        <p:txBody>
+          <a:bodyPr wrap="square" lIns="0" tIns="0" rIns="0" bIns="0" rtlCol="0" anchor="ctr"/>
+          <a:lstStyle/>
+          <a:p>
+            <a:pPr indent="0" marL="0">
+              <a:buNone/>
+            </a:pPr>
+            <a:r>
+              <a:rPr lang="en-US" sz="1350" b="1" dirty="0">
+                <a:solidFill>
+                  <a:srgbClr val="1E2761"/>
+                </a:solidFill>
+                <a:latin typeface="Arial" pitchFamily="34" charset="0"/>
+                <a:ea typeface="Arial" pitchFamily="34" charset="-122"/>
+                <a:cs typeface="Arial" pitchFamily="34" charset="-120"/>
+              </a:rPr>
+              <a:t>Dictionary-generation ambiguities</a:t>
+            </a:r>
+            <a:endParaRPr lang="en-US" sz="1350" dirty="0"/>
+          </a:p>
+        </p:txBody>
+      </p:sp>
+      <p:sp>
+        <p:nvSpPr>
+          <p:cNvPr id="11" name="Text 9"/>
+          <p:cNvSpPr/>
+          <p:nvPr/>
+        </p:nvSpPr>
+        <p:spPr>
+          <a:xfrm>
+            <a:off x="3776472" y="2587752"/>
+            <a:ext cx="4864608" cy="502920"/>
+          </a:xfrm>
+          <a:prstGeom prst="rect">
+            <a:avLst/>
+          </a:prstGeom>
+          <a:noFill/>
+          <a:ln/>
+        </p:spPr>
+        <p:txBody>
+          <a:bodyPr wrap="square" lIns="0" tIns="0" rIns="0" bIns="0" rtlCol="0" anchor="t"/>
+          <a:lstStyle/>
+          <a:p>
+            <a:pPr indent="0" marL="0">
+              <a:buNone/>
+            </a:pPr>
+            <a:r>
+              <a:rPr lang="en-US" sz="1150" dirty="0">
+                <a:solidFill>
+                  <a:srgbClr val="5B6382"/>
+                </a:solidFill>
+                <a:latin typeface="Arial" pitchFamily="34" charset="0"/>
+                <a:ea typeface="Arial" pitchFamily="34" charset="-122"/>
+                <a:cs typeface="Arial" pitchFamily="34" charset="-120"/>
+              </a:rPr>
+              <a:t>A couple of function-overload conflicts that only the older interpreter's build tooling saw.</a:t>
+            </a:r>
+            <a:endParaRPr lang="en-US" sz="1150" dirty="0"/>
+          </a:p>
+        </p:txBody>
+      </p:sp>
+      <p:sp>
+        <p:nvSpPr>
+          <p:cNvPr id="12" name="Shape 10"/>
+          <p:cNvSpPr/>
+          <p:nvPr/>
+        </p:nvSpPr>
+        <p:spPr>
+          <a:xfrm>
+            <a:off x="3246120" y="2990088"/>
+            <a:ext cx="329184" cy="329184"/>
+          </a:xfrm>
+          <a:prstGeom prst="ellipse">
+            <a:avLst/>
+          </a:prstGeom>
+          <a:solidFill>
+            <a:srgbClr val="E8A33D"/>
+          </a:solidFill>
+          <a:ln/>
+        </p:spPr>
+      </p:sp>
+      <p:sp>
+        <p:nvSpPr>
+          <p:cNvPr id="13" name="Text 11"/>
+          <p:cNvSpPr/>
+          <p:nvPr/>
+        </p:nvSpPr>
+        <p:spPr>
+          <a:xfrm>
+            <a:off x="3246120" y="2976372"/>
+            <a:ext cx="329184" cy="329184"/>
+          </a:xfrm>
+          <a:prstGeom prst="rect">
+            <a:avLst/>
+          </a:prstGeom>
+          <a:noFill/>
+          <a:ln/>
+        </p:spPr>
+        <p:txBody>
+          <a:bodyPr wrap="square" lIns="0" tIns="0" rIns="0" bIns="0" rtlCol="0" anchor="ctr"/>
+          <a:lstStyle/>
+          <a:p>
+            <a:pPr algn="ctr" indent="0" marL="0">
+              <a:buNone/>
+            </a:pPr>
+            <a:r>
+              <a:rPr lang="en-US" sz="1400" b="1" dirty="0">
+                <a:solidFill>
+                  <a:srgbClr val="FFFFFF"/>
+                </a:solidFill>
+                <a:latin typeface="Arial" pitchFamily="34" charset="0"/>
+                <a:ea typeface="Arial" pitchFamily="34" charset="-122"/>
+                <a:cs typeface="Arial" pitchFamily="34" charset="-120"/>
+              </a:rPr>
+              <a:t>!</a:t>
+            </a:r>
+            <a:endParaRPr lang="en-US" sz="1400" dirty="0"/>
+          </a:p>
+        </p:txBody>
+      </p:sp>
+      <p:sp>
+        <p:nvSpPr>
+          <p:cNvPr id="14" name="Text 12"/>
+          <p:cNvSpPr/>
+          <p:nvPr/>
+        </p:nvSpPr>
+        <p:spPr>
+          <a:xfrm>
+            <a:off x="3776472" y="2935224"/>
+            <a:ext cx="4864608" cy="292608"/>
+          </a:xfrm>
+          <a:prstGeom prst="rect">
+            <a:avLst/>
+          </a:prstGeom>
+          <a:noFill/>
+          <a:ln/>
+        </p:spPr>
+        <p:txBody>
+          <a:bodyPr wrap="square" lIns="0" tIns="0" rIns="0" bIns="0" rtlCol="0" anchor="ctr"/>
+          <a:lstStyle/>
+          <a:p>
+            <a:pPr indent="0" marL="0">
+              <a:buNone/>
+            </a:pPr>
+            <a:r>
+              <a:rPr lang="en-US" sz="1350" b="1" dirty="0">
+                <a:solidFill>
+                  <a:srgbClr val="1E2761"/>
+                </a:solidFill>
+                <a:latin typeface="Arial" pitchFamily="34" charset="0"/>
+                <a:ea typeface="Arial" pitchFamily="34" charset="-122"/>
+                <a:cs typeface="Arial" pitchFamily="34" charset="-120"/>
+              </a:rPr>
+              <a:t>Unsupported modern C++ syntax</a:t>
+            </a:r>
+            <a:endParaRPr lang="en-US" sz="1350" dirty="0"/>
+          </a:p>
+        </p:txBody>
+      </p:sp>
+      <p:sp>
+        <p:nvSpPr>
+          <p:cNvPr id="15" name="Text 13"/>
+          <p:cNvSpPr/>
+          <p:nvPr/>
+        </p:nvSpPr>
+        <p:spPr>
+          <a:xfrm>
+            <a:off x="3776472" y="3246120"/>
+            <a:ext cx="4864608" cy="502920"/>
+          </a:xfrm>
+          <a:prstGeom prst="rect">
+            <a:avLst/>
+          </a:prstGeom>
+          <a:noFill/>
+          <a:ln/>
+        </p:spPr>
+        <p:txBody>
+          <a:bodyPr wrap="square" lIns="0" tIns="0" rIns="0" bIns="0" rtlCol="0" anchor="t"/>
+          <a:lstStyle/>
+          <a:p>
+            <a:pPr indent="0" marL="0">
+              <a:buNone/>
+            </a:pPr>
+            <a:r>
+              <a:rPr lang="en-US" sz="1150" dirty="0">
+                <a:solidFill>
+                  <a:srgbClr val="5B6382"/>
+                </a:solidFill>
+                <a:latin typeface="Arial" pitchFamily="34" charset="0"/>
+                <a:ea typeface="Arial" pitchFamily="34" charset="-122"/>
+                <a:cs typeface="Arial" pitchFamily="34" charset="-120"/>
+              </a:rPr>
+              <a:t>A few default-value patterns valid in a newer C++ standard, not accepted by the older toolchain.</a:t>
+            </a:r>
+            <a:endParaRPr lang="en-US" sz="1150" dirty="0"/>
+          </a:p>
+        </p:txBody>
+      </p:sp>
+      <p:sp>
+        <p:nvSpPr>
+          <p:cNvPr id="16" name="Shape 14"/>
+          <p:cNvSpPr/>
+          <p:nvPr/>
+        </p:nvSpPr>
+        <p:spPr>
+          <a:xfrm>
+            <a:off x="3246120" y="3648456"/>
+            <a:ext cx="329184" cy="329184"/>
+          </a:xfrm>
+          <a:prstGeom prst="ellipse">
+            <a:avLst/>
+          </a:prstGeom>
+          <a:solidFill>
+            <a:srgbClr val="E8A33D"/>
+          </a:solidFill>
+          <a:ln/>
+        </p:spPr>
+      </p:sp>
+      <p:sp>
+        <p:nvSpPr>
+          <p:cNvPr id="17" name="Text 15"/>
+          <p:cNvSpPr/>
+          <p:nvPr/>
+        </p:nvSpPr>
+        <p:spPr>
+          <a:xfrm>
+            <a:off x="3246120" y="3634740"/>
+            <a:ext cx="329184" cy="329184"/>
+          </a:xfrm>
+          <a:prstGeom prst="rect">
+            <a:avLst/>
+          </a:prstGeom>
+          <a:noFill/>
+          <a:ln/>
+        </p:spPr>
+        <p:txBody>
+          <a:bodyPr wrap="square" lIns="0" tIns="0" rIns="0" bIns="0" rtlCol="0" anchor="ctr"/>
+          <a:lstStyle/>
+          <a:p>
+            <a:pPr algn="ctr" indent="0" marL="0">
+              <a:buNone/>
+            </a:pPr>
+            <a:r>
+              <a:rPr lang="en-US" sz="1400" b="1" dirty="0">
+                <a:solidFill>
+                  <a:srgbClr val="FFFFFF"/>
+                </a:solidFill>
+                <a:latin typeface="Arial" pitchFamily="34" charset="0"/>
+                <a:ea typeface="Arial" pitchFamily="34" charset="-122"/>
+                <a:cs typeface="Arial" pitchFamily="34" charset="-120"/>
+              </a:rPr>
+              <a:t>!</a:t>
+            </a:r>
+            <a:endParaRPr lang="en-US" sz="1400" dirty="0"/>
+          </a:p>
+        </p:txBody>
+      </p:sp>
+      <p:sp>
+        <p:nvSpPr>
+          <p:cNvPr id="18" name="Text 16"/>
+          <p:cNvSpPr/>
+          <p:nvPr/>
+        </p:nvSpPr>
+        <p:spPr>
+          <a:xfrm>
+            <a:off x="3776472" y="3593592"/>
+            <a:ext cx="4864608" cy="292608"/>
+          </a:xfrm>
+          <a:prstGeom prst="rect">
+            <a:avLst/>
+          </a:prstGeom>
+          <a:noFill/>
+          <a:ln/>
+        </p:spPr>
+        <p:txBody>
+          <a:bodyPr wrap="square" lIns="0" tIns="0" rIns="0" bIns="0" rtlCol="0" anchor="ctr"/>
+          <a:lstStyle/>
+          <a:p>
+            <a:pPr indent="0" marL="0">
+              <a:buNone/>
+            </a:pPr>
+            <a:r>
+              <a:rPr lang="en-US" sz="1350" b="1" dirty="0">
+                <a:solidFill>
+                  <a:srgbClr val="1E2761"/>
+                </a:solidFill>
+                <a:latin typeface="Arial" pitchFamily="34" charset="0"/>
+                <a:ea typeface="Arial" pitchFamily="34" charset="-122"/>
+                <a:cs typeface="Arial" pitchFamily="34" charset="-120"/>
+              </a:rPr>
+              <a:t>Declared-but-unimplemented methods</a:t>
+            </a:r>
+            <a:endParaRPr lang="en-US" sz="1350" dirty="0"/>
+          </a:p>
+        </p:txBody>
+      </p:sp>
+      <p:sp>
+        <p:nvSpPr>
+          <p:cNvPr id="19" name="Text 17"/>
+          <p:cNvSpPr/>
+          <p:nvPr/>
+        </p:nvSpPr>
+        <p:spPr>
+          <a:xfrm>
+            <a:off x="3776472" y="3904488"/>
+            <a:ext cx="4864608" cy="502920"/>
+          </a:xfrm>
+          <a:prstGeom prst="rect">
+            <a:avLst/>
+          </a:prstGeom>
+          <a:noFill/>
+          <a:ln/>
+        </p:spPr>
+        <p:txBody>
+          <a:bodyPr wrap="square" lIns="0" tIns="0" rIns="0" bIns="0" rtlCol="0" anchor="t"/>
+          <a:lstStyle/>
+          <a:p>
+            <a:pPr indent="0" marL="0">
+              <a:buNone/>
+            </a:pPr>
+            <a:r>
+              <a:rPr lang="en-US" sz="1150" dirty="0">
+                <a:solidFill>
+                  <a:srgbClr val="5B6382"/>
+                </a:solidFill>
+                <a:latin typeface="Arial" pitchFamily="34" charset="0"/>
+                <a:ea typeface="Arial" pitchFamily="34" charset="-122"/>
+                <a:cs typeface="Arial" pitchFamily="34" charset="-120"/>
+              </a:rPr>
+              <a:t>A handful of functions declared in headers but never written -- harmless on my laptop, fatal for the older linker.</a:t>
+            </a:r>
+            <a:endParaRPr lang="en-US" sz="1150" dirty="0"/>
+          </a:p>
+        </p:txBody>
+      </p:sp>
+      <p:sp>
+        <p:nvSpPr>
+          <p:cNvPr id="20" name="Text 18"/>
+          <p:cNvSpPr/>
+          <p:nvPr/>
+        </p:nvSpPr>
+        <p:spPr>
+          <a:xfrm>
+            <a:off x="8549640" y="4828032"/>
+            <a:ext cx="457200" cy="274320"/>
+          </a:xfrm>
+          <a:prstGeom prst="rect">
+            <a:avLst/>
+          </a:prstGeom>
+          <a:noFill/>
+          <a:ln/>
+        </p:spPr>
+        <p:txBody>
+          <a:bodyPr wrap="square" lIns="0" tIns="0" rIns="0" bIns="0" rtlCol="0" anchor="ctr"/>
+          <a:lstStyle/>
+          <a:p>
+            <a:pPr algn="r" indent="0" marL="0">
+              <a:buNone/>
+            </a:pPr>
+            <a:r>
+              <a:rPr lang="en-US" sz="1000" dirty="0">
+                <a:solidFill>
+                  <a:srgbClr val="5B6382"/>
+                </a:solidFill>
+                <a:latin typeface="Arial" pitchFamily="34" charset="0"/>
+                <a:ea typeface="Arial" pitchFamily="34" charset="-122"/>
+                <a:cs typeface="Arial" pitchFamily="34" charset="-120"/>
+              </a:rPr>
+              <a:t>12</a:t>
+            </a:r>
+            <a:endParaRPr lang="en-US" sz="1000" dirty="0"/>
+          </a:p>
+        </p:txBody>
+      </p:sp>
+      <p:sp>
+        <p:nvSpPr>
+          <p:cNvPr id="21" name="Text 19"/>
+          <p:cNvSpPr/>
+          <p:nvPr/>
+        </p:nvSpPr>
+        <p:spPr>
+          <a:xfrm>
+            <a:off x="457200" y="4828032"/>
+            <a:ext cx="3657600" cy="274320"/>
+          </a:xfrm>
+          <a:prstGeom prst="rect">
+            <a:avLst/>
+          </a:prstGeom>
+          <a:noFill/>
+          <a:ln/>
+        </p:spPr>
+        <p:txBody>
+          <a:bodyPr wrap="square" lIns="0" tIns="0" rIns="0" bIns="0" rtlCol="0" anchor="ctr"/>
+          <a:lstStyle/>
+          <a:p>
+            <a:pPr algn="l" indent="0" marL="0">
+              <a:buNone/>
+            </a:pPr>
+            <a:r>
+              <a:rPr lang="en-US" sz="1000" dirty="0">
+                <a:solidFill>
+                  <a:srgbClr val="5B6382"/>
+                </a:solidFill>
+                <a:latin typeface="Arial" pitchFamily="34" charset="0"/>
+                <a:ea typeface="Arial" pitchFamily="34" charset="-122"/>
+                <a:cs typeface="Arial" pitchFamily="34" charset="-120"/>
+              </a:rPr>
+              <a:t>lightflavorspectra_OO200</a:t>
+            </a:r>
+            <a:endParaRPr lang="en-US" sz="1000" dirty="0"/>
+          </a:p>
+        </p:txBody>
+      </p:sp>
+    </p:spTree>
+  </p:cSld>
+  <p:clrMapOvr>
+    <a:masterClrMapping/>
+  </p:clrMapOvr>
+</p:sld>
+</file>
+
 <file path=ppt/slides/slide2.xml><?xml version="1.0" encoding="utf-8"?>
 <p:sld xmlns:a="http://schemas.openxmlformats.org/drawingml/2006/main" xmlns:r="http://schemas.openxmlformats.org/officeDocument/2006/relationships" xmlns:p="http://schemas.openxmlformats.org/presentationml/2006/main">
   <p:cSld name="Slide 2">
@@ -1966,7 +4663,7 @@
                 <a:ea typeface="Arial" pitchFamily="34" charset="-122"/>
                 <a:cs typeface="Arial" pitchFamily="34" charset="-120"/>
               </a:rPr>
-              <a:t>PicoDst Reader Migration</a:t>
+              <a:t>Updated the Data Reader</a:t>
             </a:r>
             <a:endParaRPr lang="en-US" sz="1500" dirty="0"/>
           </a:p>
@@ -2005,7 +4702,7 @@
                 <a:ea typeface="Arial" pitchFamily="34" charset="-122"/>
                 <a:cs typeface="Arial" pitchFamily="34" charset="-120"/>
               </a:rPr>
-              <a:t>Porting to the SL24y library</a:t>
+              <a:t>Matching this dataset's official software</a:t>
             </a:r>
             <a:endParaRPr lang="en-US" sz="1150" dirty="0"/>
           </a:p>
@@ -2125,7 +4822,7 @@
                 <a:ea typeface="Arial" pitchFamily="34" charset="-122"/>
                 <a:cs typeface="Arial" pitchFamily="34" charset="-120"/>
               </a:rPr>
-              <a:t>SDCC Batch Submission</a:t>
+              <a:t>Scaled Up Our Computing</a:t>
             </a:r>
             <a:endParaRPr lang="en-US" sz="1500" dirty="0"/>
           </a:p>
@@ -2164,7 +4861,7 @@
                 <a:ea typeface="Arial" pitchFamily="34" charset="-122"/>
                 <a:cs typeface="Arial" pitchFamily="34" charset="-120"/>
               </a:rPr>
-              <a:t>Running Stage 1 at production scale</a:t>
+              <a:t>Processing the full dataset, not a sample</a:t>
             </a:r>
             <a:endParaRPr lang="en-US" sz="1150" dirty="0"/>
           </a:p>
@@ -2284,7 +4981,7 @@
                 <a:ea typeface="Arial" pitchFamily="34" charset="-122"/>
                 <a:cs typeface="Arial" pitchFamily="34" charset="-120"/>
               </a:rPr>
-              <a:t>Getting the Build Working</a:t>
+              <a:t>Solved Compatibility Snags</a:t>
             </a:r>
             <a:endParaRPr lang="en-US" sz="1500" dirty="0"/>
           </a:p>
@@ -2323,7 +5020,7 @@
                 <a:ea typeface="Arial" pitchFamily="34" charset="-122"/>
                 <a:cs typeface="Arial" pitchFamily="34" charset="-120"/>
               </a:rPr>
-              <a:t>ROOT5 / CINT compatibility fixes</a:t>
+              <a:t>Getting everything running smoothly</a:t>
             </a:r>
             <a:endParaRPr lang="en-US" sz="1150" dirty="0"/>
           </a:p>
@@ -2988,7 +5685,7 @@
                 <a:ea typeface="Arial" pitchFamily="34" charset="-122"/>
                 <a:cs typeface="Arial" pitchFamily="34" charset="-120"/>
               </a:rPr>
-              <a:t>Migrated the PicoDst Reader to the Right Library</a:t>
+              <a:t>Updated the Data Reader</a:t>
             </a:r>
             <a:endParaRPr lang="en-US" sz="3000" dirty="0"/>
           </a:p>
@@ -3080,7 +5777,7 @@
               <a:buNone/>
             </a:pPr>
             <a:r>
-              <a:rPr lang="en-US" sz="2600" b="1" dirty="0">
+              <a:rPr lang="en-US" sz="1900" b="1" dirty="0">
                 <a:solidFill>
                   <a:srgbClr val="1E2761"/>
                 </a:solidFill>
@@ -3088,9 +5785,9 @@
                 <a:ea typeface="Arial" pitchFamily="34" charset="-122"/>
                 <a:cs typeface="Arial" pitchFamily="34" charset="-120"/>
               </a:rPr>
-              <a:t>SL23a</a:t>
-            </a:r>
-            <a:endParaRPr lang="en-US" sz="2600" dirty="0"/>
+              <a:t>Older Version</a:t>
+            </a:r>
+            <a:endParaRPr lang="en-US" sz="1900" dirty="0"/>
           </a:p>
         </p:txBody>
       </p:sp>
@@ -3127,7 +5824,7 @@
                 <a:ea typeface="Arial" pitchFamily="34" charset="-122"/>
                 <a:cs typeface="Arial" pitchFamily="34" charset="-120"/>
               </a:rPr>
-              <a:t>Carried over from a different-energy analysis</a:t>
+              <a:t>Built for a different dataset</a:t>
             </a:r>
             <a:endParaRPr lang="en-US" sz="1050" dirty="0"/>
           </a:p>
@@ -3265,7 +5962,7 @@
               <a:buNone/>
             </a:pPr>
             <a:r>
-              <a:rPr lang="en-US" sz="2600" b="1" dirty="0">
+              <a:rPr lang="en-US" sz="1900" b="1" dirty="0">
                 <a:solidFill>
                   <a:srgbClr val="FFFFFF"/>
                 </a:solidFill>
@@ -3273,9 +5970,9 @@
                 <a:ea typeface="Arial" pitchFamily="34" charset="-122"/>
                 <a:cs typeface="Arial" pitchFamily="34" charset="-120"/>
               </a:rPr>
-              <a:t>SL24y</a:t>
-            </a:r>
-            <a:endParaRPr lang="en-US" sz="2600" dirty="0"/>
+              <a:t>Current Version</a:t>
+            </a:r>
+            <a:endParaRPr lang="en-US" sz="1900" dirty="0"/>
           </a:p>
         </p:txBody>
       </p:sp>
@@ -3312,7 +6009,7 @@
                 <a:ea typeface="Arial" pitchFamily="34" charset="-122"/>
                 <a:cs typeface="Arial" pitchFamily="34" charset="-120"/>
               </a:rPr>
-              <a:t>Matches the real production dataset's library</a:t>
+              <a:t>Matches this dataset exactly</a:t>
             </a:r>
             <a:endParaRPr lang="en-US" sz="1050" dirty="0"/>
           </a:p>
@@ -3454,7 +6151,7 @@
                 <a:ea typeface="Arial" pitchFamily="34" charset="-122"/>
                 <a:cs typeface="Arial" pitchFamily="34" charset="-120"/>
               </a:rPr>
-              <a:t>Re-vendored from STAR's own public source</a:t>
+              <a:t>Reading the right data</a:t>
             </a:r>
             <a:endParaRPr lang="en-US" sz="1350" dirty="0"/>
           </a:p>
@@ -3493,7 +6190,7 @@
                 <a:ea typeface="Arial" pitchFamily="34" charset="-122"/>
                 <a:cs typeface="Arial" pitchFamily="34" charset="-120"/>
               </a:rPr>
-              <a:t>Pulled the SL24y class definitions directly from STAR's public repository rather than hand-editing the old ones.</a:t>
+              <a:t>This dataset was produced with a newer version of STAR's official reader software, so I updated my analysis to match it.</a:t>
             </a:r>
             <a:endParaRPr lang="en-US" sz="1150" dirty="0"/>
           </a:p>
@@ -3591,7 +6288,7 @@
                 <a:ea typeface="Arial" pitchFamily="34" charset="-122"/>
                 <a:cs typeface="Arial" pitchFamily="34" charset="-120"/>
               </a:rPr>
-              <a:t>Diffed every class against the old version</a:t>
+              <a:t>Checked that nothing else changed</a:t>
             </a:r>
             <a:endParaRPr lang="en-US" sz="1350" dirty="0"/>
           </a:p>
@@ -3630,7 +6327,7 @@
                 <a:ea typeface="Arial" pitchFamily="34" charset="-122"/>
                 <a:cs typeface="Arial" pitchFamily="34" charset="-120"/>
               </a:rPr>
-              <a:t>Confirmed almost everything was unchanged; only the eTOF good-event-flag data grew far more granular (108 → 1728 entries) and needed a small update at its one call site.</a:t>
+              <a:t>Compared the new and old versions carefully to confirm the update was purely a version change -- no impact on the physics.</a:t>
             </a:r>
             <a:endParaRPr lang="en-US" sz="1150" dirty="0"/>
           </a:p>
@@ -3728,7 +6425,7 @@
                 <a:ea typeface="Arial" pitchFamily="34" charset="-122"/>
                 <a:cs typeface="Arial" pitchFamily="34" charset="-120"/>
               </a:rPr>
-              <a:t>Closed a small upstream gap</a:t>
+              <a:t>Ready end to end</a:t>
             </a:r>
             <a:endParaRPr lang="en-US" sz="1350" dirty="0"/>
           </a:p>
@@ -3767,7 +6464,7 @@
                 <a:ea typeface="Arial" pitchFamily="34" charset="-122"/>
                 <a:cs typeface="Arial" pitchFamily="34" charset="-120"/>
               </a:rPr>
-              <a:t>Two methods STAR's own header declares but never defines needed minimal implementations so the library links cleanly.</a:t>
+              <a:t>The pipeline now reads this dataset's files correctly, from raw data all the way through to final spectra.</a:t>
             </a:r>
             <a:endParaRPr lang="en-US" sz="1150" dirty="0"/>
           </a:p>
@@ -3775,7 +6472,7 @@
       </p:sp>
       <p:sp>
         <p:nvSpPr>
-          <p:cNvPr id="27" name="Text 25"/>
+          <p:cNvPr id="28" name="Text 25"/>
           <p:cNvSpPr/>
           <p:nvPr/>
         </p:nvSpPr>
@@ -3814,7 +6511,7 @@
       </p:sp>
       <p:sp>
         <p:nvSpPr>
-          <p:cNvPr id="28" name="Text 26"/>
+          <p:cNvPr id="29" name="Text 26"/>
           <p:cNvSpPr/>
           <p:nvPr/>
         </p:nvSpPr>
@@ -3916,7 +6613,7 @@
                 <a:ea typeface="Arial" pitchFamily="34" charset="-122"/>
                 <a:cs typeface="Arial" pitchFamily="34" charset="-120"/>
               </a:rPr>
-              <a:t>COMPUTING INFRASTRUCTURE</a:t>
+              <a:t>RUNNING AT FULL SCALE</a:t>
             </a:r>
             <a:endParaRPr lang="en-US" sz="1200" dirty="0"/>
           </a:p>
@@ -3955,7 +6652,7 @@
                 <a:ea typeface="Arial" pitchFamily="34" charset="-122"/>
                 <a:cs typeface="Arial" pitchFamily="34" charset="-120"/>
               </a:rPr>
-              <a:t>Added a Batch Path for the Full Production Dataset</a:t>
+              <a:t>Scaled Up Our Computing</a:t>
             </a:r>
             <a:endParaRPr lang="en-US" sz="3000" dirty="0"/>
           </a:p>
@@ -4052,7 +6749,7 @@
               <a:buNone/>
             </a:pPr>
             <a:r>
-              <a:rPr lang="en-US" sz="2000" b="1" dirty="0">
+              <a:rPr lang="en-US" sz="1900" b="1" dirty="0">
                 <a:solidFill>
                   <a:srgbClr val="1E2761"/>
                 </a:solidFill>
@@ -4060,9 +6757,9 @@
                 <a:ea typeface="Arial" pitchFamily="34" charset="-122"/>
                 <a:cs typeface="Arial" pitchFamily="34" charset="-120"/>
               </a:rPr>
-              <a:t>Stages 2–4</a:t>
-            </a:r>
-            <a:endParaRPr lang="en-US" sz="2000" dirty="0"/>
+              <a:t>Everyday Analysis</a:t>
+            </a:r>
+            <a:endParaRPr lang="en-US" sz="1900" dirty="0"/>
           </a:p>
         </p:txBody>
       </p:sp>
@@ -4099,7 +6796,7 @@
                 <a:ea typeface="Arial" pitchFamily="34" charset="-122"/>
                 <a:cs typeface="Arial" pitchFamily="34" charset="-120"/>
               </a:rPr>
-              <a:t>PID fitting, corrections, and final spectra fits -- unchanged, still run locally exactly as before.</a:t>
+              <a:t>Most of the analysis still runs here, just like before.</a:t>
             </a:r>
             <a:endParaRPr lang="en-US" sz="1200" dirty="0"/>
           </a:p>
@@ -4159,7 +6856,7 @@
               <a:buNone/>
             </a:pPr>
             <a:r>
-              <a:rPr lang="en-US" sz="1200" b="1" spc="150" kern="0" dirty="0">
+              <a:rPr lang="en-US" sz="1100" b="1" spc="100" kern="0" dirty="0">
                 <a:solidFill>
                   <a:srgbClr val="E8A33D"/>
                 </a:solidFill>
@@ -4167,9 +6864,9 @@
                 <a:ea typeface="Arial" pitchFamily="34" charset="-122"/>
                 <a:cs typeface="Arial" pitchFamily="34" charset="-120"/>
               </a:rPr>
-              <a:t>SDCC / RCF BATCH  —  NEW</a:t>
-            </a:r>
-            <a:endParaRPr lang="en-US" sz="1200" dirty="0"/>
+              <a:t>SHARED COMPUTING CLUSTER — NEW</a:t>
+            </a:r>
+            <a:endParaRPr lang="en-US" sz="1100" dirty="0"/>
           </a:p>
         </p:txBody>
       </p:sp>
@@ -4198,7 +6895,7 @@
               <a:buNone/>
             </a:pPr>
             <a:r>
-              <a:rPr lang="en-US" sz="2000" b="1" dirty="0">
+              <a:rPr lang="en-US" sz="1900" b="1" dirty="0">
                 <a:solidFill>
                   <a:srgbClr val="FFFFFF"/>
                 </a:solidFill>
@@ -4206,9 +6903,9 @@
                 <a:ea typeface="Arial" pitchFamily="34" charset="-122"/>
                 <a:cs typeface="Arial" pitchFamily="34" charset="-120"/>
               </a:rPr>
-              <a:t>Stage 1</a:t>
-            </a:r>
-            <a:endParaRPr lang="en-US" sz="2000" dirty="0"/>
+              <a:t>Big Data Runs</a:t>
+            </a:r>
+            <a:endParaRPr lang="en-US" sz="1900" dirty="0"/>
           </a:p>
         </p:txBody>
       </p:sp>
@@ -4221,7 +6918,7 @@
         <p:spPr>
           <a:xfrm>
             <a:off x="5303520" y="2331720"/>
-            <a:ext cx="3017520" cy="822960"/>
+            <a:ext cx="3017520" cy="914400"/>
           </a:xfrm>
           <a:prstGeom prst="rect">
             <a:avLst/>
@@ -4245,7 +6942,7 @@
                 <a:ea typeface="Arial" pitchFamily="34" charset="-122"/>
                 <a:cs typeface="Arial" pitchFamily="34" charset="-120"/>
               </a:rPr>
-              <a:t>Raw-yield extraction, one job per species, against the full production file list -- too large to run in one local session.</a:t>
+              <a:t>The most data-heavy step now runs on a shared physics computing cluster, so I can process the entire dataset instead of a small sample.</a:t>
             </a:r>
             <a:endParaRPr lang="en-US" sz="1200" dirty="0"/>
           </a:p>
@@ -4323,7 +7020,7 @@
                 <a:ea typeface="Arial" pitchFamily="34" charset="-122"/>
                 <a:cs typeface="Arial" pitchFamily="34" charset="-120"/>
               </a:rPr>
-              <a:t>output files</a:t>
+              <a:t>results</a:t>
             </a:r>
             <a:endParaRPr lang="en-US" sz="950" dirty="0"/>
           </a:p>
@@ -4340,7 +7037,7 @@
                 <a:ea typeface="Arial" pitchFamily="34" charset="-122"/>
                 <a:cs typeface="Arial" pitchFamily="34" charset="-120"/>
               </a:rPr>
-              <a:t>moved back</a:t>
+              <a:t>move back</a:t>
             </a:r>
             <a:endParaRPr lang="en-US" sz="950" dirty="0"/>
           </a:p>
@@ -4379,7 +7076,7 @@
                 <a:ea typeface="Arial" pitchFamily="34" charset="-122"/>
                 <a:cs typeface="Arial" pitchFamily="34" charset="-120"/>
               </a:rPr>
-              <a:t>Configured with a star-submit job template + wrapper script, pointed at the correct production tag and library for this dataset.</a:t>
+              <a:t>Bottom line: far more collisions analyzed, and much better statistics in the final results.</a:t>
             </a:r>
             <a:endParaRPr lang="en-US" sz="1250" dirty="0"/>
           </a:p>
@@ -4387,7 +7084,7 @@
       </p:sp>
       <p:sp>
         <p:nvSpPr>
-          <p:cNvPr id="15" name="Text 13"/>
+          <p:cNvPr id="16" name="Text 13"/>
           <p:cNvSpPr/>
           <p:nvPr/>
         </p:nvSpPr>
@@ -4426,7 +7123,7 @@
       </p:sp>
       <p:sp>
         <p:nvSpPr>
-          <p:cNvPr id="16" name="Text 14"/>
+          <p:cNvPr id="17" name="Text 14"/>
           <p:cNvSpPr/>
           <p:nvPr/>
         </p:nvSpPr>
@@ -4528,7 +7225,7 @@
                 <a:ea typeface="Arial" pitchFamily="34" charset="-122"/>
                 <a:cs typeface="Arial" pitchFamily="34" charset="-120"/>
               </a:rPr>
-              <a:t>THE HARD PART</a:t>
+              <a:t>BEHIND THE SCENES</a:t>
             </a:r>
             <a:endParaRPr lang="en-US" sz="1200" dirty="0"/>
           </a:p>
@@ -4567,7 +7264,7 @@
                 <a:ea typeface="Arial" pitchFamily="34" charset="-122"/>
                 <a:cs typeface="Arial" pitchFamily="34" charset="-120"/>
               </a:rPr>
-              <a:t>Getting the SDCC Build Working</a:t>
+              <a:t>Solved Some Compatibility Snags</a:t>
             </a:r>
             <a:endParaRPr lang="en-US" sz="3000" dirty="0"/>
           </a:p>
@@ -4674,7 +7371,7 @@
                 <a:ea typeface="Arial" pitchFamily="34" charset="-122"/>
                 <a:cs typeface="Arial" pitchFamily="34" charset="-120"/>
               </a:rPr>
-              <a:t>separate build issues</a:t>
+              <a:t>compatibility issues</a:t>
             </a:r>
             <a:endParaRPr lang="en-US" sz="1350" dirty="0"/>
           </a:p>
@@ -4706,7 +7403,7 @@
         <p:spPr>
           <a:xfrm>
             <a:off x="3246120" y="1463040"/>
-            <a:ext cx="5394960" cy="685800"/>
+            <a:ext cx="5394960" cy="777240"/>
           </a:xfrm>
           <a:prstGeom prst="rect">
             <a:avLst/>
@@ -4730,7 +7427,7 @@
                 <a:ea typeface="Arial" pitchFamily="34" charset="-122"/>
                 <a:cs typeface="Arial" pitchFamily="34" charset="-120"/>
               </a:rPr>
-              <a:t>SDCC runs an older ROOT version (via an interpreter called CINT) than my laptop's ROOT 6. Code that compiled fine locally didn't compile there.</a:t>
+              <a:t>The shared computing cluster runs older software than my laptop does. Getting my code to run there smoothly took some troubleshooting.</a:t>
             </a:r>
             <a:endParaRPr lang="en-US" sz="1400" dirty="0"/>
           </a:p>
@@ -4744,7 +7441,7 @@
         </p:nvSpPr>
         <p:spPr>
           <a:xfrm>
-            <a:off x="3246120" y="2331720"/>
+            <a:off x="3246120" y="2423160"/>
             <a:ext cx="329184" cy="329184"/>
           </a:xfrm>
           <a:prstGeom prst="ellipse">
@@ -4764,7 +7461,7 @@
         </p:nvSpPr>
         <p:spPr>
           <a:xfrm>
-            <a:off x="3246120" y="2318004"/>
+            <a:off x="3246120" y="2409444"/>
             <a:ext cx="329184" cy="329184"/>
           </a:xfrm>
           <a:prstGeom prst="rect">
@@ -4803,7 +7500,7 @@
         </p:nvSpPr>
         <p:spPr>
           <a:xfrm>
-            <a:off x="3776472" y="2276856"/>
+            <a:off x="3776472" y="2368296"/>
             <a:ext cx="4864608" cy="292608"/>
           </a:xfrm>
           <a:prstGeom prst="rect">
@@ -4828,7 +7525,7 @@
                 <a:ea typeface="Arial" pitchFamily="34" charset="-122"/>
                 <a:cs typeface="Arial" pitchFamily="34" charset="-120"/>
               </a:rPr>
-              <a:t>Dictionary-generation ambiguities</a:t>
+              <a:t>Older tools, newer code</a:t>
             </a:r>
             <a:endParaRPr lang="en-US" sz="1350" dirty="0"/>
           </a:p>
@@ -4842,7 +7539,7 @@
         </p:nvSpPr>
         <p:spPr>
           <a:xfrm>
-            <a:off x="3776472" y="2587752"/>
+            <a:off x="3776472" y="2679192"/>
             <a:ext cx="4864608" cy="502920"/>
           </a:xfrm>
           <a:prstGeom prst="rect">
@@ -4867,7 +7564,7 @@
                 <a:ea typeface="Arial" pitchFamily="34" charset="-122"/>
                 <a:cs typeface="Arial" pitchFamily="34" charset="-120"/>
               </a:rPr>
-              <a:t>A couple of function-overload conflicts that only the older interpreter's build tooling saw.</a:t>
+              <a:t>Some code needed small rewrites to work with the cluster's older software.</a:t>
             </a:r>
             <a:endParaRPr lang="en-US" sz="1150" dirty="0"/>
           </a:p>
@@ -4881,7 +7578,7 @@
         </p:nvSpPr>
         <p:spPr>
           <a:xfrm>
-            <a:off x="3246120" y="2990088"/>
+            <a:off x="3246120" y="3081528"/>
             <a:ext cx="329184" cy="329184"/>
           </a:xfrm>
           <a:prstGeom prst="ellipse">
@@ -4901,7 +7598,7 @@
         </p:nvSpPr>
         <p:spPr>
           <a:xfrm>
-            <a:off x="3246120" y="2976372"/>
+            <a:off x="3246120" y="3067812"/>
             <a:ext cx="329184" cy="329184"/>
           </a:xfrm>
           <a:prstGeom prst="rect">
@@ -4940,7 +7637,7 @@
         </p:nvSpPr>
         <p:spPr>
           <a:xfrm>
-            <a:off x="3776472" y="2935224"/>
+            <a:off x="3776472" y="3026664"/>
             <a:ext cx="4864608" cy="292608"/>
           </a:xfrm>
           <a:prstGeom prst="rect">
@@ -4965,7 +7662,7 @@
                 <a:ea typeface="Arial" pitchFamily="34" charset="-122"/>
                 <a:cs typeface="Arial" pitchFamily="34" charset="-120"/>
               </a:rPr>
-              <a:t>Unsupported modern C++ syntax</a:t>
+              <a:t>A few missing pieces</a:t>
             </a:r>
             <a:endParaRPr lang="en-US" sz="1350" dirty="0"/>
           </a:p>
@@ -4979,7 +7676,7 @@
         </p:nvSpPr>
         <p:spPr>
           <a:xfrm>
-            <a:off x="3776472" y="3246120"/>
+            <a:off x="3776472" y="3337560"/>
             <a:ext cx="4864608" cy="502920"/>
           </a:xfrm>
           <a:prstGeom prst="rect">
@@ -5004,7 +7701,7 @@
                 <a:ea typeface="Arial" pitchFamily="34" charset="-122"/>
                 <a:cs typeface="Arial" pitchFamily="34" charset="-120"/>
               </a:rPr>
-              <a:t>A few default-value patterns valid in a newer C++ standard, not accepted by the older toolchain.</a:t>
+              <a:t>Filled in a handful of gaps left over from earlier versions of the code.</a:t>
             </a:r>
             <a:endParaRPr lang="en-US" sz="1150" dirty="0"/>
           </a:p>
@@ -5018,7 +7715,7 @@
         </p:nvSpPr>
         <p:spPr>
           <a:xfrm>
-            <a:off x="3246120" y="3648456"/>
+            <a:off x="3246120" y="3739896"/>
             <a:ext cx="329184" cy="329184"/>
           </a:xfrm>
           <a:prstGeom prst="ellipse">
@@ -5038,7 +7735,7 @@
         </p:nvSpPr>
         <p:spPr>
           <a:xfrm>
-            <a:off x="3246120" y="3634740"/>
+            <a:off x="3246120" y="3726180"/>
             <a:ext cx="329184" cy="329184"/>
           </a:xfrm>
           <a:prstGeom prst="rect">
@@ -5077,7 +7774,7 @@
         </p:nvSpPr>
         <p:spPr>
           <a:xfrm>
-            <a:off x="3776472" y="3593592"/>
+            <a:off x="3776472" y="3685032"/>
             <a:ext cx="4864608" cy="292608"/>
           </a:xfrm>
           <a:prstGeom prst="rect">
@@ -5102,7 +7799,7 @@
                 <a:ea typeface="Arial" pitchFamily="34" charset="-122"/>
                 <a:cs typeface="Arial" pitchFamily="34" charset="-120"/>
               </a:rPr>
-              <a:t>Declared-but-unimplemented methods</a:t>
+              <a:t>Fully tested</a:t>
             </a:r>
             <a:endParaRPr lang="en-US" sz="1350" dirty="0"/>
           </a:p>
@@ -5116,7 +7813,7 @@
         </p:nvSpPr>
         <p:spPr>
           <a:xfrm>
-            <a:off x="3776472" y="3904488"/>
+            <a:off x="3776472" y="3995928"/>
             <a:ext cx="4864608" cy="502920"/>
           </a:xfrm>
           <a:prstGeom prst="rect">
@@ -5141,7 +7838,7 @@
                 <a:ea typeface="Arial" pitchFamily="34" charset="-122"/>
                 <a:cs typeface="Arial" pitchFamily="34" charset="-120"/>
               </a:rPr>
-              <a:t>A handful of functions declared in headers but never written -- harmless on my laptop, fatal for the older linker.</a:t>
+              <a:t>Confirmed everything builds and runs cleanly before moving on to real production runs.</a:t>
             </a:r>
             <a:endParaRPr lang="en-US" sz="1150" dirty="0"/>
           </a:p>
@@ -5149,7 +7846,7 @@
       </p:sp>
       <p:sp>
         <p:nvSpPr>
-          <p:cNvPr id="20" name="Text 18"/>
+          <p:cNvPr id="21" name="Text 18"/>
           <p:cNvSpPr/>
           <p:nvPr/>
         </p:nvSpPr>
@@ -5188,7 +7885,7 @@
       </p:sp>
       <p:sp>
         <p:nvSpPr>
-          <p:cNvPr id="21" name="Text 19"/>
+          <p:cNvPr id="22" name="Text 19"/>
           <p:cNvSpPr/>
           <p:nvPr/>
         </p:nvSpPr>
@@ -7422,6 +10119,199 @@
               <a:t>Questions welcome any time.</a:t>
             </a:r>
             <a:endParaRPr lang="en-US" sz="1300" dirty="0"/>
+          </a:p>
+        </p:txBody>
+      </p:sp>
+    </p:spTree>
+  </p:cSld>
+  <p:clrMapOvr>
+    <a:masterClrMapping/>
+  </p:clrMapOvr>
+</p:sld>
+</file>
+
+<file path=ppt/slides/slide9.xml><?xml version="1.0" encoding="utf-8"?>
+<p:sld xmlns:a="http://schemas.openxmlformats.org/drawingml/2006/main" xmlns:r="http://schemas.openxmlformats.org/officeDocument/2006/relationships" xmlns:p="http://schemas.openxmlformats.org/presentationml/2006/main">
+  <p:cSld name="Slide 9">
+    <p:bg>
+      <p:bgPr>
+        <a:solidFill>
+          <a:srgbClr val="1E2761"/>
+        </a:solidFill>
+      </p:bgPr>
+    </p:bg>
+    <p:spTree>
+      <p:nvGrpSpPr>
+        <p:cNvPr id="1" name=""/>
+        <p:cNvGrpSpPr/>
+        <p:nvPr/>
+      </p:nvGrpSpPr>
+      <p:grpSpPr>
+        <a:xfrm>
+          <a:off x="0" y="0"/>
+          <a:ext cx="0" cy="0"/>
+          <a:chOff x="0" y="0"/>
+          <a:chExt cx="0" cy="0"/>
+        </a:xfrm>
+      </p:grpSpPr>
+      <p:sp>
+        <p:nvSpPr>
+          <p:cNvPr id="2" name="Shape 0"/>
+          <p:cNvSpPr/>
+          <p:nvPr/>
+        </p:nvSpPr>
+        <p:spPr>
+          <a:xfrm>
+            <a:off x="6949440" y="3429000"/>
+            <a:ext cx="1280160" cy="1280160"/>
+          </a:xfrm>
+          <a:prstGeom prst="ellipse">
+            <a:avLst/>
+          </a:prstGeom>
+          <a:solidFill>
+            <a:srgbClr val="CADCFC">
+              <a:alpha val="35000"/>
+            </a:srgbClr>
+          </a:solidFill>
+          <a:ln/>
+        </p:spPr>
+      </p:sp>
+      <p:sp>
+        <p:nvSpPr>
+          <p:cNvPr id="3" name="Shape 1"/>
+          <p:cNvSpPr/>
+          <p:nvPr/>
+        </p:nvSpPr>
+        <p:spPr>
+          <a:xfrm>
+            <a:off x="7487107" y="3582619"/>
+            <a:ext cx="1280160" cy="1280160"/>
+          </a:xfrm>
+          <a:prstGeom prst="ellipse">
+            <a:avLst/>
+          </a:prstGeom>
+          <a:solidFill>
+            <a:srgbClr val="E8A33D">
+              <a:alpha val="35000"/>
+            </a:srgbClr>
+          </a:solidFill>
+          <a:ln/>
+        </p:spPr>
+      </p:sp>
+      <p:sp>
+        <p:nvSpPr>
+          <p:cNvPr id="4" name="Text 2"/>
+          <p:cNvSpPr/>
+          <p:nvPr/>
+        </p:nvSpPr>
+        <p:spPr>
+          <a:xfrm>
+            <a:off x="548640" y="1737360"/>
+            <a:ext cx="7772400" cy="320040"/>
+          </a:xfrm>
+          <a:prstGeom prst="rect">
+            <a:avLst/>
+          </a:prstGeom>
+          <a:noFill/>
+          <a:ln/>
+        </p:spPr>
+        <p:txBody>
+          <a:bodyPr wrap="square" lIns="0" tIns="0" rIns="0" bIns="0" rtlCol="0" anchor="ctr"/>
+          <a:lstStyle/>
+          <a:p>
+            <a:pPr indent="0" marL="0">
+              <a:buNone/>
+            </a:pPr>
+            <a:r>
+              <a:rPr lang="en-US" sz="1300" b="1" spc="200" kern="0" dirty="0">
+                <a:solidFill>
+                  <a:srgbClr val="E8A33D"/>
+                </a:solidFill>
+                <a:latin typeface="Arial" pitchFamily="34" charset="0"/>
+                <a:ea typeface="Arial" pitchFamily="34" charset="-122"/>
+                <a:cs typeface="Arial" pitchFamily="34" charset="-120"/>
+              </a:rPr>
+              <a:t>BACKUP</a:t>
+            </a:r>
+            <a:endParaRPr lang="en-US" sz="1300" dirty="0"/>
+          </a:p>
+        </p:txBody>
+      </p:sp>
+      <p:sp>
+        <p:nvSpPr>
+          <p:cNvPr id="5" name="Text 3"/>
+          <p:cNvSpPr/>
+          <p:nvPr/>
+        </p:nvSpPr>
+        <p:spPr>
+          <a:xfrm>
+            <a:off x="548640" y="2057400"/>
+            <a:ext cx="7863840" cy="731520"/>
+          </a:xfrm>
+          <a:prstGeom prst="rect">
+            <a:avLst/>
+          </a:prstGeom>
+          <a:noFill/>
+          <a:ln/>
+        </p:spPr>
+        <p:txBody>
+          <a:bodyPr wrap="square" lIns="0" tIns="0" rIns="0" bIns="0" rtlCol="0" anchor="ctr"/>
+          <a:lstStyle/>
+          <a:p>
+            <a:pPr indent="0" marL="0">
+              <a:buNone/>
+            </a:pPr>
+            <a:r>
+              <a:rPr lang="en-US" sz="3000" b="1" dirty="0">
+                <a:solidFill>
+                  <a:srgbClr val="FFFFFF"/>
+                </a:solidFill>
+                <a:latin typeface="Arial" pitchFamily="34" charset="0"/>
+                <a:ea typeface="Arial" pitchFamily="34" charset="-122"/>
+                <a:cs typeface="Arial" pitchFamily="34" charset="-120"/>
+              </a:rPr>
+              <a:t>Additional Technical Detail</a:t>
+            </a:r>
+            <a:endParaRPr lang="en-US" sz="3000" dirty="0"/>
+          </a:p>
+        </p:txBody>
+      </p:sp>
+      <p:sp>
+        <p:nvSpPr>
+          <p:cNvPr id="6" name="Text 4"/>
+          <p:cNvSpPr/>
+          <p:nvPr/>
+        </p:nvSpPr>
+        <p:spPr>
+          <a:xfrm>
+            <a:off x="548640" y="2743200"/>
+            <a:ext cx="7315200" cy="365760"/>
+          </a:xfrm>
+          <a:prstGeom prst="rect">
+            <a:avLst/>
+          </a:prstGeom>
+          <a:noFill/>
+          <a:ln/>
+        </p:spPr>
+        <p:txBody>
+          <a:bodyPr wrap="square" lIns="0" tIns="0" rIns="0" bIns="0" rtlCol="0" anchor="ctr"/>
+          <a:lstStyle/>
+          <a:p>
+            <a:pPr indent="0" marL="0">
+              <a:buNone/>
+            </a:pPr>
+            <a:r>
+              <a:rPr lang="en-US" sz="1400" i="1" dirty="0">
+                <a:solidFill>
+                  <a:srgbClr val="CADCFC"/>
+                </a:solidFill>
+                <a:latin typeface="Arial" pitchFamily="34" charset="0"/>
+                <a:ea typeface="Arial" pitchFamily="34" charset="-122"/>
+                <a:cs typeface="Arial" pitchFamily="34" charset="-120"/>
+              </a:rPr>
+              <a:t>For reference and questions -- not part of the main update.</a:t>
+            </a:r>
+            <a:endParaRPr lang="en-US" sz="1400" dirty="0"/>
           </a:p>
         </p:txBody>
       </p:sp>

</xml_diff>